<commit_message>
docs: refresh presentation approval status
Co-authored-by: Copilot App <223556219+Copilot@users.noreply.github.com>
</commit_message>
<xml_diff>
--- a/From-agents-to-engineering-systems.pptx
+++ b/From-agents-to-engineering-systems.pptx
@@ -2659,75 +2659,135 @@
           <a:lstStyle/>
           <a:p>
             <a:r>
+              <a:rPr dirty="0"/>
               <a:t>TALK TRACK</a:t>
             </a:r>
           </a:p>
           <a:p>
             <a:r>
+              <a:rPr dirty="0"/>
               <a:t>I call this my AI Engineering System. I started with the Microsoft Learn material and wanted to turn its principles into something we can inspect in a repository. The question is not just whether an agent can write code. It is how we define the work, limit the next action, and decide what may ship.</a:t>
             </a:r>
           </a:p>
           <a:p>
             <a:r>
+              <a:rPr dirty="0"/>
               <a:t>We will compare plan-first idempotency with a plan + execution endpoint. Same plan -&gt; act -&gt; evaluate system, different timing of human validation. I will keep application behavior, local tests, hosted policy, and live agent evidence distinct.</a:t>
             </a:r>
           </a:p>
-          <a:p/>
-          <a:p>
-            <a:r>
+          <a:p>
+            <a:endParaRPr dirty="0"/>
+          </a:p>
+          <a:p>
+            <a:r>
+              <a:rPr dirty="0"/>
               <a:t>DEMO — REPO / VS CODE</a:t>
             </a:r>
           </a:p>
           <a:p>
             <a:r>
-              <a:t>In the local WI-1843 worktree, open docs/demos/README.md. Show both runbooks and their updated source/evidence table, then compare open PR 18 with draft PRs 19, 27 and 28. Do not claim any scenario has been completed by a VS Code or Copilot cloud agent.</a:t>
-            </a:r>
-          </a:p>
-          <a:p/>
-          <a:p>
-            <a:r>
+              <a:rPr dirty="0"/>
+              <a:t>In the local WI-1843 </a:t>
+            </a:r>
+            <a:r>
+              <a:rPr dirty="0" err="1"/>
+              <a:t>worktree</a:t>
+            </a:r>
+            <a:r>
+              <a:rPr dirty="0"/>
+              <a:t>, open docs/demos/README.md. Show both runbooks and their updated source/evidence table, then compare open PR 18 with draft PRs 19, 27 and 28. Do not claim any scenario has been completed by a VS Code or Copilot cloud agent.</a:t>
+            </a:r>
+          </a:p>
+          <a:p>
+            <a:endParaRPr dirty="0"/>
+          </a:p>
+          <a:p>
+            <a:r>
+              <a:rPr dirty="0"/>
               <a:t>DOCUMENTATION LINKS</a:t>
             </a:r>
           </a:p>
           <a:p>
             <a:r>
+              <a:rPr dirty="0"/>
               <a:t>https://github.com/webmaxru/ai-engineering-system</a:t>
             </a:r>
           </a:p>
           <a:p>
             <a:r>
+              <a:rPr dirty="0"/>
               <a:t>https://github.com/webmaxru/northstar-orders-api-demo</a:t>
             </a:r>
           </a:p>
           <a:p>
             <a:r>
+              <a:rPr dirty="0"/>
               <a:t>https://github.com/webmaxru/northstar-orders-api-demo/pull/18</a:t>
             </a:r>
           </a:p>
           <a:p>
             <a:r>
+              <a:rPr dirty="0"/>
               <a:t>https://github.com/webmaxru/northstar-orders-api-demo/pull/19</a:t>
             </a:r>
           </a:p>
           <a:p>
             <a:r>
+              <a:rPr dirty="0"/>
               <a:t>https://github.com/webmaxru/northstar-orders-api-demo/pull/27</a:t>
             </a:r>
           </a:p>
           <a:p>
             <a:r>
+              <a:rPr dirty="0"/>
               <a:t>https://learn.microsoft.com/en-us/training/modules/design-agent-architecture-integration/4-plan-reason-execution</a:t>
             </a:r>
           </a:p>
-          <a:p/>
-          <a:p>
-            <a:r>
+          <a:p>
+            <a:endParaRPr dirty="0"/>
+          </a:p>
+          <a:p>
+            <a:r>
+              <a:rPr dirty="0"/>
               <a:t>EVIDENCE BOUNDARY</a:t>
             </a:r>
           </a:p>
           <a:p>
             <a:r>
-              <a:t>The audited main baseline remains b65c2de5c8224342c72c37eeed7ef9f965ad8a2c and the framework release remains blocked. PR 18 is at 17e7a5c; hosted acceptance tests pass, but evidence and repository-controls fail. PR 27 is a draft isolation candidate: 500 unit and 10 PostgreSQL acceptance tests pass locally, scope/merge pass, but Zizmor reports 84 findings and hosted evidence/repository-controls fail. PR 19 is a draft endpoint candidate with issue/plan base 17e7a5c; local validation and 12/12 PostgreSQL acceptance pass, while full Zizmor and hosted review/controls remain blockers. PR 29 used main and produced zero changes. No live VS Code or successful cloud agent run is recorded; do not claim hosted ready_for_acceptance.</a:t>
+              <a:rPr dirty="0"/>
+              <a:t>The audited main baseline remains b65c2de5c8224342c72c37eeed7ef9f965ad8a2c and the framework release remains blocked. PR 18 is at 17e7a5c; hosted acceptance tests pass, but evidence and repository-controls fail. PR 27 is a draft isolation candidate: 500 unit and 10 PostgreSQL acceptance tests pass locally, scope/merge pass, but </a:t>
+            </a:r>
+            <a:r>
+              <a:rPr dirty="0" err="1"/>
+              <a:t>Zizmor</a:t>
+            </a:r>
+            <a:r>
+              <a:rPr dirty="0"/>
+              <a:t> reports 84 findings and hosted evidence/repository-controls fail. </a:t>
+            </a:r>
+            <a:r>
+              <a:rPr lang="en-GB" dirty="0"/>
+              <a:t>PR 19 at cf762216 is aligned to base 17e7a5c; its exact-head review and human-review pass, and PostgreSQL acceptance is 12/12. Full </a:t>
+            </a:r>
+            <a:r>
+              <a:rPr lang="en-GB" dirty="0" err="1"/>
+              <a:t>Zizmor</a:t>
+            </a:r>
+            <a:r>
+              <a:rPr lang="en-GB" dirty="0"/>
+              <a:t> reports 86 findings and repository-controls fails. PR 28 at 0260fe99 also has exact-head approval and passing human-review/evidence, but repository-controls fails.</a:t>
+            </a:r>
+            <a:r>
+              <a:rPr dirty="0"/>
+              <a:t> PR 29 used main and produced zero changes. No live VS Code or successful cloud agent run is recorded; do not claim hosted </a:t>
+            </a:r>
+            <a:r>
+              <a:rPr dirty="0" err="1"/>
+              <a:t>ready_for_acceptance</a:t>
+            </a:r>
+            <a:r>
+              <a:rPr dirty="0"/>
+              <a:t>.</a:t>
             </a:r>
           </a:p>
         </p:txBody>
@@ -3511,65 +3571,175 @@
           <a:lstStyle/>
           <a:p>
             <a:r>
+              <a:rPr dirty="0"/>
               <a:t>TALK TRACK</a:t>
             </a:r>
           </a:p>
           <a:p>
             <a:r>
-              <a:t>Now the second story: GET /orders/:id. The read is bounded and uses the existing order data/storage boundary. The issue and machine plan now bind to parent 17e7a5c; the endpoint branch has been rebased to that exact parent. Local validate passes 470 unit tests and 79 governance checks; PostgreSQL acceptance passes 12/12 across processes and writer restart; scope and merge checks pass. The full validate:all run still exits 1 at Zizmor with 86 findings (65 errors, 21 notes), while Poutine reports zero findings. That is real local application evidence, not an accepted cloud delivery.</a:t>
-            </a:r>
-          </a:p>
-          <a:p>
-            <a:r>
-              <a:t>The refreshed PR 19 checks pass plan-contract, scope, acceptance, quality, dependency review, secret scan, merge-validation, and CodeQL. Repository-controls fails and human-review is still blocked pending the requested independent review. PR 19 remains draft.</a:t>
-            </a:r>
-          </a:p>
-          <a:p/>
-          <a:p>
-            <a:r>
+              <a:rPr dirty="0"/>
+              <a:t>Now the second story: GET /orders/:id. The read is bounded and uses the existing order data/storage boundary. The issue and machine plan now bind to parent 17e7a5c; the endpoint branch has been rebased to that exact parent. Local validate passes 470 unit tests and 79 governance checks; PostgreSQL acceptance passes 12/12 across processes and writer restart; scope and merge checks pass. The full </a:t>
+            </a:r>
+            <a:r>
+              <a:rPr dirty="0" err="1"/>
+              <a:t>validate:all</a:t>
+            </a:r>
+            <a:r>
+              <a:rPr dirty="0"/>
+              <a:t> run still exits 1 at </a:t>
+            </a:r>
+            <a:r>
+              <a:rPr dirty="0" err="1"/>
+              <a:t>Zizmor</a:t>
+            </a:r>
+            <a:r>
+              <a:rPr dirty="0"/>
+              <a:t> with 86 findings (65 errors, 21 notes), while Poutine reports zero findings. That is real local application evidence, not an accepted cloud delivery.</a:t>
+            </a:r>
+          </a:p>
+          <a:p>
+            <a:r>
+              <a:rPr dirty="0"/>
+              <a:t>The refreshed PR 19 checks pass plan-contract, scope, acceptance, quality, dependency review, secret scan, merge-validation, and </a:t>
+            </a:r>
+            <a:r>
+              <a:rPr dirty="0" err="1"/>
+              <a:t>CodeQL</a:t>
+            </a:r>
+            <a:r>
+              <a:rPr dirty="0"/>
+              <a:t>. Repository-controls fails and </a:t>
+            </a:r>
+            <a:r>
+              <a:rPr lang="en-GB" dirty="0" err="1"/>
+              <a:t>vibeprogrammer</a:t>
+            </a:r>
+            <a:r>
+              <a:rPr lang="en-GB" dirty="0"/>
+              <a:t> approved the exact head and hosted human-review passes; repository-controls still fails.</a:t>
+            </a:r>
+            <a:r>
+              <a:rPr dirty="0"/>
+              <a:t> PR 19 remains draft.</a:t>
+            </a:r>
+          </a:p>
+          <a:p>
+            <a:endParaRPr dirty="0"/>
+          </a:p>
+          <a:p>
+            <a:r>
+              <a:rPr dirty="0"/>
               <a:t>DEMO — REPO / VS CODE</a:t>
             </a:r>
           </a:p>
           <a:p>
             <a:r>
-              <a:t>Follow docs/demos/plan-execute-order-lookup.md. Open src/app.ts, both getOrder implementations, and the focused tests. Show the parameterized SELECT and unchanged POST behavior. The endpoint's 17.11 PostgreSQL service was disposable and has been stopped after the 12/12 run. Do not launch an agent run until the parent controller is accepted, the human review is complete, and the GitHub.com task UI can select the exact base. Use the GitHub.com UI only for cloud tasks; do not initiate them from the Copilot app or CLI.</a:t>
-            </a:r>
-          </a:p>
-          <a:p/>
-          <a:p>
-            <a:r>
+              <a:rPr dirty="0"/>
+              <a:t>Follow docs/demos/plan-execute-order-lookup.md. Open src/</a:t>
+            </a:r>
+            <a:r>
+              <a:rPr dirty="0" err="1"/>
+              <a:t>app.ts</a:t>
+            </a:r>
+            <a:r>
+              <a:rPr dirty="0"/>
+              <a:t>, both </a:t>
+            </a:r>
+            <a:r>
+              <a:rPr dirty="0" err="1"/>
+              <a:t>getOrder</a:t>
+            </a:r>
+            <a:r>
+              <a:rPr dirty="0"/>
+              <a:t> implementations, and the focused tests. Show the parameterized SELECT and unchanged POST behavior. The endpoint's 17.11 PostgreSQL service was disposable and has been stopped after the 12/12 run. </a:t>
+            </a:r>
+            <a:r>
+              <a:rPr lang="en-GB" dirty="0"/>
+              <a:t>PR 19's human review is complete. Do not launch a cloud run until the parent controller is accepted and the GitHub.com Agents UI loads with the exact base selectable.</a:t>
+            </a:r>
+            <a:r>
+              <a:rPr dirty="0"/>
+              <a:t> Use the GitHub.com UI only for cloud tasks; do not initiate them from the Copilot app or CLI.</a:t>
+            </a:r>
+          </a:p>
+          <a:p>
+            <a:endParaRPr dirty="0"/>
+          </a:p>
+          <a:p>
+            <a:r>
+              <a:rPr dirty="0"/>
               <a:t>DOCUMENTATION LINKS</a:t>
             </a:r>
           </a:p>
           <a:p>
             <a:r>
+              <a:rPr dirty="0"/>
               <a:t>https://github.com/webmaxru/northstar-orders-api-demo/issues/17</a:t>
             </a:r>
           </a:p>
           <a:p>
             <a:r>
+              <a:rPr dirty="0"/>
               <a:t>https://github.com/webmaxru/northstar-orders-api-demo/pull/19</a:t>
             </a:r>
           </a:p>
           <a:p>
             <a:r>
+              <a:rPr dirty="0"/>
               <a:t>https://learn.microsoft.com/en-us/training/modules/design-agent-architecture-integration/4-plan-reason-execution</a:t>
             </a:r>
           </a:p>
           <a:p>
             <a:r>
+              <a:rPr dirty="0"/>
               <a:t>https://code.visualstudio.com/docs/copilot/chat/chat-agent-mode</a:t>
             </a:r>
           </a:p>
-          <a:p/>
-          <a:p>
-            <a:r>
+          <a:p>
+            <a:endParaRPr dirty="0"/>
+          </a:p>
+          <a:p>
+            <a:r>
+              <a:rPr dirty="0"/>
               <a:t>EVIDENCE BOUNDARY</a:t>
             </a:r>
           </a:p>
           <a:p>
             <a:r>
-              <a:t>PostgreSQL acceptance passed 12/12 on the source tree committed to PR 19 head cf762216. The local run used an isolated PostgreSQL 17.11 container on 127.0.0.1:55433; that container is stopped. Local validate passed 470 unit tests and 79 governance checks; scope and merge checks pass. Full validate:all exits 1 on 86 Zizmor findings. On the latest hosted run, plan-contract, scope, acceptance, quality, dependency review, secret scan, CodeQL and evidence pass; repository-controls fails and human-review has not passed. No VS Code/cloud delivery or hosted acceptance is proved.</a:t>
+              <a:rPr dirty="0"/>
+              <a:t>PostgreSQL acceptance passed 12/12 on the source tree committed to PR 19 head cf762216. The local run used an isolated PostgreSQL 17.11 container on 127.0.0.1:55433; that container is stopped. Local validate passed 470 unit tests and 79 governance checks; scope and merge checks pass. Full </a:t>
+            </a:r>
+            <a:r>
+              <a:rPr dirty="0" err="1"/>
+              <a:t>validate:all</a:t>
+            </a:r>
+            <a:r>
+              <a:rPr dirty="0"/>
+              <a:t> exits 1 on 86 </a:t>
+            </a:r>
+            <a:r>
+              <a:rPr dirty="0" err="1"/>
+              <a:t>Zizmor</a:t>
+            </a:r>
+            <a:r>
+              <a:rPr dirty="0"/>
+              <a:t> findings. On the latest hosted run, plan-contract, scope, acceptance, quality, dependency review, secret scan, </a:t>
+            </a:r>
+            <a:r>
+              <a:rPr dirty="0" err="1"/>
+              <a:t>CodeQL</a:t>
+            </a:r>
+            <a:r>
+              <a:rPr dirty="0"/>
+              <a:t> and evidence pass; </a:t>
+            </a:r>
+            <a:r>
+              <a:rPr lang="en-GB" dirty="0"/>
+              <a:t>repository-controls fails; exact-head review and human-review pass, but hosted acceptance is not established.</a:t>
+            </a:r>
+            <a:r>
+              <a:rPr dirty="0"/>
+              <a:t> No VS Code/cloud delivery or hosted acceptance is proved.</a:t>
             </a:r>
           </a:p>
         </p:txBody>
@@ -3810,7 +3980,9 @@
               <a:t>The audited baseline had a mismatch between its medium-risk combined-mode claim and the unconditional plan approval path. PR 18 is a repair candidate for versioned plans and risk-aware selection, but it remains unaccepted and has not passed a live browser or host canary. Do not present that repair as an established runtime boundary.</a:t>
             </a:r>
           </a:p>
-          <a:p/>
+          <a:p>
+            <a:endParaRPr/>
+          </a:p>
           <a:p>
             <a:r>
               <a:t>DEMO — REPO / VS CODE</a:t>
@@ -3821,7 +3993,9 @@
               <a:t>Show AGENTS.md, the planner and implementer tool declarations, .github/hooks/agent-boundary.json, and scripts/authorize-tool.mjs at the audited baseline. Contrast instruction text with executable authorization. Then show PR 18's current candidate as an unaccepted repair, not proof that every VS Code or cloud hook honors the same decision.</a:t>
             </a:r>
           </a:p>
-          <a:p/>
+          <a:p>
+            <a:endParaRPr/>
+          </a:p>
           <a:p>
             <a:r>
               <a:t>DOCUMENTATION LINKS</a:t>
@@ -4501,58 +4675,125 @@
           <a:lstStyle/>
           <a:p>
             <a:r>
+              <a:rPr dirty="0"/>
               <a:t>TALK TRACK</a:t>
             </a:r>
           </a:p>
           <a:p>
             <a:r>
+              <a:rPr dirty="0"/>
               <a:t>Probabilistic generation needs objective evaluation around it. For these examples, that means build/type checks, behavior tests, scope checks, security signals and independent human review. Each has a different job.</a:t>
             </a:r>
           </a:p>
           <a:p>
             <a:r>
-              <a:t>The endpoint candidate is locally stronger now: 470 unit tests, 12 PostgreSQL acceptance tests, and scope/merge checks pass on the refreshed base. Its full validate:all still fails on 86 Zizmor findings (65 errors, 21 notes); Poutine reports zero findings. The issue #16 candidate has a separate local bundle of 500 unit tests and 10 PostgreSQL acceptance tests, but full validation reports 84 Zizmor findings (64 errors, 20 notes). Neither local result implies hosted acceptance.</a:t>
-            </a:r>
-          </a:p>
-          <a:p>
-            <a:r>
-              <a:t>The refreshed PR 19 plan-contract, scope, acceptance, quality, dependency, secret-scan, merge and CodeQL checks pass. Repository-controls fails and independent human review has not passed. Missing hosted evidence is not a pass.</a:t>
-            </a:r>
-          </a:p>
-          <a:p/>
-          <a:p>
-            <a:r>
+              <a:rPr dirty="0"/>
+              <a:t>The endpoint candidate is locally stronger now: 470 unit tests, 12 PostgreSQL acceptance tests, and scope/merge checks pass on the refreshed base. Its full </a:t>
+            </a:r>
+            <a:r>
+              <a:rPr dirty="0" err="1"/>
+              <a:t>validate:all</a:t>
+            </a:r>
+            <a:r>
+              <a:rPr dirty="0"/>
+              <a:t> still fails on 86 </a:t>
+            </a:r>
+            <a:r>
+              <a:rPr dirty="0" err="1"/>
+              <a:t>Zizmor</a:t>
+            </a:r>
+            <a:r>
+              <a:rPr dirty="0"/>
+              <a:t> findings (65 errors, 21 notes); Poutine reports zero findings. The issue #16 candidate has a separate local bundle of 500 unit tests and 10 PostgreSQL acceptance tests, but full validation reports 84 </a:t>
+            </a:r>
+            <a:r>
+              <a:rPr dirty="0" err="1"/>
+              <a:t>Zizmor</a:t>
+            </a:r>
+            <a:r>
+              <a:rPr dirty="0"/>
+              <a:t> findings (64 errors, 20 notes). Neither local result implies hosted acceptance.</a:t>
+            </a:r>
+          </a:p>
+          <a:p>
+            <a:r>
+              <a:rPr dirty="0"/>
+              <a:t>The refreshed PR 19 plan-contract, scope, acceptance, quality, dependency, secret-scan, merge and </a:t>
+            </a:r>
+            <a:r>
+              <a:rPr dirty="0" err="1"/>
+              <a:t>CodeQL</a:t>
+            </a:r>
+            <a:r>
+              <a:rPr dirty="0"/>
+              <a:t> checks pass. </a:t>
+            </a:r>
+            <a:r>
+              <a:rPr lang="en-GB" dirty="0" err="1"/>
+              <a:t>Vibeprogrammer</a:t>
+            </a:r>
+            <a:r>
+              <a:rPr lang="en-GB" dirty="0"/>
+              <a:t> approved PR 19's exact head and hosted human-review passes; repository-controls still fails.</a:t>
+            </a:r>
+            <a:r>
+              <a:rPr dirty="0"/>
+              <a:t> Missing hosted evidence is not a pass.</a:t>
+            </a:r>
+          </a:p>
+          <a:p>
+            <a:endParaRPr dirty="0"/>
+          </a:p>
+          <a:p>
+            <a:r>
+              <a:rPr dirty="0"/>
               <a:t>DEMO — REPO / VS CODE</a:t>
             </a:r>
           </a:p>
           <a:p>
             <a:r>
-              <a:t>Show the actual local validation output and scanner reports for PR 19 and PR 27. Identify the exact candidate/base before comparing counts. Open the PostgreSQL acceptance result and Zizmor report. Do not suppress findings or present a green subset as overall acceptance.</a:t>
-            </a:r>
-          </a:p>
-          <a:p/>
-          <a:p>
-            <a:r>
+              <a:rPr dirty="0"/>
+              <a:t>Show the actual local validation output and scanner reports for PR 19 and PR 27. Identify the exact candidate/base before comparing counts. Open the PostgreSQL acceptance result and </a:t>
+            </a:r>
+            <a:r>
+              <a:rPr dirty="0" err="1"/>
+              <a:t>Zizmor</a:t>
+            </a:r>
+            <a:r>
+              <a:rPr dirty="0"/>
+              <a:t> report. Do not suppress findings or present a green subset as overall acceptance.</a:t>
+            </a:r>
+          </a:p>
+          <a:p>
+            <a:endParaRPr dirty="0"/>
+          </a:p>
+          <a:p>
+            <a:r>
+              <a:rPr dirty="0"/>
               <a:t>DOCUMENTATION LINKS</a:t>
             </a:r>
           </a:p>
           <a:p>
             <a:r>
+              <a:rPr dirty="0"/>
               <a:t>https://github.com/webmaxru/northstar-orders-api-demo/issues/14</a:t>
             </a:r>
           </a:p>
           <a:p>
             <a:r>
+              <a:rPr dirty="0"/>
               <a:t>https://github.com/webmaxru/northstar-orders-api-demo/issues/16</a:t>
             </a:r>
           </a:p>
           <a:p>
             <a:r>
+              <a:rPr dirty="0"/>
               <a:t>https://github.com/webmaxru/northstar-orders-api-demo/issues/17</a:t>
             </a:r>
           </a:p>
           <a:p>
             <a:r>
+              <a:rPr dirty="0"/>
               <a:t>https://learn.microsoft.com/en-us/training/modules/design-agent-architecture-integration/5-pull-request-governance-controls</a:t>
             </a:r>
           </a:p>
@@ -4658,7 +4899,7 @@
           <a:p>
             <a:r>
               <a:rPr dirty="0"/>
-              <a:t xml:space="preserve">The filename </a:t>
+              <a:t>The filename </a:t>
             </a:r>
             <a:r>
               <a:rPr dirty="0" err="1"/>
@@ -4666,7 +4907,7 @@
             </a:r>
             <a:r>
               <a:rPr dirty="0"/>
-              <a:t xml:space="preserve"> is not globally unique. It is only safe inside the correct isolated workspace and source-run context. Copying a file from another task does not make it evidence for this one.</a:t>
+              <a:t> is not globally unique. It is only safe inside the correct isolated workspace and source-run context. Copying a file from another task does not make it evidence for this one.</a:t>
             </a:r>
           </a:p>
           <a:p>
@@ -4962,7 +5203,9 @@
               <a:t>The issue #16 candidate adds isolated task worktrees and PostgreSQL schemas. Two read-only CLI canaries in separate worktrees matched the live task, contract, approved plan, base, session and workspace-owner identities. PR 27 passes 500 unit tests, 10 PostgreSQL acceptance tests, scope and merge checks locally. Its full validate:all still fails on 84 Zizmor findings; hosted evidence and repository-controls fail. Cloud attempt PR 29 used main and produced zero changed files, so AC9 cloud isolation remains unproved.</a:t>
             </a:r>
           </a:p>
-          <a:p/>
+          <a:p>
+            <a:endParaRPr/>
+          </a:p>
           <a:p>
             <a:r>
               <a:t>DEMO — REPO / VS CODE</a:t>
@@ -4973,7 +5216,9 @@
               <a:t>Show the separate worktree paths and PR 27. Explain the exact checks covered by the CLI canaries and what they do not cover. Do not run a destructive shared-checkout test in a real task directory. VS Code Local-mode demos remain serial. If attempting cloud later, use the GitHub.com UI and select the exact approved base; stop if the Agents task view cannot load or select it.</a:t>
             </a:r>
           </a:p>
-          <a:p/>
+          <a:p>
+            <a:endParaRPr/>
+          </a:p>
           <a:p>
             <a:r>
               <a:t>DOCUMENTATION LINKS</a:t>
@@ -5004,7 +5249,9 @@
               <a:t>https://git-scm.com/docs/git-worktree</a:t>
             </a:r>
           </a:p>
-          <a:p/>
+          <a:p>
+            <a:endParaRPr/>
+          </a:p>
           <a:p>
             <a:r>
               <a:t>EVIDENCE BOUNDARY</a:t>
@@ -6470,91 +6717,157 @@
           <a:lstStyle/>
           <a:p>
             <a:r>
+              <a:rPr dirty="0"/>
               <a:t>TALK TRACK</a:t>
             </a:r>
           </a:p>
           <a:p>
             <a:r>
+              <a:rPr dirty="0"/>
               <a:t>Thank you. I hope the useful takeaway is that we can make agentic development inspectable. We can name the task, see the boundaries, challenge the plan or code at the right time, and ask what the evidence actually proves. The database acceptance results are real; a completed governed-agent demonstration is not established.</a:t>
             </a:r>
           </a:p>
-          <a:p/>
-          <a:p>
-            <a:r>
+          <a:p>
+            <a:endParaRPr dirty="0"/>
+          </a:p>
+          <a:p>
+            <a:r>
+              <a:rPr dirty="0"/>
               <a:t>DEMO — REPO / VS CODE</a:t>
             </a:r>
           </a:p>
           <a:p>
             <a:r>
-              <a:t>Show the updated paired runbook evidence table and open PR 18 plus draft PRs 19, 27 and 28. Say plainly: PR 19's plan/base is aligned to 17e7a5c and its PostgreSQL acceptance passed 12/12, but full validation has 86 Zizmor findings and hosted repository-controls/human-review remain blocked. PR 27 passes local isolation validation but full validation has 84 Zizmor findings and hosted evidence/controls fail. PR 18 and PR 28 are also unaccepted. No live VS Code or successful cloud-agent run is recorded. Do not show a green status as acceptance.</a:t>
-            </a:r>
-          </a:p>
-          <a:p/>
-          <a:p>
-            <a:r>
+              <a:rPr dirty="0"/>
+              <a:t>Show the updated paired runbook evidence table and open PR 18 plus draft PRs 19, 27 and 28. </a:t>
+            </a:r>
+            <a:r>
+              <a:rPr lang="en-GB" dirty="0"/>
+              <a:t>Say plainly: PR 19 at cf762216 is aligned to base 17e7a5c; its exact-head review and hosted human-review pass, PostgreSQL acceptance is 12/12, full validation reports 86 </a:t>
+            </a:r>
+            <a:r>
+              <a:rPr lang="en-GB" dirty="0" err="1"/>
+              <a:t>Zizmor</a:t>
+            </a:r>
+            <a:r>
+              <a:rPr lang="en-GB" dirty="0"/>
+              <a:t> findings, and repository-controls fails. PR 27 at fc59deef also has exact-head approval and passing human-review; local isolation validation passes, full validation reports 84 </a:t>
+            </a:r>
+            <a:r>
+              <a:rPr lang="en-GB" dirty="0" err="1"/>
+              <a:t>Zizmor</a:t>
+            </a:r>
+            <a:r>
+              <a:rPr lang="en-GB" dirty="0"/>
+              <a:t> findings, and hosted evidence/repository-controls fail. PR 28 at 0260fe99 has exact-head approval and passing human-review/evidence, but repository-controls fails. PRs 18, 19, 27 and 28 remain unaccepted. No live VS Code or successful cloud-agent run is recorded. Do not show a green status as acceptance.</a:t>
+            </a:r>
+            <a:endParaRPr dirty="0"/>
+          </a:p>
+          <a:p>
+            <a:endParaRPr dirty="0"/>
+          </a:p>
+          <a:p>
+            <a:r>
+              <a:rPr dirty="0"/>
               <a:t>NEXT ACTION</a:t>
             </a:r>
           </a:p>
           <a:p>
             <a:r>
-              <a:t>An independent reviewer must review the latest implementation head on PRs 19 and 28. For cloud proof, refresh the GitHub.com session after the account-switch warning, open issue 16, and use the GitHub.com Agents UI to start a plan/read-only task on base 17e7a5c only if the task picker loads. The Agents page previously returned “Unable to load tasks”; no new task was launched. PR 29 was a wrong-base/no-change attempt, not successful cloud evidence. Do not use the Copilot app or CLI to start the cloud task. No repository settings or rulesets were changed.</a:t>
-            </a:r>
-          </a:p>
-          <a:p/>
-          <a:p>
-            <a:r>
+              <a:rPr lang="en-GB" dirty="0"/>
+              <a:t>Exact-head reviews on PRs 19 and 28 are approved and their hosted human-review checks pass; repository-controls still blocks acceptance.</a:t>
+            </a:r>
+            <a:r>
+              <a:rPr dirty="0"/>
+              <a:t> For cloud proof, refresh the GitHub.com session after the account-switch warning, open issue 16, and use the GitHub.com Agents UI to start a plan/read-only task on base 17e7a5c only if the task picker loads. The Agents page previously returned “Unable to load tasks”; no new task was launched. PR 29 was a wrong-base/no-change attempt, not successful cloud evidence. Do not use the Copilot app or CLI to start the cloud task. No repository settings or rulesets were changed.</a:t>
+            </a:r>
+          </a:p>
+          <a:p>
+            <a:endParaRPr dirty="0"/>
+          </a:p>
+          <a:p>
+            <a:r>
+              <a:rPr dirty="0"/>
               <a:t>DOCUMENTATION LINKS</a:t>
             </a:r>
           </a:p>
           <a:p>
             <a:r>
+              <a:rPr dirty="0"/>
               <a:t>https://github.com/webmaxru/ai-engineering-system</a:t>
             </a:r>
           </a:p>
           <a:p>
             <a:r>
+              <a:rPr dirty="0"/>
               <a:t>https://github.com/webmaxru/northstar-orders-api-demo/pull/18</a:t>
             </a:r>
           </a:p>
           <a:p>
             <a:r>
+              <a:rPr dirty="0"/>
               <a:t>https://github.com/webmaxru/northstar-orders-api-demo/pull/19</a:t>
             </a:r>
           </a:p>
           <a:p>
             <a:r>
+              <a:rPr dirty="0"/>
               <a:t>https://github.com/webmaxru/northstar-orders-api-demo/pull/27</a:t>
             </a:r>
           </a:p>
           <a:p>
             <a:r>
+              <a:rPr dirty="0"/>
               <a:t>https://github.com/webmaxru/northstar-orders-api-demo/pull/28</a:t>
             </a:r>
           </a:p>
           <a:p>
             <a:r>
+              <a:rPr dirty="0"/>
               <a:t>https://github.com/webmaxru/northstar-orders-api-demo/issues/16</a:t>
             </a:r>
           </a:p>
           <a:p>
             <a:r>
+              <a:rPr dirty="0"/>
               <a:t>https://github.com/webmaxru/ai-engineering-system/blob/main/docs/GUIDE-CONFORMANCE.md</a:t>
             </a:r>
           </a:p>
           <a:p>
             <a:r>
+              <a:rPr dirty="0"/>
               <a:t>https://learn.microsoft.com/en-us/training/modules/design-agent-architecture-integration/4-plan-reason-execution</a:t>
             </a:r>
           </a:p>
-          <a:p/>
-          <a:p>
-            <a:r>
+          <a:p>
+            <a:endParaRPr dirty="0"/>
+          </a:p>
+          <a:p>
+            <a:r>
+              <a:rPr dirty="0"/>
               <a:t>EVIDENCE BOUNDARY</a:t>
             </a:r>
           </a:p>
           <a:p>
             <a:r>
-              <a:t>PR 18 is open and unaccepted; PRs 19, 27 and 28 remain draft/unaccepted. PR 19's issue/plan/base identities are reconciled, but repository-controls and independent review still block it. PR 27 has passing local identity and database proofs but no accepted hosted evidence or cloud AC9. PR 29 was a wrong-base/no-change attempt. No hosted ready_for_acceptance or live VS Code/successful cloud-agent delivery is recorded.</a:t>
+              <a:rPr dirty="0"/>
+              <a:t>PR 18 is open and unaccepted; PRs 19, 27 and 28 remain draft/unaccepted. </a:t>
+            </a:r>
+            <a:r>
+              <a:rPr lang="en-GB" dirty="0"/>
+              <a:t>PR 19's issue/plan/base identities are reconciled; exact-head review and hosted human-review pass, but repository-controls still blocks acceptance.</a:t>
+            </a:r>
+            <a:r>
+              <a:rPr dirty="0"/>
+              <a:t> PR 27 has passing local identity and database proofs but no accepted hosted evidence or cloud AC9. PR 29 was a wrong-base/no-change attempt. No hosted </a:t>
+            </a:r>
+            <a:r>
+              <a:rPr dirty="0" err="1"/>
+              <a:t>ready_for_acceptance</a:t>
+            </a:r>
+            <a:r>
+              <a:rPr dirty="0"/>
+              <a:t> or live VS Code/successful cloud-agent delivery is recorded.</a:t>
             </a:r>
           </a:p>
         </p:txBody>
@@ -6777,7 +7090,9 @@
               <a:t>TIMING: 1:45</a:t>
             </a:r>
           </a:p>
-          <a:p/>
+          <a:p>
+            <a:endParaRPr/>
+          </a:p>
           <a:p>
             <a:r>
               <a:t>TALK TRACK</a:t>
@@ -6788,7 +7103,9 @@
               <a:t>This is a synthetic incident, not a real agent run. I use it to make one failure shape visible: a process-local check cannot guarantee correctness across concurrent requests and processes. The run counts and pull request in the left panel are fictional. The code on the right is an exact excerpt from the genuine WI-1842 starter and shows why its idempotency key was ignored.</a:t>
             </a:r>
           </a:p>
-          <a:p/>
+          <a:p>
+            <a:endParaRPr/>
+          </a:p>
           <a:p>
             <a:r>
               <a:t>TRANSITION</a:t>
@@ -6799,7 +7116,9 @@
               <a:t>The agent did more than generate code, so its failure has a different geometry.</a:t>
             </a:r>
           </a:p>
-          <a:p/>
+          <a:p>
+            <a:endParaRPr/>
+          </a:p>
           <a:p>
             <a:r>
               <a:t>DEMO — REPO / VS CODE</a:t>
@@ -6810,7 +7129,9 @@
               <a:t>Open the historical starter at 21d5e5a937e61a2a0513158942b3c9556c1ab0e0. Show BasicOrderService.placeOrder and idempotency-harness.ts, then compare them with the plan-first runbook. Do not present the fictional 42/42 result or PR #5 as real evidence.</a:t>
             </a:r>
           </a:p>
-          <a:p/>
+          <a:p>
+            <a:endParaRPr/>
+          </a:p>
           <a:p>
             <a:r>
               <a:t>DOCUMENTATION LINKS</a:t>
@@ -6831,7 +7152,9 @@
               <a:t>https://learn.microsoft.com/en-us/training/modules/memory-state-evaluation/5-evaluation-signals-quality-gates</a:t>
             </a:r>
           </a:p>
-          <a:p/>
+          <a:p>
+            <a:endParaRPr/>
+          </a:p>
           <a:p>
             <a:r>
               <a:t>EVIDENCE BOUNDARY</a:t>
@@ -6985,65 +7308,135 @@
           <a:lstStyle/>
           <a:p>
             <a:r>
+              <a:rPr dirty="0"/>
               <a:t>TALK TRACK</a:t>
             </a:r>
           </a:p>
           <a:p>
             <a:r>
-              <a:t>Here is the distinction I want to make visible: a repaired implementation candidate can pass application or acceptance tests without becoming an accepted release. PR 18 at 17e7a5c5 passes its hosted acceptance tests, but evidence and repository-controls are still blocked. PR 27 adds task/workspace and PostgreSQL isolation. Its local validate and acceptance tests pass, but full validate:all reports 84 Zizmor findings and its hosted evidence/control checks fail. The review is approved, but the PR remains draft. I will not merge those facts into one green status.</a:t>
-            </a:r>
-          </a:p>
-          <a:p/>
-          <a:p>
-            <a:r>
+              <a:rPr dirty="0"/>
+              <a:t>Here is the distinction I want to make visible: a repaired implementation candidate can pass application or acceptance tests without becoming an accepted release. PR 18 at 17e7a5c5 passes its hosted acceptance tests, but evidence and repository-controls are still blocked. PR 27 adds task/workspace and PostgreSQL isolation. Its local validate and acceptance tests pass, but full </a:t>
+            </a:r>
+            <a:r>
+              <a:rPr dirty="0" err="1"/>
+              <a:t>validate:all</a:t>
+            </a:r>
+            <a:r>
+              <a:rPr dirty="0"/>
+              <a:t> reports 84 </a:t>
+            </a:r>
+            <a:r>
+              <a:rPr dirty="0" err="1"/>
+              <a:t>Zizmor</a:t>
+            </a:r>
+            <a:r>
+              <a:rPr dirty="0"/>
+              <a:t> findings and its hosted evidence/control checks fail. </a:t>
+            </a:r>
+            <a:r>
+              <a:rPr lang="en-GB" dirty="0" err="1"/>
+              <a:t>Vibeprogrammer</a:t>
+            </a:r>
+            <a:r>
+              <a:rPr lang="en-GB" dirty="0"/>
+              <a:t> approved PR 27's exact head; it remains draft because hosted evidence and repository-controls fail.</a:t>
+            </a:r>
+            <a:r>
+              <a:rPr dirty="0"/>
+              <a:t> I will not merge those facts into one green status.</a:t>
+            </a:r>
+          </a:p>
+          <a:p>
+            <a:endParaRPr dirty="0"/>
+          </a:p>
+          <a:p>
+            <a:r>
+              <a:rPr dirty="0"/>
               <a:t>DEMO — REPO / VS CODE</a:t>
             </a:r>
           </a:p>
           <a:p>
             <a:r>
-              <a:t>Open PR 18 and show its current governed validation result. Then open PR 27 and distinguish local validation, the two read-only CLI identity canaries, and the still-blocked hosted checks. Keep scanner findings visible: Poutine reports zero findings, while Zizmor reports 84. The displayed code is the exact historical missing-artifact check from the audited baseline; it ends after the closing brace, before the report object. Do not claim either candidate is hosted acceptance.</a:t>
-            </a:r>
-          </a:p>
-          <a:p/>
-          <a:p>
-            <a:r>
+              <a:rPr dirty="0"/>
+              <a:t>Open PR 18 and show its current governed validation result. Then open PR 27 and distinguish local validation, the two read-only CLI identity canaries, and the still-blocked hosted checks. Keep scanner findings visible: Poutine reports zero findings, while </a:t>
+            </a:r>
+            <a:r>
+              <a:rPr dirty="0" err="1"/>
+              <a:t>Zizmor</a:t>
+            </a:r>
+            <a:r>
+              <a:rPr dirty="0"/>
+              <a:t> reports 84. The displayed code is the exact historical missing-artifact check from the audited baseline; it ends after the closing brace, before the report object. Do not claim either candidate is hosted acceptance.</a:t>
+            </a:r>
+          </a:p>
+          <a:p>
+            <a:endParaRPr dirty="0"/>
+          </a:p>
+          <a:p>
+            <a:r>
+              <a:rPr dirty="0"/>
               <a:t>DOCUMENTATION LINKS</a:t>
             </a:r>
           </a:p>
           <a:p>
             <a:r>
+              <a:rPr dirty="0"/>
               <a:t>https://github.com/webmaxru/northstar-orders-api-demo/pull/18</a:t>
             </a:r>
           </a:p>
           <a:p>
             <a:r>
+              <a:rPr dirty="0"/>
               <a:t>https://github.com/webmaxru/northstar-orders-api-demo/pull/27</a:t>
             </a:r>
           </a:p>
           <a:p>
             <a:r>
+              <a:rPr dirty="0"/>
               <a:t>https://github.com/webmaxru/northstar-orders-api-demo/issues/14</a:t>
             </a:r>
           </a:p>
           <a:p>
             <a:r>
+              <a:rPr dirty="0"/>
               <a:t>https://github.com/webmaxru/ai-engineering-system/blob/main/docs/GUIDE-CONFORMANCE.md</a:t>
             </a:r>
           </a:p>
           <a:p>
             <a:r>
+              <a:rPr dirty="0"/>
               <a:t>https://github.com/webmaxru/northstar-orders-api-demo</a:t>
             </a:r>
           </a:p>
-          <a:p/>
-          <a:p>
-            <a:r>
+          <a:p>
+            <a:endParaRPr dirty="0"/>
+          </a:p>
+          <a:p>
+            <a:r>
+              <a:rPr dirty="0"/>
               <a:t>EVIDENCE BOUNDARY</a:t>
             </a:r>
           </a:p>
           <a:p>
             <a:r>
-              <a:t>PR 18 head 17e7a5c has passing hosted acceptance tests but fails evidence and repository-controls. PR 27 head fc59deef passes 500 unit tests, 10 PostgreSQL acceptance tests, scope and merge checks locally; its full validation reports 84 Zizmor findings (64 errors, 20 notes). Two read-only CLI identity canaries pass only for task/contract/plan/base/session/owner binding. No live VS Code or successful cloud run is recorded; PR 29 used the wrong base and produced zero changes. No hosted ready_for_acceptance is recorded.</a:t>
+              <a:rPr dirty="0"/>
+              <a:t>PR 18 head 17e7a5c has passing hosted acceptance tests but fails evidence and repository-controls. PR 27 head fc59deef passes 500 unit tests, 10 PostgreSQL acceptance tests, scope and merge checks locally; its full validation reports 84 </a:t>
+            </a:r>
+            <a:r>
+              <a:rPr dirty="0" err="1"/>
+              <a:t>Zizmor</a:t>
+            </a:r>
+            <a:r>
+              <a:rPr dirty="0"/>
+              <a:t> findings (64 errors, 20 notes). Two read-only CLI identity canaries pass only for task/contract/plan/base/session/owner binding. No live VS Code or successful cloud run is recorded; PR 29 used the wrong base and produced zero changes. No hosted </a:t>
+            </a:r>
+            <a:r>
+              <a:rPr dirty="0" err="1"/>
+              <a:t>ready_for_acceptance</a:t>
+            </a:r>
+            <a:r>
+              <a:rPr dirty="0"/>
+              <a:t> is recorded.</a:t>
             </a:r>
           </a:p>
         </p:txBody>
@@ -12885,7 +13278,7 @@
                 <a:ea typeface="Cascadia Mono" pitchFamily="34" charset="-122"/>
                 <a:cs typeface="Cascadia Mono" pitchFamily="34" charset="-120"/>
               </a:rPr>
-              <a:t xml:space="preserve">  - src/services/**</a:t>
+              <a:t>  - src/services/**</a:t>
             </a:r>
             <a:endParaRPr lang="en-US" sz="1400" dirty="0"/>
           </a:p>
@@ -12902,7 +13295,7 @@
                 <a:ea typeface="Cascadia Mono" pitchFamily="34" charset="-122"/>
                 <a:cs typeface="Cascadia Mono" pitchFamily="34" charset="-120"/>
               </a:rPr>
-              <a:t xml:space="preserve">  - tests/**</a:t>
+              <a:t>  - tests/**</a:t>
             </a:r>
             <a:endParaRPr lang="en-US" sz="1400" dirty="0"/>
           </a:p>
@@ -12942,7 +13335,7 @@
                 <a:ea typeface="Cascadia Mono" pitchFamily="34" charset="-122"/>
                 <a:cs typeface="Cascadia Mono" pitchFamily="34" charset="-120"/>
               </a:rPr>
-              <a:t xml:space="preserve">  - API schema</a:t>
+              <a:t>  - API schema</a:t>
             </a:r>
             <a:endParaRPr lang="en-US" sz="1400" dirty="0"/>
           </a:p>
@@ -12959,7 +13352,7 @@
                 <a:ea typeface="Cascadia Mono" pitchFamily="34" charset="-122"/>
                 <a:cs typeface="Cascadia Mono" pitchFamily="34" charset="-120"/>
               </a:rPr>
-              <a:t xml:space="preserve">  - authentication</a:t>
+              <a:t>  - authentication</a:t>
             </a:r>
             <a:endParaRPr lang="en-US" sz="1400" dirty="0"/>
           </a:p>
@@ -12976,7 +13369,7 @@
                 <a:ea typeface="Cascadia Mono" pitchFamily="34" charset="-122"/>
                 <a:cs typeface="Cascadia Mono" pitchFamily="34" charset="-120"/>
               </a:rPr>
-              <a:t xml:space="preserve">  - deployment configuration</a:t>
+              <a:t>  - deployment configuration</a:t>
             </a:r>
             <a:endParaRPr lang="en-US" sz="1400" dirty="0"/>
           </a:p>
@@ -13016,7 +13409,7 @@
                 <a:ea typeface="Cascadia Mono" pitchFamily="34" charset="-122"/>
                 <a:cs typeface="Cascadia Mono" pitchFamily="34" charset="-120"/>
               </a:rPr>
-              <a:t xml:space="preserve">  - use the existing Postgres transaction boundary</a:t>
+              <a:t>  - use the existing Postgres transaction boundary</a:t>
             </a:r>
             <a:endParaRPr lang="en-US" sz="1400" dirty="0"/>
           </a:p>
@@ -13033,7 +13426,7 @@
                 <a:ea typeface="Cascadia Mono" pitchFamily="34" charset="-122"/>
                 <a:cs typeface="Cascadia Mono" pitchFamily="34" charset="-120"/>
               </a:rPr>
-              <a:t xml:space="preserve">  - never log raw idempotency keys</a:t>
+              <a:t>  - never log raw idempotency keys</a:t>
             </a:r>
             <a:endParaRPr lang="en-US" sz="1400" dirty="0"/>
           </a:p>
@@ -17813,7 +18206,7 @@
               <a:buNone/>
             </a:pPr>
             <a:r>
-              <a:rPr lang="en-US" dirty="0" b="1" sz="1300">
+              <a:rPr lang="en-GB" sz="1300" b="1" dirty="0">
                 <a:solidFill>
                   <a:srgbClr val="F4F1E8"/>
                 </a:solidFill>
@@ -17821,7 +18214,7 @@
                 <a:ea typeface="Cascadia Mono" pitchFamily="34" charset="-122"/>
                 <a:cs typeface="Cascadia Mono" pitchFamily="34" charset="-120"/>
               </a:rPr>
-              <a:t>DRAFT: BASE/PLAN ALIGNED; PG 12/12; REVIEW/CONTROLS BLOCKED.</a:t>
+              <a:t>DRAFT: BASE ALIGNED; PG 12/12; REVIEW APPROVED; CONTROLS FAIL.</a:t>
             </a:r>
             <a:endParaRPr lang="en-US" sz="1150" dirty="0"/>
           </a:p>
@@ -24449,7 +24842,7 @@
                 <a:ea typeface="Georgia" pitchFamily="18" charset="-122"/>
                 <a:cs typeface="Georgia" pitchFamily="18" charset="-120"/>
               </a:rPr>
-              <a:t xml:space="preserve">Webdev, </a:t>
+              <a:t>Webdev, </a:t>
             </a:r>
             <a:r>
               <a:rPr lang="en-US" sz="1200" kern="0">
@@ -24471,7 +24864,7 @@
                 <a:ea typeface="Georgia" pitchFamily="18" charset="-122"/>
                 <a:cs typeface="Georgia" pitchFamily="18" charset="-120"/>
               </a:rPr>
-              <a:t xml:space="preserve">, </a:t>
+              <a:t>, </a:t>
             </a:r>
             <a:r>
               <a:rPr lang="en-US" sz="1200" kern="0">
@@ -24493,7 +24886,7 @@
                 <a:ea typeface="Georgia" pitchFamily="18" charset="-122"/>
                 <a:cs typeface="Georgia" pitchFamily="18" charset="-120"/>
               </a:rPr>
-              <a:t xml:space="preserve">, </a:t>
+              <a:t>, </a:t>
             </a:r>
             <a:r>
               <a:rPr lang="en-US" sz="1200" kern="0">
@@ -24515,7 +24908,7 @@
                 <a:ea typeface="Georgia" pitchFamily="18" charset="-122"/>
                 <a:cs typeface="Georgia" pitchFamily="18" charset="-120"/>
               </a:rPr>
-              <a:t xml:space="preserve">, </a:t>
+              <a:t>, </a:t>
             </a:r>
             <a:r>
               <a:rPr lang="en-US" sz="1200" kern="0">
@@ -25651,7 +26044,7 @@
               <a:buNone/>
             </a:pPr>
             <a:r>
-              <a:rPr lang="en-US" dirty="0" sz="1200">
+              <a:rPr lang="en-US" sz="1200" dirty="0">
                 <a:solidFill>
                   <a:srgbClr val="F4F1E8"/>
                 </a:solidFill>
@@ -28021,7 +28414,7 @@
               <a:buNone/>
             </a:pPr>
             <a:r>
-              <a:rPr lang="en-US" b="0" dirty="0" sz="1050">
+              <a:rPr lang="en-US" sz="1050" b="0" dirty="0">
                 <a:solidFill>
                   <a:srgbClr val="F4F1E8"/>
                 </a:solidFill>
@@ -28047,7 +28440,7 @@
               <a:buNone/>
             </a:pPr>
             <a:r>
-              <a:rPr lang="en-US" b="0" dirty="0" sz="1050">
+              <a:rPr lang="en-US" sz="1050" b="0" dirty="0">
                 <a:solidFill>
                   <a:srgbClr val="F4F1E8"/>
                 </a:solidFill>
@@ -28055,7 +28448,7 @@
                 <a:ea typeface="Cascadia Mono" pitchFamily="34" charset="-122"/>
                 <a:cs typeface="Cascadia Mono" pitchFamily="34" charset="-120"/>
               </a:rPr>
-              <a:t xml:space="preserve">  if: always()</a:t>
+              <a:t>  if: always()</a:t>
             </a:r>
           </a:p>
           <a:p>
@@ -28072,7 +28465,7 @@
               <a:buNone/>
             </a:pPr>
             <a:r>
-              <a:rPr lang="en-US" b="0" dirty="0" sz="1050">
+              <a:rPr lang="en-US" sz="1050" b="0" dirty="0">
                 <a:solidFill>
                   <a:srgbClr val="F4F1E8"/>
                 </a:solidFill>
@@ -28080,7 +28473,7 @@
                 <a:ea typeface="Cascadia Mono" pitchFamily="34" charset="-122"/>
                 <a:cs typeface="Cascadia Mono" pitchFamily="34" charset="-120"/>
               </a:rPr>
-              <a:t xml:space="preserve">  with:</a:t>
+              <a:t>  with:</a:t>
             </a:r>
           </a:p>
           <a:p>
@@ -28097,7 +28490,7 @@
               <a:buNone/>
             </a:pPr>
             <a:r>
-              <a:rPr lang="en-US" b="0" dirty="0" sz="1050">
+              <a:rPr lang="en-US" sz="1050" b="0" dirty="0">
                 <a:solidFill>
                   <a:srgbClr val="F4F1E8"/>
                 </a:solidFill>
@@ -28105,7 +28498,7 @@
                 <a:ea typeface="Cascadia Mono" pitchFamily="34" charset="-122"/>
                 <a:cs typeface="Cascadia Mono" pitchFamily="34" charset="-120"/>
               </a:rPr>
-              <a:t xml:space="preserve">    name: northstar-execution-report</a:t>
+              <a:t>    name: northstar-execution-report</a:t>
             </a:r>
           </a:p>
           <a:p>
@@ -28122,7 +28515,7 @@
               <a:buNone/>
             </a:pPr>
             <a:r>
-              <a:rPr lang="en-US" b="0" dirty="0" sz="1050">
+              <a:rPr lang="en-US" sz="1050" b="0" dirty="0">
                 <a:solidFill>
                   <a:srgbClr val="F4F1E8"/>
                 </a:solidFill>
@@ -28130,7 +28523,7 @@
                 <a:ea typeface="Cascadia Mono" pitchFamily="34" charset="-122"/>
                 <a:cs typeface="Cascadia Mono" pitchFamily="34" charset="-120"/>
               </a:rPr>
-              <a:t xml:space="preserve">    path: artifacts/report.json</a:t>
+              <a:t>    path: artifacts/report.json</a:t>
             </a:r>
           </a:p>
           <a:p>
@@ -28147,7 +28540,7 @@
               <a:buNone/>
             </a:pPr>
             <a:r>
-              <a:rPr lang="en-US" b="0" dirty="0" sz="1050">
+              <a:rPr lang="en-US" sz="1050" b="0" dirty="0">
                 <a:solidFill>
                   <a:srgbClr val="F4F1E8"/>
                 </a:solidFill>
@@ -28155,7 +28548,7 @@
                 <a:ea typeface="Cascadia Mono" pitchFamily="34" charset="-122"/>
                 <a:cs typeface="Cascadia Mono" pitchFamily="34" charset="-120"/>
               </a:rPr>
-              <a:t xml:space="preserve">    if-no-files-found: error</a:t>
+              <a:t>    if-no-files-found: error</a:t>
             </a:r>
           </a:p>
         </p:txBody>
@@ -34556,7 +34949,7 @@
         </p:spPr>
         <p:txBody>
           <a:bodyPr wrap="square" lIns="0" tIns="0" rIns="0" bIns="0" rtlCol="0" anchor="ctr">
-            <a:normAutofit fontScale="85000" lnSpcReduction="10000"/>
+            <a:normAutofit/>
           </a:bodyPr>
           <a:lstStyle/>
           <a:p>
@@ -34564,7 +34957,7 @@
               <a:buNone/>
             </a:pPr>
             <a:r>
-              <a:rPr lang="en-US" b="1" dirty="0" sz="1450">
+              <a:rPr lang="en-US" sz="1450" b="1" dirty="0">
                 <a:solidFill>
                   <a:srgbClr val="F4F1E8"/>
                 </a:solidFill>
@@ -34581,7 +34974,7 @@
               <a:buNone/>
             </a:pPr>
             <a:r>
-              <a:rPr lang="en-US" b="1" dirty="0" sz="1450">
+              <a:rPr lang="en-US" sz="1450" b="1" dirty="0">
                 <a:solidFill>
                   <a:srgbClr val="F4F1E8"/>
                 </a:solidFill>
@@ -34597,17 +34990,6 @@
             <a:pPr marL="0" indent="0" algn="ctr">
               <a:buNone/>
             </a:pPr>
-            <a:r>
-              <a:rPr lang="en-US" sz="1800" b="1" dirty="0">
-                <a:solidFill>
-                  <a:srgbClr val="F4F1E8"/>
-                </a:solidFill>
-                <a:latin typeface="Georgia" pitchFamily="34" charset="0"/>
-                <a:ea typeface="Georgia" pitchFamily="34" charset="-122"/>
-                <a:cs typeface="Georgia" pitchFamily="34" charset="-120"/>
-              </a:rPr>
-              <a:t/>
-            </a:r>
             <a:endParaRPr lang="en-US" sz="1800" dirty="0"/>
           </a:p>
         </p:txBody>
@@ -34639,7 +35021,7 @@
               <a:buNone/>
             </a:pPr>
             <a:r>
-              <a:rPr lang="en-US" dirty="0" sz="1200">
+              <a:rPr lang="en-US" sz="1200" dirty="0">
                 <a:solidFill>
                   <a:srgbClr val="9AA6DC"/>
                 </a:solidFill>
@@ -34656,7 +35038,7 @@
               <a:buNone/>
             </a:pPr>
             <a:r>
-              <a:rPr lang="en-US" dirty="0" sz="1200">
+              <a:rPr lang="en-US" sz="1200" dirty="0">
                 <a:solidFill>
                   <a:srgbClr val="9AA6DC"/>
                 </a:solidFill>
@@ -34673,7 +35055,7 @@
               <a:buNone/>
             </a:pPr>
             <a:r>
-              <a:rPr lang="en-US" dirty="0" sz="1200">
+              <a:rPr lang="en-US" sz="1200" dirty="0">
                 <a:solidFill>
                   <a:srgbClr val="9AA6DC"/>
                 </a:solidFill>
@@ -34690,7 +35072,7 @@
               <a:buNone/>
             </a:pPr>
             <a:r>
-              <a:rPr lang="en-US" dirty="0" sz="1200">
+              <a:rPr lang="en-US" sz="1200" dirty="0">
                 <a:solidFill>
                   <a:srgbClr val="9AA6DC"/>
                 </a:solidFill>
@@ -42316,7 +42698,7 @@
         </p:spPr>
         <p:txBody>
           <a:bodyPr wrap="square" lIns="0" tIns="0" rIns="0" bIns="0" rtlCol="0" anchor="ctr">
-            <a:normAutofit/>
+            <a:normAutofit fontScale="92500" lnSpcReduction="20000"/>
           </a:bodyPr>
           <a:lstStyle/>
           <a:p>
@@ -42876,7 +43258,7 @@
                 <a:ea typeface="Georgia" pitchFamily="34" charset="-122"/>
                 <a:cs typeface="Georgia" pitchFamily="34" charset="-120"/>
               </a:rPr>
-              <a:t xml:space="preserve">Detect and </a:t>
+              <a:t>Detect and </a:t>
             </a:r>
             <a:r>
               <a:rPr lang="en-US" sz="1400" dirty="0" err="1">
@@ -42898,7 +43280,7 @@
                 <a:ea typeface="Georgia" pitchFamily="34" charset="-122"/>
                 <a:cs typeface="Georgia" pitchFamily="34" charset="-120"/>
               </a:rPr>
-              <a:t xml:space="preserve"> vulnerabilities before they ship</a:t>
+              <a:t> vulnerabilities before they ship</a:t>
             </a:r>
             <a:endParaRPr lang="en-US" sz="1400" dirty="0"/>
           </a:p>
@@ -47096,7 +47478,7 @@
                 <a:ea typeface="Cascadia Mono" pitchFamily="34" charset="-122"/>
                 <a:cs typeface="Cascadia Mono" pitchFamily="34" charset="-120"/>
               </a:rPr>
-              <a:t xml:space="preserve">  order: await this.orders.create(input),</a:t>
+              <a:t>  order: await this.orders.create(input),</a:t>
             </a:r>
             <a:endParaRPr kumimoji="0" lang="en-US" sz="1500" b="0" i="0" u="none" strike="noStrike" kern="1200" cap="none" spc="0" normalizeH="0" baseline="0" noProof="0" dirty="0">
               <a:ln>
@@ -47179,7 +47561,7 @@
                 <a:ea typeface="Cascadia Mono" pitchFamily="34" charset="-122"/>
                 <a:cs typeface="Cascadia Mono" pitchFamily="34" charset="-120"/>
               </a:rPr>
-              <a:t xml:space="preserve">  statusCode: 201,</a:t>
+              <a:t>  statusCode: 201,</a:t>
             </a:r>
             <a:endParaRPr kumimoji="0" lang="en-US" sz="1500" b="0" i="0" u="none" strike="noStrike" kern="1200" cap="none" spc="0" normalizeH="0" baseline="0" noProof="0" dirty="0">
               <a:ln>
@@ -47229,7 +47611,7 @@
                 <a:ea typeface="Cascadia Mono" pitchFamily="34" charset="-122"/>
                 <a:cs typeface="Cascadia Mono" pitchFamily="34" charset="-120"/>
               </a:rPr>
-              <a:t xml:space="preserve">  replayed: false,</a:t>
+              <a:t>  replayed: false,</a:t>
             </a:r>
             <a:endParaRPr kumimoji="0" lang="en-US" sz="1500" b="0" i="0" u="none" strike="noStrike" kern="1200" cap="none" spc="0" normalizeH="0" baseline="0" noProof="0" dirty="0">
               <a:ln>
@@ -48430,7 +48812,7 @@
                 <a:ea typeface="Cascadia Mono" pitchFamily="34" charset="-122"/>
                 <a:cs typeface="Cascadia Mono" pitchFamily="34" charset="-120"/>
               </a:rPr>
-              <a:t xml:space="preserve">  record?.artifact &amp;&amp;</a:t>
+              <a:t>  record?.artifact &amp;&amp;</a:t>
             </a:r>
           </a:p>
           <a:p>
@@ -48455,7 +48837,7 @@
                 <a:ea typeface="Cascadia Mono" pitchFamily="34" charset="-122"/>
                 <a:cs typeface="Cascadia Mono" pitchFamily="34" charset="-120"/>
               </a:rPr>
-              <a:t xml:space="preserve">  record.artifactDigest !== digestPath(record.artifact)</a:t>
+              <a:t>  record.artifactDigest !== digestPath(record.artifact)</a:t>
             </a:r>
           </a:p>
           <a:p>
@@ -48505,7 +48887,7 @@
                 <a:ea typeface="Cascadia Mono" pitchFamily="34" charset="-122"/>
                 <a:cs typeface="Cascadia Mono" pitchFamily="34" charset="-120"/>
               </a:rPr>
-              <a:t xml:space="preserve">  reasons.push("artifact digest mismatch");</a:t>
+              <a:t>  reasons.push("artifact digest mismatch");</a:t>
             </a:r>
           </a:p>
           <a:p>
@@ -48546,17 +48928,14 @@
               </a:spcAft>
               <a:buNone/>
             </a:pPr>
-            <a:r>
-              <a:rPr lang="en-US" sz="1200" b="0" dirty="0">
-                <a:solidFill>
-                  <a:srgbClr val="F4F1E8"/>
-                </a:solidFill>
-                <a:latin typeface="Consolas" pitchFamily="34" charset="0"/>
-                <a:ea typeface="Cascadia Mono" pitchFamily="34" charset="-122"/>
-                <a:cs typeface="Cascadia Mono" pitchFamily="34" charset="-120"/>
-              </a:rPr>
-              <a:t/>
-            </a:r>
+            <a:endParaRPr lang="en-US" sz="1200" b="0" dirty="0">
+              <a:solidFill>
+                <a:srgbClr val="F4F1E8"/>
+              </a:solidFill>
+              <a:latin typeface="Consolas" pitchFamily="34" charset="0"/>
+              <a:ea typeface="Cascadia Mono" pitchFamily="34" charset="-122"/>
+              <a:cs typeface="Cascadia Mono" pitchFamily="34" charset="-120"/>
+            </a:endParaRPr>
           </a:p>
         </p:txBody>
       </p:sp>

</xml_diff>

<commit_message>
docs: reconcile demo-only backlog status
Co-authored-by: Copilot App <223556219+Copilot@users.noreply.github.com>
</commit_message>
<xml_diff>
--- a/From-agents-to-engineering-systems.pptx
+++ b/From-agents-to-engineering-systems.pptx
@@ -2686,17 +2686,18 @@
           </a:p>
           <a:p>
             <a:r>
-              <a:rPr dirty="0"/>
+              <a:rPr lang="en-GB" dirty="0"/>
               <a:t>In the local WI-1843 </a:t>
             </a:r>
             <a:r>
-              <a:rPr dirty="0" err="1"/>
+              <a:rPr lang="en-GB" dirty="0" err="1"/>
               <a:t>worktree</a:t>
             </a:r>
             <a:r>
-              <a:rPr dirty="0"/>
-              <a:t>, open docs/demos/README.md. Show both runbooks and their updated source/evidence table, then compare open PR 18 with draft PRs 19, 27 and 28. Do not claim any scenario has been completed by a VS Code or Copilot cloud agent.</a:t>
-            </a:r>
+              <a:rPr lang="en-GB" dirty="0"/>
+              <a:t>, open docs/demos/README.md. Show the WI-1842 and WI-1843 runbooks, open demo issues #4 and #17, and show draft PR #19. PR #13 was a closed zero-file rehearsal; PRs #18, #27, and #28 are closed unmerged maintenance candidates, and PR #29 was a closed wrong-base/no-change attempt. Do not present closures as acceptance or claim a completed VS Code/cloud-agent demo.</a:t>
+            </a:r>
+            <a:endParaRPr dirty="0"/>
           </a:p>
           <a:p>
             <a:endParaRPr dirty="0"/>
@@ -2755,15 +2756,31 @@
           <a:p>
             <a:r>
               <a:rPr dirty="0"/>
-              <a:t>The audited main baseline remains b65c2de5c8224342c72c37eeed7ef9f965ad8a2c and the framework release remains blocked. PR 18 is at 17e7a5c; hosted acceptance tests pass, but evidence and repository-controls fail. PR 27 is a draft isolation candidate: 500 unit and 10 PostgreSQL acceptance tests pass locally, scope/merge pass, but </a:t>
-            </a:r>
-            <a:r>
-              <a:rPr dirty="0" err="1"/>
+              <a:t>The audited main baseline remains b65c2de5c8224342c72c37eeed7ef9f965ad8a2c and the framework release remains blocked. </a:t>
+            </a:r>
+            <a:r>
+              <a:rPr lang="en-GB" dirty="0"/>
+              <a:t>PR 18 was closed unmerged; hosted acceptance tests had passed, but evidence and repository-controls failed.</a:t>
+            </a:r>
+            <a:r>
+              <a:rPr dirty="0"/>
+              <a:t> </a:t>
+            </a:r>
+            <a:r>
+              <a:rPr lang="en-GB" dirty="0"/>
+              <a:t>PR 27 was closed unmerged by owner scope direction: 500 unit and 10 PostgreSQL acceptance tests and the local scope/merge checks had passed, but full </a:t>
+            </a:r>
+            <a:r>
+              <a:rPr lang="en-GB" dirty="0" err="1"/>
               <a:t>Zizmor</a:t>
             </a:r>
             <a:r>
+              <a:rPr lang="en-GB" dirty="0"/>
+              <a:t> reported 84 findings and hosted evidence/repository-controls failed.</a:t>
+            </a:r>
+            <a:r>
               <a:rPr dirty="0"/>
-              <a:t> reports 84 findings and hosted evidence/repository-controls fail. </a:t>
+              <a:t> </a:t>
             </a:r>
             <a:r>
               <a:rPr lang="en-GB" dirty="0"/>
@@ -2775,7 +2792,7 @@
             </a:r>
             <a:r>
               <a:rPr lang="en-GB" dirty="0"/>
-              <a:t> reports 86 findings and repository-controls fails. PR 28 at 0260fe99 also has exact-head approval and passing human-review/evidence, but repository-controls fails.</a:t>
+              <a:t> reports 86 findings and repository-controls fails. PR 28 was closed unmerged despite its exact-head approval and passing human-review/evidence; repository-controls failed, so trusted acceptance was not established.</a:t>
             </a:r>
             <a:r>
               <a:rPr dirty="0"/>
@@ -3608,20 +3625,25 @@
             </a:r>
             <a:r>
               <a:rPr dirty="0"/>
-              <a:t>. Repository-controls fails and </a:t>
+              <a:t>. </a:t>
             </a:r>
             <a:r>
               <a:rPr lang="en-GB" dirty="0" err="1"/>
-              <a:t>vibeprogrammer</a:t>
+              <a:t>Vibeprogrammer</a:t>
             </a:r>
             <a:r>
               <a:rPr lang="en-GB" dirty="0"/>
-              <a:t> approved the exact head and hosted human-review passes; repository-controls still fails.</a:t>
+              <a:t> approved PR 19's exact head and hosted human-review passes; repository-controls still fails.</a:t>
             </a:r>
             <a:r>
               <a:rPr dirty="0"/>
-              <a:t> PR 19 remains draft.</a:t>
-            </a:r>
+              <a:t> </a:t>
+            </a:r>
+            <a:r>
+              <a:rPr lang="en-GB" dirty="0"/>
+              <a:t>PR #19 remains a draft demo candidate and is unaccepted; its parent PR #18 was closed unmerged as maintenance scope, so no accepted controller repair underpins it.</a:t>
+            </a:r>
+            <a:endParaRPr dirty="0"/>
           </a:p>
           <a:p>
             <a:endParaRPr dirty="0"/>
@@ -3655,7 +3677,7 @@
             </a:r>
             <a:r>
               <a:rPr lang="en-GB" dirty="0"/>
-              <a:t>PR 19's human review is complete. Do not launch a cloud run until the parent controller is accepted and the GitHub.com Agents UI loads with the exact base selectable.</a:t>
+              <a:t>Keep this segment as a local code and test walkthrough; it is not proof of hosted delivery. Do not present a cloud run as ready until a replacement controller repair is accepted and the GitHub.com task UI binds the exact base.</a:t>
             </a:r>
             <a:r>
               <a:rPr dirty="0"/>
@@ -3962,62 +3984,122 @@
           <a:lstStyle/>
           <a:p>
             <a:r>
+              <a:rPr dirty="0"/>
               <a:t>TALK TRACK</a:t>
             </a:r>
           </a:p>
           <a:p>
             <a:r>
+              <a:rPr dirty="0"/>
               <a:t>Instructions express intent; capabilities determine what can actually happen. A prompt may say "do not deploy," but the effective boundary comes from the available tools, identity, permissions, environment and pre-action policy.</a:t>
             </a:r>
           </a:p>
           <a:p>
             <a:r>
-              <a:t>Northstar illustrates this through role-specific agent tools, PreToolUse authorization, issue/plan identity and GitHub checks. The repository files describe those controls; a real host canary and live GitHub policy are still needed to prove enforcement.</a:t>
-            </a:r>
-          </a:p>
-          <a:p>
-            <a:r>
-              <a:t>The audited baseline had a mismatch between its medium-risk combined-mode claim and the unconditional plan approval path. PR 18 is a repair candidate for versioned plans and risk-aware selection, but it remains unaccepted and has not passed a live browser or host canary. Do not present that repair as an established runtime boundary.</a:t>
-            </a:r>
-          </a:p>
-          <a:p>
-            <a:endParaRPr/>
-          </a:p>
-          <a:p>
-            <a:r>
+              <a:rPr dirty="0"/>
+              <a:t>Northstar illustrates this through role-specific agent tools, </a:t>
+            </a:r>
+            <a:r>
+              <a:rPr dirty="0" err="1"/>
+              <a:t>PreToolUse</a:t>
+            </a:r>
+            <a:r>
+              <a:rPr dirty="0"/>
+              <a:t> authorization, issue/plan identity and GitHub checks. The repository files describe those controls; a real host canary and live GitHub policy are still needed to prove enforcement.</a:t>
+            </a:r>
+          </a:p>
+          <a:p>
+            <a:r>
+              <a:rPr lang="en-GB" dirty="0"/>
+              <a:t>The audited baseline had a mismatch between its medium-risk combined-mode claim and unconditional plan approval. PR 18 proposed versioned plans and risk-aware selection, but the owner closed it unmerged as maintenance scope. It remains an unaccepted historical proposal and never passed a live browser or host canary.</a:t>
+            </a:r>
+            <a:r>
+              <a:rPr dirty="0"/>
+              <a:t> Do not present that repair as an established runtime boundary.</a:t>
+            </a:r>
+          </a:p>
+          <a:p>
+            <a:endParaRPr dirty="0"/>
+          </a:p>
+          <a:p>
+            <a:r>
+              <a:rPr dirty="0"/>
               <a:t>DEMO — REPO / VS CODE</a:t>
             </a:r>
           </a:p>
           <a:p>
             <a:r>
-              <a:t>Show AGENTS.md, the planner and implementer tool declarations, .github/hooks/agent-boundary.json, and scripts/authorize-tool.mjs at the audited baseline. Contrast instruction text with executable authorization. Then show PR 18's current candidate as an unaccepted repair, not proof that every VS Code or cloud hook honors the same decision.</a:t>
-            </a:r>
-          </a:p>
-          <a:p>
-            <a:endParaRPr/>
-          </a:p>
-          <a:p>
-            <a:r>
+              <a:rPr dirty="0"/>
+              <a:t>Show AGENTS.md, the planner and implementer tool declarations, .</a:t>
+            </a:r>
+            <a:r>
+              <a:rPr dirty="0" err="1"/>
+              <a:t>github</a:t>
+            </a:r>
+            <a:r>
+              <a:rPr dirty="0"/>
+              <a:t>/hooks/agent-</a:t>
+            </a:r>
+            <a:r>
+              <a:rPr dirty="0" err="1"/>
+              <a:t>boundary.json</a:t>
+            </a:r>
+            <a:r>
+              <a:rPr dirty="0"/>
+              <a:t>, and scripts/authorize-</a:t>
+            </a:r>
+            <a:r>
+              <a:rPr dirty="0" err="1"/>
+              <a:t>tool.mjs</a:t>
+            </a:r>
+            <a:r>
+              <a:rPr dirty="0"/>
+              <a:t> at the audited baseline. Contrast instruction text with executable authorization. </a:t>
+            </a:r>
+            <a:r>
+              <a:rPr lang="en-GB" dirty="0"/>
+              <a:t>If useful, show closed PR 18 only as an unaccepted historical repair, not proof that every VS Code or cloud hook </a:t>
+            </a:r>
+            <a:r>
+              <a:rPr lang="en-GB" dirty="0" err="1"/>
+              <a:t>honors</a:t>
+            </a:r>
+            <a:r>
+              <a:rPr lang="en-GB" dirty="0"/>
+              <a:t> the same decision.</a:t>
+            </a:r>
+            <a:endParaRPr dirty="0"/>
+          </a:p>
+          <a:p>
+            <a:endParaRPr dirty="0"/>
+          </a:p>
+          <a:p>
+            <a:r>
+              <a:rPr dirty="0"/>
               <a:t>DOCUMENTATION LINKS</a:t>
             </a:r>
           </a:p>
           <a:p>
             <a:r>
+              <a:rPr dirty="0"/>
               <a:t>https://github.com/webmaxru/northstar-orders-api-demo/blob/b65c2de5c8224342c72c37eeed7ef9f965ad8a2c/AGENTS.md</a:t>
             </a:r>
           </a:p>
           <a:p>
             <a:r>
+              <a:rPr dirty="0"/>
               <a:t>https://github.com/webmaxru/northstar-orders-api-demo/blob/b65c2de5c8224342c72c37eeed7ef9f965ad8a2c/scripts/authorize-tool.mjs</a:t>
             </a:r>
           </a:p>
           <a:p>
             <a:r>
+              <a:rPr dirty="0"/>
               <a:t>https://github.com/webmaxru/northstar-orders-api-demo/pull/18</a:t>
             </a:r>
           </a:p>
           <a:p>
             <a:r>
+              <a:rPr dirty="0"/>
               <a:t>https://learn.microsoft.com/en-us/training/modules/design-agent-architecture-integration/4-plan-reason-execution</a:t>
             </a:r>
           </a:p>
@@ -4561,9 +4643,10 @@
           </a:p>
           <a:p>
             <a:r>
-              <a:rPr dirty="0"/>
-              <a:t>Show the PR template and a real review event on repair plan PR 15. Explain exactly what that event approved: the repair plan at its specific commit, not every later implementation or a different demo task. Do not merge a PR during this explanatory segment.</a:t>
-            </a:r>
+              <a:rPr lang="en-GB" dirty="0"/>
+              <a:t>Show the PR template and a real review event on now-closed repair plan PR 15. Explain exactly what that event approved: the plan at its specific commit, not the later implementation or a different demo task. PR 15 and its maintenance task were closed unmerged; do not present that review as acceptance. Do not merge a PR during this explanatory segment.</a:t>
+            </a:r>
+            <a:endParaRPr dirty="0"/>
           </a:p>
           <a:p>
             <a:endParaRPr dirty="0"/>
@@ -4704,16 +4787,21 @@
             </a:r>
             <a:r>
               <a:rPr dirty="0"/>
-              <a:t> findings (65 errors, 21 notes); Poutine reports zero findings. The issue #16 candidate has a separate local bundle of 500 unit tests and 10 PostgreSQL acceptance tests, but full validation reports 84 </a:t>
-            </a:r>
-            <a:r>
-              <a:rPr dirty="0" err="1"/>
+              <a:t> findings (65 errors, 21 notes); Poutine reports zero findings. </a:t>
+            </a:r>
+            <a:r>
+              <a:rPr lang="en-GB" dirty="0"/>
+              <a:t>The now-closed issue #16 maintenance candidate had a historical local bundle of 500 unit and 10 PostgreSQL acceptance tests; full validation reported 84 </a:t>
+            </a:r>
+            <a:r>
+              <a:rPr lang="en-GB" dirty="0" err="1"/>
               <a:t>Zizmor</a:t>
             </a:r>
             <a:r>
-              <a:rPr dirty="0"/>
-              <a:t> findings (64 errors, 20 notes). Neither local result implies hosted acceptance.</a:t>
-            </a:r>
+              <a:rPr lang="en-GB" dirty="0"/>
+              <a:t> findings. Those local results do not imply hosted acceptance, and issue #16 is not an active task.</a:t>
+            </a:r>
+            <a:endParaRPr dirty="0"/>
           </a:p>
           <a:p>
             <a:r>
@@ -4752,17 +4840,18 @@
           </a:p>
           <a:p>
             <a:r>
-              <a:rPr dirty="0"/>
-              <a:t>Show the actual local validation output and scanner reports for PR 19 and PR 27. Identify the exact candidate/base before comparing counts. Open the PostgreSQL acceptance result and </a:t>
-            </a:r>
-            <a:r>
-              <a:rPr dirty="0" err="1"/>
+              <a:rPr lang="en-GB" dirty="0"/>
+              <a:t>Show current demo PR 19 and archived maintenance PR 27 results. Identify the exact head/base before comparing counts. Open the PostgreSQL acceptance result and </a:t>
+            </a:r>
+            <a:r>
+              <a:rPr lang="en-GB" dirty="0" err="1"/>
               <a:t>Zizmor</a:t>
             </a:r>
             <a:r>
-              <a:rPr dirty="0"/>
-              <a:t> report. Do not suppress findings or present a green subset as overall acceptance.</a:t>
-            </a:r>
+              <a:rPr lang="en-GB" dirty="0"/>
+              <a:t> report. PR 27 is closed and unaccepted; use its checks only as historical evidence. Do not suppress findings or present a green subset as overall acceptance.</a:t>
+            </a:r>
+            <a:endParaRPr dirty="0"/>
           </a:p>
           <a:p>
             <a:endParaRPr dirty="0"/>
@@ -5190,75 +5279,114 @@
           <a:lstStyle/>
           <a:p>
             <a:r>
+              <a:rPr dirty="0"/>
               <a:t>TALK TRACK</a:t>
             </a:r>
           </a:p>
           <a:p>
             <a:r>
+              <a:rPr dirty="0"/>
               <a:t>There is a subtle point behind parallel agents. Two tasks on one machine are not automatically a problem; two writers sharing one checkout, Git index and mutable artifact directory are.</a:t>
             </a:r>
           </a:p>
           <a:p>
             <a:r>
-              <a:t>The issue #16 candidate adds isolated task worktrees and PostgreSQL schemas. Two read-only CLI canaries in separate worktrees matched the live task, contract, approved plan, base, session and workspace-owner identities. PR 27 passes 500 unit tests, 10 PostgreSQL acceptance tests, scope and merge checks locally. Its full validate:all still fails on 84 Zizmor findings; hosted evidence and repository-controls fail. Cloud attempt PR 29 used main and produced zero changed files, so AC9 cloud isolation remains unproved.</a:t>
-            </a:r>
-          </a:p>
-          <a:p>
-            <a:endParaRPr/>
-          </a:p>
-          <a:p>
-            <a:r>
+              <a:rPr lang="en-GB" dirty="0"/>
+              <a:t>Closed maintenance PR 27 proposed isolated task </a:t>
+            </a:r>
+            <a:r>
+              <a:rPr lang="en-GB" dirty="0" err="1"/>
+              <a:t>worktrees</a:t>
+            </a:r>
+            <a:r>
+              <a:rPr lang="en-GB" dirty="0"/>
+              <a:t> and PostgreSQL schemas, but it was never accepted. Two read-only CLI canaries matched task/contract/plan/base/session/owner identity; they did not prove write authorization, recovery, or cloud isolation. Issue #16 is no longer active.</a:t>
+            </a:r>
+            <a:r>
+              <a:rPr dirty="0"/>
+              <a:t> </a:t>
+            </a:r>
+            <a:r>
+              <a:rPr lang="en-GB" dirty="0"/>
+              <a:t>These are historical checks only: PR 27 was closed unmerged with full validation and hosted gates still failing; PR 29 was closed after a wrong-base/no-change attempt. No cloud isolation or acceptance is established.</a:t>
+            </a:r>
+            <a:endParaRPr dirty="0"/>
+          </a:p>
+          <a:p>
+            <a:endParaRPr dirty="0"/>
+          </a:p>
+          <a:p>
+            <a:r>
+              <a:rPr dirty="0"/>
               <a:t>DEMO — REPO / VS CODE</a:t>
             </a:r>
           </a:p>
           <a:p>
             <a:r>
-              <a:t>Show the separate worktree paths and PR 27. Explain the exact checks covered by the CLI canaries and what they do not cover. Do not run a destructive shared-checkout test in a real task directory. VS Code Local-mode demos remain serial. If attempting cloud later, use the GitHub.com UI and select the exact approved base; stop if the Agents task view cannot load or select it.</a:t>
-            </a:r>
-          </a:p>
-          <a:p>
-            <a:endParaRPr/>
-          </a:p>
-          <a:p>
-            <a:r>
+              <a:rPr lang="en-GB" dirty="0"/>
+              <a:t>Show the separate </a:t>
+            </a:r>
+            <a:r>
+              <a:rPr lang="en-GB" dirty="0" err="1"/>
+              <a:t>worktree</a:t>
+            </a:r>
+            <a:r>
+              <a:rPr lang="en-GB" dirty="0"/>
+              <a:t> paths and closed PR 27 only as historical evidence. Explain what the CLI canaries did and did not prove. Do not run destructive shared-checkout tests. VS Code Local-mode demos remain serial. Issue #16 is closed; do not start another task under it. Any future owner-authorized cloud task must use GitHub.com and an explicitly approved base for its live task.</a:t>
+            </a:r>
+            <a:endParaRPr dirty="0"/>
+          </a:p>
+          <a:p>
+            <a:endParaRPr dirty="0"/>
+          </a:p>
+          <a:p>
+            <a:r>
+              <a:rPr dirty="0"/>
               <a:t>DOCUMENTATION LINKS</a:t>
             </a:r>
           </a:p>
           <a:p>
             <a:r>
+              <a:rPr dirty="0"/>
               <a:t>https://github.com/webmaxru/northstar-orders-api-demo/issues/16</a:t>
             </a:r>
           </a:p>
           <a:p>
             <a:r>
+              <a:rPr dirty="0"/>
               <a:t>https://github.com/webmaxru/northstar-orders-api-demo/pull/27</a:t>
             </a:r>
           </a:p>
           <a:p>
             <a:r>
+              <a:rPr dirty="0"/>
               <a:t>https://github.com/webmaxru/northstar-orders-api-demo/pull/29</a:t>
             </a:r>
           </a:p>
           <a:p>
             <a:r>
+              <a:rPr dirty="0"/>
               <a:t>https://learn.microsoft.com/en-us/training/modules/multi-agent-systems-orchestration/4-execution-isolation-permissions-concurrency</a:t>
             </a:r>
           </a:p>
           <a:p>
             <a:r>
+              <a:rPr dirty="0"/>
               <a:t>https://git-scm.com/docs/git-worktree</a:t>
             </a:r>
           </a:p>
           <a:p>
-            <a:endParaRPr/>
-          </a:p>
-          <a:p>
-            <a:r>
+            <a:endParaRPr dirty="0"/>
+          </a:p>
+          <a:p>
+            <a:r>
+              <a:rPr dirty="0"/>
               <a:t>EVIDENCE BOUNDARY</a:t>
             </a:r>
           </a:p>
           <a:p>
             <a:r>
+              <a:rPr dirty="0"/>
               <a:t>Synthetic concurrency tests and two local CLI identity canaries are not live cloud acceptance. PR 27's AC9 cloud criterion remains unproven; PR 29 is a wrong-base/no-change attempt.</a:t>
             </a:r>
           </a:p>
@@ -5746,47 +5874,56 @@
           <a:lstStyle/>
           <a:p>
             <a:r>
+              <a:rPr dirty="0"/>
               <a:t>TALK TRACK — OPTIONAL, HIDDEN</a:t>
             </a:r>
           </a:p>
           <a:p>
             <a:r>
+              <a:rPr dirty="0"/>
               <a:t>When the same kind of miss keeps returning, I want to improve the system that allowed it: the task contract, context selection, tools, checks or recovery path. A new prompt may be part of that, but it is not the automatic answer to every problem.</a:t>
             </a:r>
           </a:p>
           <a:p>
             <a:r>
+              <a:rPr dirty="0"/>
               <a:t>This slide repeats the practical lesson from the real missing-artifact defect, so it is kept for discussion rather than interrupting the two-demo story.</a:t>
             </a:r>
           </a:p>
           <a:p>
-            <a:endParaRPr/>
-          </a:p>
-          <a:p>
-            <a:r>
+            <a:endParaRPr dirty="0"/>
+          </a:p>
+          <a:p>
+            <a:r>
+              <a:rPr dirty="0"/>
               <a:t>DEMO — REPO / VS CODE</a:t>
             </a:r>
           </a:p>
           <a:p>
             <a:r>
-              <a:t>If needed, return to issue 14 and the specific regression test. Trace one failure to the changed control instead of browsing the entire audit.</a:t>
-            </a:r>
-          </a:p>
-          <a:p>
-            <a:endParaRPr/>
-          </a:p>
-          <a:p>
-            <a:r>
+              <a:rPr lang="en-GB" dirty="0"/>
+              <a:t>If needed, review closed issue #14/PR #18 and the specific regression test as historical maintenance evidence. Trace one failure to the changed control instead of browsing the entire audit; no active maintenance task remains.</a:t>
+            </a:r>
+            <a:endParaRPr dirty="0"/>
+          </a:p>
+          <a:p>
+            <a:endParaRPr dirty="0"/>
+          </a:p>
+          <a:p>
+            <a:r>
+              <a:rPr dirty="0"/>
               <a:t>DOCUMENTATION LINKS</a:t>
             </a:r>
           </a:p>
           <a:p>
             <a:r>
+              <a:rPr dirty="0"/>
               <a:t>https://github.com/webmaxru/northstar-orders-api-demo/issues/14</a:t>
             </a:r>
           </a:p>
           <a:p>
             <a:r>
+              <a:rPr dirty="0"/>
               <a:t>https://learn.microsoft.com/en-us/training/modules/multi-agent-systems-orchestration/</a:t>
             </a:r>
           </a:p>
@@ -6738,12 +6875,8 @@
           </a:p>
           <a:p>
             <a:r>
-              <a:rPr dirty="0"/>
-              <a:t>Show the updated paired runbook evidence table and open PR 18 plus draft PRs 19, 27 and 28. </a:t>
-            </a:r>
-            <a:r>
               <a:rPr lang="en-GB" dirty="0"/>
-              <a:t>Say plainly: PR 19 at cf762216 is aligned to base 17e7a5c; its exact-head review and hosted human-review pass, PostgreSQL acceptance is 12/12, full validation reports 86 </a:t>
+              <a:t>Show open demo issues #4 and #17 and draft PR #19. Show closed maintenance PRs #13, #15, #18, #21, #23, #25, #26, #27, #28 and #29 only as historical records. Say plainly: those closures were scope cancellations, not accepted implementations. PR #19 at cf762216 is aligned to base 17e7a5c; exact-head review, human-review and PostgreSQL 12/12 pass, but full validation reports 86 </a:t>
             </a:r>
             <a:r>
               <a:rPr lang="en-GB" dirty="0" err="1"/>
@@ -6751,15 +6884,15 @@
             </a:r>
             <a:r>
               <a:rPr lang="en-GB" dirty="0"/>
-              <a:t> findings, and repository-controls fails. PR 27 at fc59deef also has exact-head approval and passing human-review; local isolation validation passes, full validation reports 84 </a:t>
-            </a:r>
-            <a:r>
-              <a:rPr lang="en-GB" dirty="0" err="1"/>
-              <a:t>Zizmor</a:t>
+              <a:t> findings and repository-controls fails. No live VS Code or successful cloud-agent run is recorded. Do not show a green status as acceptance.</a:t>
+            </a:r>
+            <a:r>
+              <a:rPr dirty="0"/>
+              <a:t> </a:t>
             </a:r>
             <a:r>
               <a:rPr lang="en-GB" dirty="0"/>
-              <a:t> findings, and hosted evidence/repository-controls fail. PR 28 at 0260fe99 has exact-head approval and passing human-review/evidence, but repository-controls fails. PRs 18, 19, 27 and 28 remain unaccepted. No live VS Code or successful cloud-agent run is recorded. Do not show a green status as acceptance.</a:t>
+              <a:t>Historical note: PR #19's current status and the closure of maintenance PRs are summarized above. Earlier PR #27/#28 checks did not establish hosted acceptance. No maintenance candidate is accepted, and no successful VS Code/cloud-agent run is recorded.</a:t>
             </a:r>
             <a:endParaRPr dirty="0"/>
           </a:p>
@@ -6775,12 +6908,17 @@
           <a:p>
             <a:r>
               <a:rPr lang="en-GB" dirty="0"/>
-              <a:t>Exact-head reviews on PRs 19 and 28 are approved and their hosted human-review checks pass; repository-controls still blocks acceptance.</a:t>
+              <a:t>PR #19's exact-head review and hosted human-review pass, but repository-controls still blocks acceptance. PR #28's exact-head review was approved, but its PR was closed unmerged under maintenance scope and its controls check failed.</a:t>
             </a:r>
             <a:r>
               <a:rPr dirty="0"/>
-              <a:t> For cloud proof, refresh the GitHub.com session after the account-switch warning, open issue 16, and use the GitHub.com Agents UI to start a plan/read-only task on base 17e7a5c only if the task picker loads. The Agents page previously returned “Unable to load tasks”; no new task was launched. PR 29 was a wrong-base/no-change attempt, not successful cloud evidence. Do not use the Copilot app or CLI to start the cloud task. No repository settings or rulesets were changed.</a:t>
-            </a:r>
+              <a:t> </a:t>
+            </a:r>
+            <a:r>
+              <a:rPr lang="en-GB" dirty="0"/>
+              <a:t>The system-maintenance issue #16 is closed; do not start another #16 task. WI-1842 remains a demo task, but its prior plan-only PR #13 was closed after the planner stopped on a missing cached task contract, so no plan was produced. No successful cloud run is recorded. Any future demo cloud run must use GitHub.com (not the Copilot app or CLI), a live demo issue, the read-only plan agent, and the exact base authorized for that task; stop if live task authority or base binding is unavailable. PR #29 was the wrong-base/no-change attempt. No repository settings or rulesets changed.</a:t>
+            </a:r>
+            <a:endParaRPr dirty="0"/>
           </a:p>
           <a:p>
             <a:endParaRPr dirty="0"/>
@@ -6850,25 +6988,18 @@
           </a:p>
           <a:p>
             <a:r>
-              <a:rPr dirty="0"/>
-              <a:t>PR 18 is open and unaccepted; PRs 19, 27 and 28 remain draft/unaccepted. </a:t>
-            </a:r>
-            <a:r>
               <a:rPr lang="en-GB" dirty="0"/>
-              <a:t>PR 19's issue/plan/base identities are reconciled; exact-head review and hosted human-review pass, but repository-controls still blocks acceptance.</a:t>
-            </a:r>
-            <a:r>
-              <a:rPr dirty="0"/>
-              <a:t> PR 27 has passing local identity and database proofs but no accepted hosted evidence or cloud AC9. PR 29 was a wrong-base/no-change attempt. No hosted </a:t>
-            </a:r>
-            <a:r>
-              <a:rPr dirty="0" err="1"/>
+              <a:t>Open demo work is issues #4 and #17; draft demo PR #19 is the only open PR. PR #13 is a closed WI-1842 planner stop; PRs #15, #18, #21, #23, #25, #26, #27, #28 and #29 are closed, unmerged maintenance or failed-attempt records. These closures are scope cancellations, not accepted implementations. PR #19's exact-head review and hosted human-review pass, but repository-controls fails; no hosted </a:t>
+            </a:r>
+            <a:r>
+              <a:rPr lang="en-GB" dirty="0" err="1"/>
               <a:t>ready_for_acceptance</a:t>
             </a:r>
             <a:r>
-              <a:rPr dirty="0"/>
-              <a:t> or live VS Code/successful cloud-agent delivery is recorded.</a:t>
-            </a:r>
+              <a:rPr lang="en-GB" dirty="0"/>
+              <a:t> or successful VS Code/cloud delivery is recorded.</a:t>
+            </a:r>
+            <a:endParaRPr dirty="0"/>
           </a:p>
         </p:txBody>
       </p:sp>
@@ -7314,37 +7445,26 @@
           </a:p>
           <a:p>
             <a:r>
-              <a:rPr dirty="0"/>
-              <a:t>Here is the distinction I want to make visible: a repaired implementation candidate can pass application or acceptance tests without becoming an accepted release. PR 18 at 17e7a5c5 passes its hosted acceptance tests, but evidence and repository-controls are still blocked. PR 27 adds task/workspace and PostgreSQL isolation. Its local validate and acceptance tests pass, but full </a:t>
-            </a:r>
-            <a:r>
-              <a:rPr dirty="0" err="1"/>
+              <a:rPr lang="en-GB" dirty="0"/>
+              <a:t>Here is the distinction I want to make visible: a repaired implementation can pass application tests without becoming an accepted release. PR 18 is closed unmerged: hosted acceptance tests passed, but evidence and repository-controls failed. PR 27 is also closed unmerged. Its local validation passed 500 unit and 10 PostgreSQL acceptance tests, scope/merge passed, but full </a:t>
+            </a:r>
+            <a:r>
+              <a:rPr lang="en-GB" dirty="0" err="1"/>
               <a:t>validate:all</a:t>
             </a:r>
             <a:r>
-              <a:rPr dirty="0"/>
-              <a:t> reports 84 </a:t>
-            </a:r>
-            <a:r>
-              <a:rPr dirty="0" err="1"/>
+              <a:rPr lang="en-GB" dirty="0"/>
+              <a:t> reported 84 </a:t>
+            </a:r>
+            <a:r>
+              <a:rPr lang="en-GB" dirty="0" err="1"/>
               <a:t>Zizmor</a:t>
             </a:r>
             <a:r>
-              <a:rPr dirty="0"/>
-              <a:t> findings and its hosted evidence/control checks fail. </a:t>
-            </a:r>
-            <a:r>
-              <a:rPr lang="en-GB" dirty="0" err="1"/>
-              <a:t>Vibeprogrammer</a:t>
-            </a:r>
-            <a:r>
               <a:rPr lang="en-GB" dirty="0"/>
-              <a:t> approved PR 27's exact head; it remains draft because hosted evidence and repository-controls fail.</a:t>
-            </a:r>
-            <a:r>
-              <a:rPr dirty="0"/>
-              <a:t> I will not merge those facts into one green status.</a:t>
-            </a:r>
+              <a:t> findings and hosted evidence/repository-controls failed. Neither closure converted these results into acceptance. I will not merge those facts into one green status.</a:t>
+            </a:r>
+            <a:endParaRPr dirty="0"/>
           </a:p>
           <a:p>
             <a:endParaRPr dirty="0"/>
@@ -7357,17 +7477,18 @@
           </a:p>
           <a:p>
             <a:r>
-              <a:rPr dirty="0"/>
-              <a:t>Open PR 18 and show its current governed validation result. Then open PR 27 and distinguish local validation, the two read-only CLI identity canaries, and the still-blocked hosted checks. Keep scanner findings visible: Poutine reports zero findings, while </a:t>
-            </a:r>
-            <a:r>
-              <a:rPr dirty="0" err="1"/>
+              <a:rPr lang="en-GB" dirty="0"/>
+              <a:t>Show the closed PR 18 and PR 27 pages only as historical examples. Their local tests did not clear the failed hosted evidence and repository-controls gates; PR 27's two read-only CLI canaries proved identity binding only. Keep scanner findings visible: Poutine reports zero findings, while </a:t>
+            </a:r>
+            <a:r>
+              <a:rPr lang="en-GB" dirty="0" err="1"/>
               <a:t>Zizmor</a:t>
             </a:r>
             <a:r>
-              <a:rPr dirty="0"/>
-              <a:t> reports 84. The displayed code is the exact historical missing-artifact check from the audited baseline; it ends after the closing brace, before the report object. Do not claim either candidate is hosted acceptance.</a:t>
-            </a:r>
+              <a:rPr lang="en-GB" dirty="0"/>
+              <a:t> reported 84 on PR 27. The displayed code is the historical missing-artifact check from the audited baseline; it ends after the closing brace, before the report object. Do not present either closure as acceptance.</a:t>
+            </a:r>
+            <a:endParaRPr dirty="0"/>
           </a:p>
           <a:p>
             <a:endParaRPr dirty="0"/>
@@ -7419,25 +7540,26 @@
           </a:p>
           <a:p>
             <a:r>
-              <a:rPr dirty="0"/>
-              <a:t>PR 18 head 17e7a5c has passing hosted acceptance tests but fails evidence and repository-controls. PR 27 head fc59deef passes 500 unit tests, 10 PostgreSQL acceptance tests, scope and merge checks locally; its full validation reports 84 </a:t>
-            </a:r>
-            <a:r>
-              <a:rPr dirty="0" err="1"/>
+              <a:rPr lang="en-GB" dirty="0"/>
+              <a:t>PR 18 was closed unmerged; its head 17e7a5c passed hosted acceptance tests but failed evidence and repository-controls. Closed PR 27 head fc59deef passed 500 unit tests, 10 PostgreSQL acceptance tests, scope and merge checks locally, but its full validation reported 84 </a:t>
+            </a:r>
+            <a:r>
+              <a:rPr lang="en-GB" dirty="0" err="1"/>
               <a:t>Zizmor</a:t>
             </a:r>
             <a:r>
-              <a:rPr dirty="0"/>
-              <a:t> findings (64 errors, 20 notes). Two read-only CLI identity canaries pass only for task/contract/plan/base/session/owner binding. No live VS Code or successful cloud run is recorded; PR 29 used the wrong base and produced zero changes. No hosted </a:t>
-            </a:r>
-            <a:r>
-              <a:rPr dirty="0" err="1"/>
+              <a:rPr lang="en-GB" dirty="0"/>
+              <a:t> findings. Two read-only CLI identity canaries proved only task/contract/plan/base/session/owner binding. No live VS Code or successful cloud run is recorded; PR 29 used the wrong base and produced zero changes. No hosted </a:t>
+            </a:r>
+            <a:r>
+              <a:rPr lang="en-GB" dirty="0" err="1"/>
               <a:t>ready_for_acceptance</a:t>
             </a:r>
             <a:r>
-              <a:rPr dirty="0"/>
+              <a:rPr lang="en-GB" dirty="0"/>
               <a:t> is recorded.</a:t>
             </a:r>
+            <a:endParaRPr dirty="0"/>
           </a:p>
         </p:txBody>
       </p:sp>
@@ -31654,7 +31776,7 @@
               <a:buNone/>
             </a:pPr>
             <a:r>
-              <a:rPr lang="en-US" sz="1150" b="1" dirty="0">
+              <a:rPr lang="en-GB" sz="1150" b="1" dirty="0">
                 <a:solidFill>
                   <a:srgbClr val="F4F1E8"/>
                 </a:solidFill>
@@ -31662,7 +31784,7 @@
                 <a:ea typeface="Cascadia Mono" pitchFamily="34" charset="-122"/>
                 <a:cs typeface="Cascadia Mono" pitchFamily="34" charset="-120"/>
               </a:rPr>
-              <a:t>CLI CANARIES PASS; PR 27 DRAFT; CLOUD AC9 UNPROVED.</a:t>
+              <a:t>CLI ID ONLY; PR 27 CLOSED; CLOUD AC9 UNPROVED.</a:t>
             </a:r>
             <a:endParaRPr lang="en-US" sz="1150" dirty="0"/>
           </a:p>
@@ -48557,7 +48679,7 @@
               <a:buNone/>
             </a:pPr>
             <a:r>
-              <a:rPr lang="en-US" sz="1400" dirty="0">
+              <a:rPr lang="en-GB" sz="1400" dirty="0">
                 <a:solidFill>
                   <a:srgbClr val="F4F1E8"/>
                 </a:solidFill>
@@ -48565,7 +48687,7 @@
                 <a:ea typeface="Cascadia Mono" pitchFamily="34" charset="-122"/>
                 <a:cs typeface="Cascadia Mono" pitchFamily="34" charset="-120"/>
               </a:rPr>
-              <a:t>PR 18 head 17e7a5c5 (open)</a:t>
+              <a:t>PR 18 head 17e7a5c5 (closed)</a:t>
             </a:r>
             <a:endParaRPr lang="en-US" sz="1450" dirty="0"/>
           </a:p>

</xml_diff>

<commit_message>
docs: refresh Northstar candidate evidence and deck
Refresh the inert control-plane snapshot from validated Northstar candidate bfb2cbf while keeping release status known-defective and architecture conformance blocked. Reconcile conformance, extension, surface, and demo records with current hosted and local evidence; correct stale PowerPoint status claims and verify code excerpts against immutable reference revisions.

Co-authored-by: Copilot App <223556219+Copilot@users.noreply.github.com
</commit_message>
<xml_diff>
--- a/From-agents-to-engineering-systems.pptx
+++ b/From-agents-to-engineering-systems.pptx
@@ -2659,152 +2659,75 @@
           <a:lstStyle/>
           <a:p>
             <a:r>
-              <a:rPr dirty="0"/>
               <a:t>TALK TRACK</a:t>
             </a:r>
           </a:p>
           <a:p>
             <a:r>
-              <a:rPr dirty="0"/>
               <a:t>I call this my AI Engineering System. I started with the Microsoft Learn material and wanted to turn its principles into something we can inspect in a repository. The question is not just whether an agent can write code. It is how we define the work, limit the next action, and decide what may ship.</a:t>
             </a:r>
           </a:p>
           <a:p>
             <a:r>
-              <a:rPr dirty="0"/>
-              <a:t>We will compare plan-first idempotency with a plan + execution endpoint. Same plan -&gt; act -&gt; evaluate system, different timing of human validation. I will keep application behavior, local tests, hosted policy, and live agent evidence distinct.</a:t>
-            </a:r>
-          </a:p>
-          <a:p>
-            <a:endParaRPr dirty="0"/>
-          </a:p>
-          <a:p>
-            <a:r>
-              <a:rPr dirty="0"/>
+              <a:t>We will compare plan-first idempotency with a plan + execution endpoint. Same plan → act → evaluate system, different timing of human validation. I will keep application behavior, local tests, hosted policy, and live agent evidence distinct.</a:t>
+            </a:r>
+          </a:p>
+          <a:p/>
+          <a:p>
+            <a:r>
               <a:t>DEMO — REPO / VS CODE</a:t>
             </a:r>
           </a:p>
           <a:p>
             <a:r>
-              <a:rPr lang="en-GB" dirty="0"/>
-              <a:t>In the local WI-1843 </a:t>
-            </a:r>
-            <a:r>
-              <a:rPr lang="en-GB" dirty="0" err="1"/>
-              <a:t>worktree</a:t>
-            </a:r>
-            <a:r>
-              <a:rPr lang="en-GB" dirty="0"/>
-              <a:t>, open docs/demos/README.md. Show the WI-1842 and WI-1843 runbooks, open demo issues #4 and #17, and show draft PR #19. PR #13 was a closed zero-file rehearsal; PRs #18, #27, and #28 are closed unmerged maintenance candidates, and PR #29 was a closed wrong-base/no-change attempt. Do not present closures as acceptance or claim a completed VS Code/cloud-agent demo.</a:t>
-            </a:r>
-            <a:endParaRPr dirty="0"/>
-          </a:p>
-          <a:p>
-            <a:endParaRPr dirty="0"/>
-          </a:p>
-          <a:p>
-            <a:r>
-              <a:rPr dirty="0"/>
+              <a:t>Open the WI-1843 task worktree at PR #19 head `cf762216` and verify `docs/demos/README.md` there. Show the WI-1842 and WI-1843 runbooks and open issues #4 and #17. PR #13 and PR #29 are closed historical attempts; PRs #15, #18, #21, #23, #25, #26, #27, and #28 are open maintenance items. PR #27 and #28 are draft implementations; none is accepted. Do not present an open PR or approved plan as implementation acceptance.</a:t>
+            </a:r>
+          </a:p>
+          <a:p/>
+          <a:p>
+            <a:r>
               <a:t>DOCUMENTATION LINKS</a:t>
             </a:r>
           </a:p>
           <a:p>
             <a:r>
-              <a:rPr dirty="0"/>
               <a:t>https://github.com/webmaxru/ai-engineering-system</a:t>
             </a:r>
           </a:p>
           <a:p>
             <a:r>
-              <a:rPr dirty="0"/>
               <a:t>https://github.com/webmaxru/northstar-orders-api-demo</a:t>
             </a:r>
           </a:p>
           <a:p>
             <a:r>
-              <a:rPr dirty="0"/>
               <a:t>https://github.com/webmaxru/northstar-orders-api-demo/pull/18</a:t>
             </a:r>
           </a:p>
           <a:p>
             <a:r>
-              <a:rPr dirty="0"/>
               <a:t>https://github.com/webmaxru/northstar-orders-api-demo/pull/19</a:t>
             </a:r>
           </a:p>
           <a:p>
             <a:r>
-              <a:rPr dirty="0"/>
               <a:t>https://github.com/webmaxru/northstar-orders-api-demo/pull/27</a:t>
             </a:r>
           </a:p>
           <a:p>
             <a:r>
-              <a:rPr dirty="0"/>
               <a:t>https://learn.microsoft.com/en-us/training/modules/design-agent-architecture-integration/4-plan-reason-execution</a:t>
             </a:r>
           </a:p>
-          <a:p>
-            <a:endParaRPr dirty="0"/>
-          </a:p>
-          <a:p>
-            <a:r>
-              <a:rPr dirty="0"/>
+          <a:p/>
+          <a:p>
+            <a:r>
               <a:t>EVIDENCE BOUNDARY</a:t>
             </a:r>
           </a:p>
           <a:p>
             <a:r>
-              <a:rPr dirty="0"/>
-              <a:t>The audited main baseline remains b65c2de5c8224342c72c37eeed7ef9f965ad8a2c and the framework release remains blocked. </a:t>
-            </a:r>
-            <a:r>
-              <a:rPr lang="en-GB" dirty="0"/>
-              <a:t>PR 18 was closed unmerged; hosted acceptance tests had passed, but evidence and repository-controls failed.</a:t>
-            </a:r>
-            <a:r>
-              <a:rPr dirty="0"/>
-              <a:t> </a:t>
-            </a:r>
-            <a:r>
-              <a:rPr lang="en-GB" dirty="0"/>
-              <a:t>PR 27 was closed unmerged by owner scope direction: 500 unit and 10 PostgreSQL acceptance tests and the local scope/merge checks had passed, but full </a:t>
-            </a:r>
-            <a:r>
-              <a:rPr lang="en-GB" dirty="0" err="1"/>
-              <a:t>Zizmor</a:t>
-            </a:r>
-            <a:r>
-              <a:rPr lang="en-GB" dirty="0"/>
-              <a:t> reported 84 findings and hosted evidence/repository-controls failed.</a:t>
-            </a:r>
-            <a:r>
-              <a:rPr dirty="0"/>
-              <a:t> </a:t>
-            </a:r>
-            <a:r>
-              <a:rPr lang="en-GB" dirty="0"/>
-              <a:t>PR 19 at cf762216 is aligned to base 17e7a5c; its exact-head review and human-review pass, and PostgreSQL acceptance is 12/12. Full </a:t>
-            </a:r>
-            <a:r>
-              <a:rPr lang="en-GB" dirty="0" err="1"/>
-              <a:t>Zizmor</a:t>
-            </a:r>
-            <a:r>
-              <a:rPr lang="en-GB" dirty="0"/>
-              <a:t> reports 86 findings and repository-controls fails. PR 28 was closed unmerged despite its exact-head approval and passing human-review/evidence; repository-controls failed, so trusted acceptance was not established.</a:t>
-            </a:r>
-            <a:r>
-              <a:rPr dirty="0"/>
-              <a:t> PR 29 used main and produced zero changes. No live VS Code or successful cloud agent run is recorded; do not claim hosted </a:t>
-            </a:r>
-            <a:r>
-              <a:rPr dirty="0" err="1"/>
-              <a:t>ready_for_acceptance</a:t>
-            </a:r>
-            <a:r>
-              <a:rPr dirty="0"/>
-              <a:t>.</a:t>
+              <a:t>Northstar main remains the known-defective baseline `b65c2de…`; the inert framework snapshot tracks validated candidate `bfb2cbf…` but remains `known-defective`, and conformance remains blocked. PR #18 is open at `2ce3cf8…`, unmerged and unaccepted; its local validation passed 489 unit/9 PostgreSQL tests, but hosted human-review, controls, and final trusted acceptance remain unresolved and AC15 is unverified. PR #19 is open/draft at `cf762216`, based on older `17e7a5c…`; its local 470 unit/12 PostgreSQL tests and human-review pass, but Zizmor reports 86 findings and repository-controls fails. PR #27 is open/draft at `bfb2cbf…`; local validation passes 528 unit/10 PostgreSQL tests, while `validate:all` fails on 83 Zizmor findings. Hosted run `36705616895` passes plan, scope, quality, acceptance, CodeQL, dependency, secret, merge, and governance checks, but controls, human-review, and evidence fail; AC9 is unproven. PR #28 remains open/draft and unaccepted. PR #13 and #29 are closed; #29 used `main` and made no source changes. Cloud canary PR #30 stopped because the task-contract artifact was absent; no live VS Code or successful cloud delivery is established.</a:t>
             </a:r>
           </a:p>
         </p:txBody>
@@ -3588,180 +3511,60 @@
           <a:lstStyle/>
           <a:p>
             <a:r>
-              <a:rPr dirty="0"/>
               <a:t>TALK TRACK</a:t>
             </a:r>
           </a:p>
           <a:p>
             <a:r>
-              <a:rPr dirty="0"/>
-              <a:t>Now the second story: GET /orders/:id. The read is bounded and uses the existing order data/storage boundary. The issue and machine plan now bind to parent 17e7a5c; the endpoint branch has been rebased to that exact parent. Local validate passes 470 unit tests and 79 governance checks; PostgreSQL acceptance passes 12/12 across processes and writer restart; scope and merge checks pass. The full </a:t>
-            </a:r>
-            <a:r>
-              <a:rPr dirty="0" err="1"/>
-              <a:t>validate:all</a:t>
-            </a:r>
-            <a:r>
-              <a:rPr dirty="0"/>
-              <a:t> run still exits 1 at </a:t>
-            </a:r>
-            <a:r>
-              <a:rPr dirty="0" err="1"/>
-              <a:t>Zizmor</a:t>
-            </a:r>
-            <a:r>
-              <a:rPr dirty="0"/>
-              <a:t> with 86 findings (65 errors, 21 notes), while Poutine reports zero findings. That is real local application evidence, not an accepted cloud delivery.</a:t>
-            </a:r>
-          </a:p>
-          <a:p>
-            <a:r>
-              <a:rPr dirty="0"/>
-              <a:t>The refreshed PR 19 checks pass plan-contract, scope, acceptance, quality, dependency review, secret scan, merge-validation, and </a:t>
-            </a:r>
-            <a:r>
-              <a:rPr dirty="0" err="1"/>
-              <a:t>CodeQL</a:t>
-            </a:r>
-            <a:r>
-              <a:rPr dirty="0"/>
-              <a:t>. </a:t>
-            </a:r>
-            <a:r>
-              <a:rPr lang="en-GB" dirty="0" err="1"/>
-              <a:t>Vibeprogrammer</a:t>
-            </a:r>
-            <a:r>
-              <a:rPr lang="en-GB" dirty="0"/>
-              <a:t> approved PR 19's exact head and hosted human-review passes; repository-controls still fails.</a:t>
-            </a:r>
-            <a:r>
-              <a:rPr dirty="0"/>
-              <a:t> </a:t>
-            </a:r>
-            <a:r>
-              <a:rPr lang="en-GB" dirty="0"/>
-              <a:t>PR #19 remains a draft demo candidate and is unaccepted; its parent PR #18 was closed unmerged as maintenance scope, so no accepted controller repair underpins it.</a:t>
-            </a:r>
-            <a:endParaRPr dirty="0"/>
-          </a:p>
-          <a:p>
-            <a:endParaRPr dirty="0"/>
-          </a:p>
-          <a:p>
-            <a:r>
-              <a:rPr dirty="0"/>
+              <a:t>Now the second story: GET /orders/:id. The read is bounded and uses the existing order data/storage boundary. Issue #17 and PR #19 both bind to base `17e7a5c…`, but that base is older than current PR #18 head `2ce3cf8…`; show the candidate as aligned to its own task/plan, not as a current stacked child of the latest controller. PR #19 at `cf762216` passes local validation (470 unit tests, 12 PostgreSQL acceptance tests, scope/merge) and hosted human-review. Full `validate:all` reports 86 Zizmor findings and repository-controls fails, so it is not accepted. Do not imply hosted delivery.</a:t>
+            </a:r>
+          </a:p>
+          <a:p/>
+          <a:p>
+            <a:r>
               <a:t>DEMO — REPO / VS CODE</a:t>
             </a:r>
           </a:p>
           <a:p>
             <a:r>
-              <a:rPr dirty="0"/>
-              <a:t>Follow docs/demos/plan-execute-order-lookup.md. Open src/</a:t>
-            </a:r>
-            <a:r>
-              <a:rPr dirty="0" err="1"/>
-              <a:t>app.ts</a:t>
-            </a:r>
-            <a:r>
-              <a:rPr dirty="0"/>
-              <a:t>, both </a:t>
-            </a:r>
-            <a:r>
-              <a:rPr dirty="0" err="1"/>
-              <a:t>getOrder</a:t>
-            </a:r>
-            <a:r>
-              <a:rPr dirty="0"/>
-              <a:t> implementations, and the focused tests. Show the parameterized SELECT and unchanged POST behavior. The endpoint's 17.11 PostgreSQL service was disposable and has been stopped after the 12/12 run. </a:t>
-            </a:r>
-            <a:r>
-              <a:rPr lang="en-GB" dirty="0"/>
-              <a:t>Keep this segment as a local code and test walkthrough; it is not proof of hosted delivery. Do not present a cloud run as ready until a replacement controller repair is accepted and the GitHub.com task UI binds the exact base.</a:t>
-            </a:r>
-            <a:r>
-              <a:rPr dirty="0"/>
-              <a:t> Use the GitHub.com UI only for cloud tasks; do not initiate them from the Copilot app or CLI.</a:t>
-            </a:r>
-          </a:p>
-          <a:p>
-            <a:endParaRPr dirty="0"/>
-          </a:p>
-          <a:p>
-            <a:r>
-              <a:rPr dirty="0"/>
+              <a:t>Follow `docs/demos/plan-execute-order-lookup.md` from PR #19 head `cf762216` (the runbook is present there). Open `src/app.ts`, both `getOrder` implementations, and the focused tests. Show the parameterized SELECT and unchanged POST behavior. The PostgreSQL 17.11 service used for 12/12 acceptance was disposable and has been stopped. Keep this a local code/test walkthrough; it is not proof of hosted delivery. Do not start a cloud run until the base and task authority can be bound; the current Issue #16 cloud canary stopped on a missing contract artifact.</a:t>
+            </a:r>
+          </a:p>
+          <a:p/>
+          <a:p>
+            <a:r>
               <a:t>DOCUMENTATION LINKS</a:t>
             </a:r>
           </a:p>
           <a:p>
             <a:r>
-              <a:rPr dirty="0"/>
               <a:t>https://github.com/webmaxru/northstar-orders-api-demo/issues/17</a:t>
             </a:r>
           </a:p>
           <a:p>
             <a:r>
-              <a:rPr dirty="0"/>
               <a:t>https://github.com/webmaxru/northstar-orders-api-demo/pull/19</a:t>
             </a:r>
           </a:p>
           <a:p>
             <a:r>
-              <a:rPr dirty="0"/>
               <a:t>https://learn.microsoft.com/en-us/training/modules/design-agent-architecture-integration/4-plan-reason-execution</a:t>
             </a:r>
           </a:p>
           <a:p>
             <a:r>
-              <a:rPr dirty="0"/>
               <a:t>https://code.visualstudio.com/docs/copilot/chat/chat-agent-mode</a:t>
             </a:r>
           </a:p>
-          <a:p>
-            <a:endParaRPr dirty="0"/>
-          </a:p>
-          <a:p>
-            <a:r>
-              <a:rPr dirty="0"/>
+          <a:p/>
+          <a:p>
+            <a:r>
               <a:t>EVIDENCE BOUNDARY</a:t>
             </a:r>
           </a:p>
           <a:p>
             <a:r>
-              <a:rPr dirty="0"/>
-              <a:t>PostgreSQL acceptance passed 12/12 on the source tree committed to PR 19 head cf762216. The local run used an isolated PostgreSQL 17.11 container on 127.0.0.1:55433; that container is stopped. Local validate passed 470 unit tests and 79 governance checks; scope and merge checks pass. Full </a:t>
-            </a:r>
-            <a:r>
-              <a:rPr dirty="0" err="1"/>
-              <a:t>validate:all</a:t>
-            </a:r>
-            <a:r>
-              <a:rPr dirty="0"/>
-              <a:t> exits 1 on 86 </a:t>
-            </a:r>
-            <a:r>
-              <a:rPr dirty="0" err="1"/>
-              <a:t>Zizmor</a:t>
-            </a:r>
-            <a:r>
-              <a:rPr dirty="0"/>
-              <a:t> findings. On the latest hosted run, plan-contract, scope, acceptance, quality, dependency review, secret scan, </a:t>
-            </a:r>
-            <a:r>
-              <a:rPr dirty="0" err="1"/>
-              <a:t>CodeQL</a:t>
-            </a:r>
-            <a:r>
-              <a:rPr dirty="0"/>
-              <a:t> and evidence pass; </a:t>
-            </a:r>
-            <a:r>
-              <a:rPr lang="en-GB" dirty="0"/>
-              <a:t>repository-controls fails; exact-head review and human-review pass, but hosted acceptance is not established.</a:t>
-            </a:r>
-            <a:r>
-              <a:rPr dirty="0"/>
-              <a:t> No VS Code/cloud delivery or hosted acceptance is proved.</a:t>
+              <a:t>PostgreSQL acceptance passed 12/12 on PR #19 head `cf762216`. Local validation passed 470 unit tests and 79 governance checks; scope/merge checks passed. Full `validate:all` exits 1 on 86 Zizmor findings. Hosted human-review passes, but repository-controls fails; no hosted acceptance is established. PR #19 remains open/draft and is based on `17e7a5c…`, behind current PR #18 head `2ce3cf8…`. No VS Code/cloud delivery is proved.</a:t>
             </a:r>
           </a:p>
         </p:txBody>
@@ -3984,122 +3787,58 @@
           <a:lstStyle/>
           <a:p>
             <a:r>
-              <a:rPr dirty="0"/>
               <a:t>TALK TRACK</a:t>
             </a:r>
           </a:p>
           <a:p>
             <a:r>
-              <a:rPr dirty="0"/>
-              <a:t>Instructions express intent; capabilities determine what can actually happen. A prompt may say "do not deploy," but the effective boundary comes from the available tools, identity, permissions, environment and pre-action policy.</a:t>
-            </a:r>
-          </a:p>
-          <a:p>
-            <a:r>
-              <a:rPr dirty="0"/>
-              <a:t>Northstar illustrates this through role-specific agent tools, </a:t>
-            </a:r>
-            <a:r>
-              <a:rPr dirty="0" err="1"/>
-              <a:t>PreToolUse</a:t>
-            </a:r>
-            <a:r>
-              <a:rPr dirty="0"/>
-              <a:t> authorization, issue/plan identity and GitHub checks. The repository files describe those controls; a real host canary and live GitHub policy are still needed to prove enforcement.</a:t>
-            </a:r>
-          </a:p>
-          <a:p>
-            <a:r>
-              <a:rPr lang="en-GB" dirty="0"/>
-              <a:t>The audited baseline had a mismatch between its medium-risk combined-mode claim and unconditional plan approval. PR 18 proposed versioned plans and risk-aware selection, but the owner closed it unmerged as maintenance scope. It remains an unaccepted historical proposal and never passed a live browser or host canary.</a:t>
-            </a:r>
-            <a:r>
-              <a:rPr dirty="0"/>
-              <a:t> Do not present that repair as an established runtime boundary.</a:t>
-            </a:r>
-          </a:p>
-          <a:p>
-            <a:endParaRPr dirty="0"/>
-          </a:p>
-          <a:p>
-            <a:r>
-              <a:rPr dirty="0"/>
+              <a:t>Instructions express intent; capabilities determine what can actually happen. A prompt may say “do not deploy,” but the effective boundary comes from available tools, identity, permissions, environment, and pre-action policy.</a:t>
+            </a:r>
+          </a:p>
+          <a:p>
+            <a:r>
+              <a:t>Northstar illustrates this through role-specific agent tools, PreToolUse authorization, issue/plan identity, and GitHub checks. Repository files describe those controls; a real host canary and live GitHub policy are still needed to prove enforcement.</a:t>
+            </a:r>
+          </a:p>
+          <a:p>
+            <a:r>
+              <a:t>The audited baseline had a mismatch between its medium-risk combined-mode claim and unconditional plan approval. PR #18 is now open at `2ce3cf8…` with a risk-aware repair candidate, but remains unmerged and unaccepted; the hosted review, controls, and trusted-acceptance gates are still incomplete. Do not present the repair as an established runtime boundary.</a:t>
+            </a:r>
+          </a:p>
+          <a:p/>
+          <a:p>
+            <a:r>
               <a:t>DEMO — REPO / VS CODE</a:t>
             </a:r>
           </a:p>
           <a:p>
             <a:r>
-              <a:rPr dirty="0"/>
-              <a:t>Show AGENTS.md, the planner and implementer tool declarations, .</a:t>
-            </a:r>
-            <a:r>
-              <a:rPr dirty="0" err="1"/>
-              <a:t>github</a:t>
-            </a:r>
-            <a:r>
-              <a:rPr dirty="0"/>
-              <a:t>/hooks/agent-</a:t>
-            </a:r>
-            <a:r>
-              <a:rPr dirty="0" err="1"/>
-              <a:t>boundary.json</a:t>
-            </a:r>
-            <a:r>
-              <a:rPr dirty="0"/>
-              <a:t>, and scripts/authorize-</a:t>
-            </a:r>
-            <a:r>
-              <a:rPr dirty="0" err="1"/>
-              <a:t>tool.mjs</a:t>
-            </a:r>
-            <a:r>
-              <a:rPr dirty="0"/>
-              <a:t> at the audited baseline. Contrast instruction text with executable authorization. </a:t>
-            </a:r>
-            <a:r>
-              <a:rPr lang="en-GB" dirty="0"/>
-              <a:t>If useful, show closed PR 18 only as an unaccepted historical repair, not proof that every VS Code or cloud hook </a:t>
-            </a:r>
-            <a:r>
-              <a:rPr lang="en-GB" dirty="0" err="1"/>
-              <a:t>honors</a:t>
-            </a:r>
-            <a:r>
-              <a:rPr lang="en-GB" dirty="0"/>
-              <a:t> the same decision.</a:t>
-            </a:r>
-            <a:endParaRPr dirty="0"/>
-          </a:p>
-          <a:p>
-            <a:endParaRPr dirty="0"/>
-          </a:p>
-          <a:p>
-            <a:r>
-              <a:rPr dirty="0"/>
+              <a:t>Show AGENTS.md, the planner/implementer tool declarations, `.github/hooks/agent-boundary.json`, and `scripts/authorize-tool.mjs` at the audited baseline. Contrast instruction text with executable authorization. If useful, compare open PR #18 as an unaccepted candidate; it does not prove every VS Code or cloud hook honors the same decision.</a:t>
+            </a:r>
+          </a:p>
+          <a:p/>
+          <a:p>
+            <a:r>
               <a:t>DOCUMENTATION LINKS</a:t>
             </a:r>
           </a:p>
           <a:p>
             <a:r>
-              <a:rPr dirty="0"/>
               <a:t>https://github.com/webmaxru/northstar-orders-api-demo/blob/b65c2de5c8224342c72c37eeed7ef9f965ad8a2c/AGENTS.md</a:t>
             </a:r>
           </a:p>
           <a:p>
             <a:r>
-              <a:rPr dirty="0"/>
               <a:t>https://github.com/webmaxru/northstar-orders-api-demo/blob/b65c2de5c8224342c72c37eeed7ef9f965ad8a2c/scripts/authorize-tool.mjs</a:t>
             </a:r>
           </a:p>
           <a:p>
             <a:r>
-              <a:rPr dirty="0"/>
               <a:t>https://github.com/webmaxru/northstar-orders-api-demo/pull/18</a:t>
             </a:r>
           </a:p>
           <a:p>
             <a:r>
-              <a:rPr dirty="0"/>
               <a:t>https://learn.microsoft.com/en-us/training/modules/design-agent-architecture-integration/4-plan-reason-execution</a:t>
             </a:r>
           </a:p>
@@ -4610,68 +4349,43 @@
           <a:lstStyle/>
           <a:p>
             <a:r>
-              <a:rPr dirty="0"/>
               <a:t>TALK TRACK</a:t>
             </a:r>
           </a:p>
           <a:p>
             <a:r>
-              <a:rPr dirty="0"/>
-              <a:t>The contributor model is a very practical simplification. I can ask the same questions about a human-authored or agent-authored PR: what is the intent, is the scope appropriate, what evidence exists, who owns the risk, and how do we recover?</a:t>
-            </a:r>
-          </a:p>
-          <a:p>
-            <a:r>
-              <a:rPr dirty="0"/>
-              <a:t>The author changes; the acceptance boundary does not disappear. A nice agent summary is useful for navigation, but it cannot replace the diff or the current checks.</a:t>
-            </a:r>
-          </a:p>
-          <a:p>
-            <a:r>
-              <a:rPr dirty="0"/>
-              <a:t>That is why both of our examples finish at the same place: a reviewable proposal and an independent decision, not an automatic declaration that the code is done.</a:t>
-            </a:r>
-          </a:p>
-          <a:p>
-            <a:endParaRPr dirty="0"/>
-          </a:p>
-          <a:p>
-            <a:r>
-              <a:rPr dirty="0"/>
+              <a:t>The contributor model is a practical simplification. Ask the same questions about human- or agent-authored work: what is the intent, is the scope appropriate, what evidence exists, who owns the risk, and how do we recover? The author changes; the acceptance boundary does not.</a:t>
+            </a:r>
+          </a:p>
+          <a:p/>
+          <a:p>
+            <a:r>
               <a:t>DEMO — REPO / VS CODE</a:t>
             </a:r>
           </a:p>
           <a:p>
             <a:r>
-              <a:rPr lang="en-GB" dirty="0"/>
-              <a:t>Show the PR template and a real review event on now-closed repair plan PR 15. Explain exactly what that event approved: the plan at its specific commit, not the later implementation or a different demo task. PR 15 and its maintenance task were closed unmerged; do not present that review as acceptance. Do not merge a PR during this explanatory segment.</a:t>
-            </a:r>
-            <a:endParaRPr dirty="0"/>
-          </a:p>
-          <a:p>
-            <a:endParaRPr dirty="0"/>
-          </a:p>
-          <a:p>
-            <a:r>
-              <a:rPr dirty="0"/>
+              <a:t>Show the PR template and the exact review event on open plan PR #15. Review `5353720051` approved the plan-only artifact at its specific commit; it did not approve the later implementation PR #18, demo PR #19, or candidate PR #27. PR #15 remains open. No merge or acceptance occurs in this explanatory segment.</a:t>
+            </a:r>
+          </a:p>
+          <a:p/>
+          <a:p>
+            <a:r>
               <a:t>DOCUMENTATION LINKS</a:t>
             </a:r>
           </a:p>
           <a:p>
             <a:r>
-              <a:rPr dirty="0"/>
               <a:t>https://github.com/webmaxru/northstar-orders-api-demo/pull/15</a:t>
             </a:r>
           </a:p>
           <a:p>
             <a:r>
-              <a:rPr dirty="0"/>
               <a:t>https://learn.microsoft.com/en-us/training/modules/design-agent-architecture-integration/5-pull-request-governance-controls</a:t>
             </a:r>
           </a:p>
           <a:p>
             <a:r>
-              <a:rPr dirty="0"/>
               <a:t>https://docs.github.com/en/pull-requests/collaborating-with-pull-requests/reviewing-changes-in-pull-requests/reviewing-proposed-changes-in-a-pull-request</a:t>
             </a:r>
           </a:p>
@@ -4758,131 +4472,58 @@
           <a:lstStyle/>
           <a:p>
             <a:r>
-              <a:rPr dirty="0"/>
               <a:t>TALK TRACK</a:t>
             </a:r>
           </a:p>
           <a:p>
             <a:r>
-              <a:rPr dirty="0"/>
-              <a:t>Probabilistic generation needs objective evaluation around it. For these examples, that means build/type checks, behavior tests, scope checks, security signals and independent human review. Each has a different job.</a:t>
-            </a:r>
-          </a:p>
-          <a:p>
-            <a:r>
-              <a:rPr dirty="0"/>
-              <a:t>The endpoint candidate is locally stronger now: 470 unit tests, 12 PostgreSQL acceptance tests, and scope/merge checks pass on the refreshed base. Its full </a:t>
-            </a:r>
-            <a:r>
-              <a:rPr dirty="0" err="1"/>
-              <a:t>validate:all</a:t>
-            </a:r>
-            <a:r>
-              <a:rPr dirty="0"/>
-              <a:t> still fails on 86 </a:t>
-            </a:r>
-            <a:r>
-              <a:rPr dirty="0" err="1"/>
-              <a:t>Zizmor</a:t>
-            </a:r>
-            <a:r>
-              <a:rPr dirty="0"/>
-              <a:t> findings (65 errors, 21 notes); Poutine reports zero findings. </a:t>
-            </a:r>
-            <a:r>
-              <a:rPr lang="en-GB" dirty="0"/>
-              <a:t>The now-closed issue #16 maintenance candidate had a historical local bundle of 500 unit and 10 PostgreSQL acceptance tests; full validation reported 84 </a:t>
-            </a:r>
-            <a:r>
-              <a:rPr lang="en-GB" dirty="0" err="1"/>
-              <a:t>Zizmor</a:t>
-            </a:r>
-            <a:r>
-              <a:rPr lang="en-GB" dirty="0"/>
-              <a:t> findings. Those local results do not imply hosted acceptance, and issue #16 is not an active task.</a:t>
-            </a:r>
-            <a:endParaRPr dirty="0"/>
-          </a:p>
-          <a:p>
-            <a:r>
-              <a:rPr dirty="0"/>
-              <a:t>The refreshed PR 19 plan-contract, scope, acceptance, quality, dependency, secret-scan, merge and </a:t>
-            </a:r>
-            <a:r>
-              <a:rPr dirty="0" err="1"/>
-              <a:t>CodeQL</a:t>
-            </a:r>
-            <a:r>
-              <a:rPr dirty="0"/>
-              <a:t> checks pass. </a:t>
-            </a:r>
-            <a:r>
-              <a:rPr lang="en-GB" dirty="0" err="1"/>
-              <a:t>Vibeprogrammer</a:t>
-            </a:r>
-            <a:r>
-              <a:rPr lang="en-GB" dirty="0"/>
-              <a:t> approved PR 19's exact head and hosted human-review passes; repository-controls still fails.</a:t>
-            </a:r>
-            <a:r>
-              <a:rPr dirty="0"/>
-              <a:t> Missing hosted evidence is not a pass.</a:t>
-            </a:r>
-          </a:p>
-          <a:p>
-            <a:endParaRPr dirty="0"/>
-          </a:p>
-          <a:p>
-            <a:r>
-              <a:rPr dirty="0"/>
+              <a:t>Probabilistic generation needs objective evaluation around it: build/type checks, behavior tests, scope checks, security signals, and independent human review. Each has a different job.</a:t>
+            </a:r>
+          </a:p>
+          <a:p>
+            <a:r>
+              <a:t>The endpoint candidate PR #19 at `cf762216` is locally proven by 470 unit tests, 12 PostgreSQL acceptance tests, scope, and merge checks. Full `validate:all` fails on 86 Zizmor findings; Poutine reports zero findings. Hosted human-review passes, but repository-controls fails. Its issue/plan/base `17e7a5c…` is older than current PR #18 head `2ce3cf8…`, so no hosted acceptance is claimed.</a:t>
+            </a:r>
+          </a:p>
+          <a:p>
+            <a:r>
+              <a:t>Issue #16 is open. Its implementation PR #27 at `bfb2cbf…` is draft: local validation passes 528 unit/10 PostgreSQL tests, but full validation reports 83 Zizmor findings. Hosted run `36705616895` fails repository-controls, human-review, and evidence; AC9 remains unproven. The local CLI canaries at predecessor `bb767fc…` prove identity binding only. Cloud canary PR #30 stopped because the task-contract artifact was absent. Local results do not imply hosted acceptance.</a:t>
+            </a:r>
+          </a:p>
+          <a:p/>
+          <a:p>
+            <a:r>
               <a:t>DEMO — REPO / VS CODE</a:t>
             </a:r>
           </a:p>
           <a:p>
             <a:r>
-              <a:rPr lang="en-GB" dirty="0"/>
-              <a:t>Show current demo PR 19 and archived maintenance PR 27 results. Identify the exact head/base before comparing counts. Open the PostgreSQL acceptance result and </a:t>
-            </a:r>
-            <a:r>
-              <a:rPr lang="en-GB" dirty="0" err="1"/>
-              <a:t>Zizmor</a:t>
-            </a:r>
-            <a:r>
-              <a:rPr lang="en-GB" dirty="0"/>
-              <a:t> report. PR 27 is closed and unaccepted; use its checks only as historical evidence. Do not suppress findings or present a green subset as overall acceptance.</a:t>
-            </a:r>
-            <a:endParaRPr dirty="0"/>
-          </a:p>
-          <a:p>
-            <a:endParaRPr dirty="0"/>
-          </a:p>
-          <a:p>
-            <a:r>
-              <a:rPr dirty="0"/>
+              <a:t>Show current PR #19 and PR #27, identify each exact head/base before comparing results, and open the acceptance output and Zizmor report. PR #27 is open/draft, not closed; PR #19 is also draft/unaccepted. Do not suppress findings or present a green subset as overall acceptance.</a:t>
+            </a:r>
+          </a:p>
+          <a:p/>
+          <a:p>
+            <a:r>
               <a:t>DOCUMENTATION LINKS</a:t>
             </a:r>
           </a:p>
           <a:p>
             <a:r>
-              <a:rPr dirty="0"/>
               <a:t>https://github.com/webmaxru/northstar-orders-api-demo/issues/14</a:t>
             </a:r>
           </a:p>
           <a:p>
             <a:r>
-              <a:rPr dirty="0"/>
               <a:t>https://github.com/webmaxru/northstar-orders-api-demo/issues/16</a:t>
             </a:r>
           </a:p>
           <a:p>
             <a:r>
-              <a:rPr dirty="0"/>
               <a:t>https://github.com/webmaxru/northstar-orders-api-demo/issues/17</a:t>
             </a:r>
           </a:p>
           <a:p>
             <a:r>
-              <a:rPr dirty="0"/>
               <a:t>https://learn.microsoft.com/en-us/training/modules/design-agent-architecture-integration/5-pull-request-governance-controls</a:t>
             </a:r>
           </a:p>
@@ -4969,83 +4610,48 @@
           <a:lstStyle/>
           <a:p>
             <a:r>
-              <a:rPr dirty="0"/>
               <a:t>TALK TRACK</a:t>
             </a:r>
           </a:p>
           <a:p>
             <a:r>
-              <a:rPr dirty="0"/>
-              <a:t>Evidence needs an address and an identity. Which task, which plan, which commit, which run and which attempt produced this result? If I cannot answer those questions, I cannot safely combine the files into a release decision.</a:t>
-            </a:r>
-          </a:p>
-          <a:p>
-            <a:r>
-              <a:rPr dirty="0"/>
-              <a:t>The snippets here are excerpts from the reference, not a complete workflow to paste into any repository. Their job is to show the durable handoff: a PR carries the decision context, and a workflow uploads inspectable output.</a:t>
-            </a:r>
-          </a:p>
-          <a:p>
-            <a:r>
-              <a:rPr dirty="0"/>
-              <a:t>The filename </a:t>
-            </a:r>
-            <a:r>
-              <a:rPr dirty="0" err="1"/>
-              <a:t>report.json</a:t>
-            </a:r>
-            <a:r>
-              <a:rPr dirty="0"/>
-              <a:t> is not globally unique. It is only safe inside the correct isolated workspace and source-run context. Copying a file from another task does not make it evidence for this one.</a:t>
-            </a:r>
-          </a:p>
-          <a:p>
-            <a:endParaRPr dirty="0"/>
-          </a:p>
-          <a:p>
-            <a:r>
-              <a:rPr dirty="0"/>
+              <a:t>Evidence needs an address and an identity: which task, plan, commit, run, and attempt produced the result? Without those, it cannot safely support a release decision. The PR carries that context; workflow artifacts carry inspectable output. `report.json` is only authoritative inside its matching task and source-run context.</a:t>
+            </a:r>
+          </a:p>
+          <a:p/>
+          <a:p>
+            <a:r>
               <a:t>DEMO — REPO / VS CODE</a:t>
             </a:r>
           </a:p>
           <a:p>
             <a:r>
-              <a:rPr dirty="0"/>
-              <a:t>Open the PR template, the upload step in governed-</a:t>
-            </a:r>
-            <a:r>
-              <a:rPr dirty="0" err="1"/>
-              <a:t>change.yml</a:t>
-            </a:r>
-            <a:r>
-              <a:rPr dirty="0"/>
-              <a:t>, and an execution report. Point to task/plan/base/head/run/attempt binding and the rejection of missing or mixed evidence. Explain that current major action tags are under scanner review; a source excerpt is not approval of every external repository setting.</a:t>
-            </a:r>
-          </a:p>
-          <a:p>
-            <a:endParaRPr dirty="0"/>
-          </a:p>
-          <a:p>
-            <a:r>
-              <a:rPr dirty="0"/>
+              <a:t>Open the PR template, the upload step in `.github/workflows/governed-change.yml`, and an execution report. Point to task/plan/base/head/run/attempt binding and rejection of missing or mixed evidence. The upload-artifact excerpt is from the Northstar candidate at `bfb2cbf1d0f488ced1595f100c14ed8e312bb1f7`; the source uses the same `actions/upload-artifact@v7` tag, which remains among Zizmor's `unpinned-uses` findings. A source excerpt is not approval of every external repository setting.</a:t>
+            </a:r>
+          </a:p>
+          <a:p/>
+          <a:p>
+            <a:r>
               <a:t>DOCUMENTATION LINKS</a:t>
             </a:r>
           </a:p>
           <a:p>
             <a:r>
-              <a:rPr dirty="0"/>
               <a:t>https://github.com/webmaxru/northstar-orders-api-demo/blob/b65c2de5c8224342c72c37eeed7ef9f965ad8a2c/.github/pull_request_template.md</a:t>
             </a:r>
           </a:p>
           <a:p>
             <a:r>
-              <a:rPr dirty="0"/>
+              <a:t>https://github.com/webmaxru/northstar-orders-api-demo/blob/bfb2cbf1d0f488ced1595f100c14ed8e312bb1f7/.github/workflows/governed-change.yml</a:t>
+            </a:r>
+          </a:p>
+          <a:p>
+            <a:r>
               <a:t>https://docs.github.com/en/actions/using-workflows/storing-workflow-data-as-artifacts</a:t>
             </a:r>
           </a:p>
           <a:p>
             <a:r>
-              <a:rPr dirty="0"/>
               <a:t>https://learn.microsoft.com/en-us/training/modules/multi-agent-systems-orchestration/3-orchestrate-agent-workflows</a:t>
             </a:r>
           </a:p>
@@ -5279,115 +4885,80 @@
           <a:lstStyle/>
           <a:p>
             <a:r>
-              <a:rPr dirty="0"/>
               <a:t>TALK TRACK</a:t>
             </a:r>
           </a:p>
           <a:p>
             <a:r>
-              <a:rPr dirty="0"/>
-              <a:t>There is a subtle point behind parallel agents. Two tasks on one machine are not automatically a problem; two writers sharing one checkout, Git index and mutable artifact directory are.</a:t>
-            </a:r>
-          </a:p>
-          <a:p>
-            <a:r>
-              <a:rPr lang="en-GB" dirty="0"/>
-              <a:t>Closed maintenance PR 27 proposed isolated task </a:t>
-            </a:r>
-            <a:r>
-              <a:rPr lang="en-GB" dirty="0" err="1"/>
-              <a:t>worktrees</a:t>
-            </a:r>
-            <a:r>
-              <a:rPr lang="en-GB" dirty="0"/>
-              <a:t> and PostgreSQL schemas, but it was never accepted. Two read-only CLI canaries matched task/contract/plan/base/session/owner identity; they did not prove write authorization, recovery, or cloud isolation. Issue #16 is no longer active.</a:t>
-            </a:r>
-            <a:r>
-              <a:rPr dirty="0"/>
-              <a:t> </a:t>
-            </a:r>
-            <a:r>
-              <a:rPr lang="en-GB" dirty="0"/>
-              <a:t>These are historical checks only: PR 27 was closed unmerged with full validation and hosted gates still failing; PR 29 was closed after a wrong-base/no-change attempt. No cloud isolation or acceptance is established.</a:t>
-            </a:r>
-            <a:endParaRPr dirty="0"/>
-          </a:p>
-          <a:p>
-            <a:endParaRPr dirty="0"/>
-          </a:p>
-          <a:p>
-            <a:r>
-              <a:rPr dirty="0"/>
+              <a:t>A plan on a separate worktree can be useful, but a green local identity result is not cloud acceptance. Two read-only Copilot CLI canaries at predecessor `bb767fc…` resolved issue #16, its contract, approved plan, base, session, and distinct workspace-owner identities. They made no source changes and did not prove write authorization, Stop behavior, recovery, VS Code behavior, or cloud isolation.</a:t>
+            </a:r>
+          </a:p>
+          <a:p>
+            <a:r>
+              <a:t>Issue #16 is open; approved plan PR #26 is open, and implementation PR #27 at `bfb2cbf…` is draft. Cloud canary PR #30 used predecessor base `bb767fc…` but stopped because `artifacts/task-contract.json` was absent. PR #32 attempted Issue #24 on that same Issue #16 base and is not valid Issue #24 evidence. No cloud parallel-isolation result or hosted acceptance is established.</a:t>
+            </a:r>
+          </a:p>
+          <a:p/>
+          <a:p>
+            <a:r>
               <a:t>DEMO — REPO / VS CODE</a:t>
             </a:r>
           </a:p>
           <a:p>
             <a:r>
-              <a:rPr lang="en-GB" dirty="0"/>
-              <a:t>Show the separate </a:t>
-            </a:r>
-            <a:r>
-              <a:rPr lang="en-GB" dirty="0" err="1"/>
-              <a:t>worktree</a:t>
-            </a:r>
-            <a:r>
-              <a:rPr lang="en-GB" dirty="0"/>
-              <a:t> paths and closed PR 27 only as historical evidence. Explain what the CLI canaries did and did not prove. Do not run destructive shared-checkout tests. VS Code Local-mode demos remain serial. Issue #16 is closed; do not start another task under it. Any future owner-authorized cloud task must use GitHub.com and an explicitly approved base for its live task.</a:t>
-            </a:r>
-            <a:endParaRPr dirty="0"/>
-          </a:p>
-          <a:p>
-            <a:endParaRPr dirty="0"/>
-          </a:p>
-          <a:p>
-            <a:r>
-              <a:rPr dirty="0"/>
+              <a:t>Show separate CLI worktree paths and the current open PR #27. Explain that the canaries prove only local read-only identity binding. Do not run destructive shared-checkout tests. VS Code Local-mode behavior is unverified; any future cloud task must bind its own live contract and approved base.</a:t>
+            </a:r>
+          </a:p>
+          <a:p/>
+          <a:p>
+            <a:r>
               <a:t>DOCUMENTATION LINKS</a:t>
             </a:r>
           </a:p>
           <a:p>
             <a:r>
-              <a:rPr dirty="0"/>
               <a:t>https://github.com/webmaxru/northstar-orders-api-demo/issues/16</a:t>
             </a:r>
           </a:p>
           <a:p>
             <a:r>
-              <a:rPr dirty="0"/>
               <a:t>https://github.com/webmaxru/northstar-orders-api-demo/pull/27</a:t>
             </a:r>
           </a:p>
           <a:p>
             <a:r>
-              <a:rPr dirty="0"/>
+              <a:t>https://github.com/webmaxru/northstar-orders-api-demo/pull/30</a:t>
+            </a:r>
+          </a:p>
+          <a:p>
+            <a:r>
+              <a:t>https://github.com/webmaxru/northstar-orders-api-demo/pull/32</a:t>
+            </a:r>
+          </a:p>
+          <a:p>
+            <a:r>
               <a:t>https://github.com/webmaxru/northstar-orders-api-demo/pull/29</a:t>
             </a:r>
           </a:p>
           <a:p>
             <a:r>
-              <a:rPr dirty="0"/>
               <a:t>https://learn.microsoft.com/en-us/training/modules/multi-agent-systems-orchestration/4-execution-isolation-permissions-concurrency</a:t>
             </a:r>
           </a:p>
           <a:p>
             <a:r>
-              <a:rPr dirty="0"/>
               <a:t>https://git-scm.com/docs/git-worktree</a:t>
             </a:r>
           </a:p>
-          <a:p>
-            <a:endParaRPr dirty="0"/>
-          </a:p>
-          <a:p>
-            <a:r>
-              <a:rPr dirty="0"/>
+          <a:p/>
+          <a:p>
+            <a:r>
               <a:t>EVIDENCE BOUNDARY</a:t>
             </a:r>
           </a:p>
           <a:p>
             <a:r>
-              <a:rPr dirty="0"/>
-              <a:t>Synthetic concurrency tests and two local CLI identity canaries are not live cloud acceptance. PR 27's AC9 cloud criterion remains unproven; PR 29 is a wrong-base/no-change attempt.</a:t>
+              <a:t>Synthetic concurrency tests and two local CLI identity canaries are not live cloud acceptance. PR #27 AC9 remains unproven; cloud task bootstrap lacked the contract artifact. PR #29 remains a wrong-base/no-change attempt.</a:t>
             </a:r>
           </a:p>
         </p:txBody>
@@ -5874,56 +5445,48 @@
           <a:lstStyle/>
           <a:p>
             <a:r>
-              <a:rPr dirty="0"/>
               <a:t>TALK TRACK — OPTIONAL, HIDDEN</a:t>
             </a:r>
           </a:p>
           <a:p>
             <a:r>
-              <a:rPr dirty="0"/>
-              <a:t>When the same kind of miss keeps returning, I want to improve the system that allowed it: the task contract, context selection, tools, checks or recovery path. A new prompt may be part of that, but it is not the automatic answer to every problem.</a:t>
-            </a:r>
-          </a:p>
-          <a:p>
-            <a:r>
-              <a:rPr dirty="0"/>
-              <a:t>This slide repeats the practical lesson from the real missing-artifact defect, so it is kept for discussion rather than interrupting the two-demo story.</a:t>
-            </a:r>
-          </a:p>
-          <a:p>
-            <a:endParaRPr dirty="0"/>
-          </a:p>
-          <a:p>
-            <a:r>
-              <a:rPr dirty="0"/>
+              <a:t>When the same miss repeats, improve the system that allowed it: task contract, context selection, tools, checks, or recovery. A new prompt is not the automatic answer.</a:t>
+            </a:r>
+          </a:p>
+          <a:p>
+            <a:r>
+              <a:t>This slide echoes the actual missing-artifact issue. Issue #14 and PR #18 remain open; PR #18 is an unaccepted repair candidate, and its hosted evidence/controls gates are incomplete. Review the specific regression test and trace one failure to the changed control; do not imply the maintenance work is accepted.</a:t>
+            </a:r>
+          </a:p>
+          <a:p/>
+          <a:p>
+            <a:r>
               <a:t>DEMO — REPO / VS CODE</a:t>
             </a:r>
           </a:p>
           <a:p>
             <a:r>
-              <a:rPr lang="en-GB" dirty="0"/>
-              <a:t>If needed, review closed issue #14/PR #18 and the specific regression test as historical maintenance evidence. Trace one failure to the changed control instead of browsing the entire audit; no active maintenance task remains.</a:t>
-            </a:r>
-            <a:endParaRPr dirty="0"/>
-          </a:p>
-          <a:p>
-            <a:endParaRPr dirty="0"/>
-          </a:p>
-          <a:p>
-            <a:r>
-              <a:rPr dirty="0"/>
+              <a:t>If needed, open issue #14/PR #18 and the regression test as current maintenance evidence. Keep its `ready_for_review` report distinct from hosted `ready_for_acceptance`.</a:t>
+            </a:r>
+          </a:p>
+          <a:p/>
+          <a:p>
+            <a:r>
               <a:t>DOCUMENTATION LINKS</a:t>
             </a:r>
           </a:p>
           <a:p>
             <a:r>
-              <a:rPr dirty="0"/>
               <a:t>https://github.com/webmaxru/northstar-orders-api-demo/issues/14</a:t>
             </a:r>
           </a:p>
           <a:p>
             <a:r>
-              <a:rPr dirty="0"/>
+              <a:t>https://github.com/webmaxru/northstar-orders-api-demo/pull/18</a:t>
+            </a:r>
+          </a:p>
+          <a:p>
+            <a:r>
               <a:t>https://learn.microsoft.com/en-us/training/modules/multi-agent-systems-orchestration/</a:t>
             </a:r>
           </a:p>
@@ -6854,152 +6417,92 @@
           <a:lstStyle/>
           <a:p>
             <a:r>
-              <a:rPr dirty="0"/>
               <a:t>TALK TRACK</a:t>
             </a:r>
           </a:p>
           <a:p>
             <a:r>
-              <a:rPr dirty="0"/>
-              <a:t>Thank you. I hope the useful takeaway is that we can make agentic development inspectable. We can name the task, see the boundaries, challenge the plan or code at the right time, and ask what the evidence actually proves. The database acceptance results are real; a completed governed-agent demonstration is not established.</a:t>
-            </a:r>
-          </a:p>
-          <a:p>
-            <a:endParaRPr dirty="0"/>
-          </a:p>
-          <a:p>
-            <a:r>
-              <a:rPr dirty="0"/>
+              <a:t>Thank you. The useful takeaway is that agentic development can be made inspectable: name the task, see the boundaries, challenge the plan or code at the right time, and check what the evidence actually proves. The database acceptance results are real; a completed governed-agent delivery is not established.</a:t>
+            </a:r>
+          </a:p>
+          <a:p/>
+          <a:p>
+            <a:r>
               <a:t>DEMO — REPO / VS CODE</a:t>
             </a:r>
           </a:p>
           <a:p>
             <a:r>
-              <a:rPr lang="en-GB" dirty="0"/>
-              <a:t>Show open demo issues #4 and #17 and draft PR #19. Show closed maintenance PRs #13, #15, #18, #21, #23, #25, #26, #27, #28 and #29 only as historical records. Say plainly: those closures were scope cancellations, not accepted implementations. PR #19 at cf762216 is aligned to base 17e7a5c; exact-head review, human-review and PostgreSQL 12/12 pass, but full validation reports 86 </a:t>
-            </a:r>
-            <a:r>
-              <a:rPr lang="en-GB" dirty="0" err="1"/>
-              <a:t>Zizmor</a:t>
-            </a:r>
-            <a:r>
-              <a:rPr lang="en-GB" dirty="0"/>
-              <a:t> findings and repository-controls fails. No live VS Code or successful cloud-agent run is recorded. Do not show a green status as acceptance.</a:t>
-            </a:r>
-            <a:r>
-              <a:rPr dirty="0"/>
-              <a:t> </a:t>
-            </a:r>
-            <a:r>
-              <a:rPr lang="en-GB" dirty="0"/>
-              <a:t>Historical note: PR #19's current status and the closure of maintenance PRs are summarized above. Earlier PR #27/#28 checks did not establish hosted acceptance. No maintenance candidate is accepted, and no successful VS Code/cloud-agent run is recorded.</a:t>
-            </a:r>
-            <a:endParaRPr dirty="0"/>
-          </a:p>
-          <a:p>
-            <a:endParaRPr dirty="0"/>
-          </a:p>
-          <a:p>
-            <a:r>
-              <a:rPr dirty="0"/>
+              <a:t>Show open issues #4 and #17 and draft PR #19. Maintenance plans #15/#21/#23/#25/#26 remain open; implementation PRs #18/#27/#28 also remain open, with #27 and #28 draft/unaccepted. Only PR #13 and PR #29 are closed among the prior canaries. PR #19 at `cf762216` passes local PostgreSQL 12/12 and hosted human-review, but full validation has 86 Zizmor findings and repository-controls fails. PR #27 at `bfb2cbf…` passes local 528-unit/10-acceptance validation, but full validation has 83 Zizmor findings; hosted run `36705616895` is `review_required`, with AC9 unproven. PR #28 remains draft and unaccepted. Do not show a green status as acceptance.</a:t>
+            </a:r>
+          </a:p>
+          <a:p/>
+          <a:p>
+            <a:r>
               <a:t>NEXT ACTION</a:t>
             </a:r>
           </a:p>
           <a:p>
             <a:r>
-              <a:rPr lang="en-GB" dirty="0"/>
-              <a:t>PR #19's exact-head review and hosted human-review pass, but repository-controls still blocks acceptance. PR #28's exact-head review was approved, but its PR was closed unmerged under maintenance scope and its controls check failed.</a:t>
-            </a:r>
-            <a:r>
-              <a:rPr dirty="0"/>
-              <a:t> </a:t>
-            </a:r>
-            <a:r>
-              <a:rPr lang="en-GB" dirty="0"/>
-              <a:t>The system-maintenance issue #16 is closed; do not start another #16 task. WI-1842 remains a demo task, but its prior plan-only PR #13 was closed after the planner stopped on a missing cached task contract, so no plan was produced. No successful cloud run is recorded. Any future demo cloud run must use GitHub.com (not the Copilot app or CLI), a live demo issue, the read-only plan agent, and the exact base authorized for that task; stop if live task authority or base binding is unavailable. PR #29 was the wrong-base/no-change attempt. No repository settings or rulesets changed.</a:t>
-            </a:r>
-            <a:endParaRPr dirty="0"/>
-          </a:p>
-          <a:p>
-            <a:endParaRPr dirty="0"/>
-          </a:p>
-          <a:p>
-            <a:r>
-              <a:rPr dirty="0"/>
+              <a:t>A fresh implementation review is requested on PR #27 head `bfb2cbf…`. Resolve the `repository-controls`, `human-review`, and `evidence` gates; `validation-authority` did not run. The cloud task-resolution canary stopped on absent `artifacts/task-contract.json`, and no successful cloud or VS Code delivery is proved. Do not change repository settings or rulesets without the required authorization.</a:t>
+            </a:r>
+          </a:p>
+          <a:p/>
+          <a:p>
+            <a:r>
               <a:t>DOCUMENTATION LINKS</a:t>
             </a:r>
           </a:p>
           <a:p>
             <a:r>
-              <a:rPr dirty="0"/>
               <a:t>https://github.com/webmaxru/ai-engineering-system</a:t>
             </a:r>
           </a:p>
           <a:p>
             <a:r>
-              <a:rPr dirty="0"/>
               <a:t>https://github.com/webmaxru/northstar-orders-api-demo/pull/18</a:t>
             </a:r>
           </a:p>
           <a:p>
             <a:r>
-              <a:rPr dirty="0"/>
               <a:t>https://github.com/webmaxru/northstar-orders-api-demo/pull/19</a:t>
             </a:r>
           </a:p>
           <a:p>
             <a:r>
-              <a:rPr dirty="0"/>
               <a:t>https://github.com/webmaxru/northstar-orders-api-demo/pull/27</a:t>
             </a:r>
           </a:p>
           <a:p>
             <a:r>
-              <a:rPr dirty="0"/>
               <a:t>https://github.com/webmaxru/northstar-orders-api-demo/pull/28</a:t>
             </a:r>
           </a:p>
           <a:p>
             <a:r>
-              <a:rPr dirty="0"/>
               <a:t>https://github.com/webmaxru/northstar-orders-api-demo/issues/16</a:t>
             </a:r>
           </a:p>
           <a:p>
             <a:r>
-              <a:rPr dirty="0"/>
               <a:t>https://github.com/webmaxru/ai-engineering-system/blob/main/docs/GUIDE-CONFORMANCE.md</a:t>
             </a:r>
           </a:p>
           <a:p>
             <a:r>
-              <a:rPr dirty="0"/>
               <a:t>https://learn.microsoft.com/en-us/training/modules/design-agent-architecture-integration/4-plan-reason-execution</a:t>
             </a:r>
           </a:p>
-          <a:p>
-            <a:endParaRPr dirty="0"/>
-          </a:p>
-          <a:p>
-            <a:r>
-              <a:rPr dirty="0"/>
+          <a:p/>
+          <a:p>
+            <a:r>
               <a:t>EVIDENCE BOUNDARY</a:t>
             </a:r>
           </a:p>
           <a:p>
             <a:r>
-              <a:rPr lang="en-GB" dirty="0"/>
-              <a:t>Open demo work is issues #4 and #17; draft demo PR #19 is the only open PR. PR #13 is a closed WI-1842 planner stop; PRs #15, #18, #21, #23, #25, #26, #27, #28 and #29 are closed, unmerged maintenance or failed-attempt records. These closures are scope cancellations, not accepted implementations. PR #19's exact-head review and hosted human-review pass, but repository-controls fails; no hosted </a:t>
-            </a:r>
-            <a:r>
-              <a:rPr lang="en-GB" dirty="0" err="1"/>
-              <a:t>ready_for_acceptance</a:t>
-            </a:r>
-            <a:r>
-              <a:rPr lang="en-GB" dirty="0"/>
-              <a:t> or successful VS Code/cloud delivery is recorded.</a:t>
-            </a:r>
-            <a:endParaRPr dirty="0"/>
+              <a:t>PR #18 remains open and unaccepted; PR #19, #27, and #28 are open drafts. PR #15/#21/#23/#25/#26 are open plans; the required implementation and hosted acceptance steps remain pending. PR #13 and #29 are closed historical attempts, not accepted results. No hosted `ready_for_acceptance`, live VS Code delivery, or successful cloud-agent delivery is recorded.</a:t>
+            </a:r>
           </a:p>
         </p:txBody>
       </p:sp>
@@ -7439,127 +6942,66 @@
           <a:lstStyle/>
           <a:p>
             <a:r>
-              <a:rPr dirty="0"/>
               <a:t>TALK TRACK</a:t>
             </a:r>
           </a:p>
           <a:p>
             <a:r>
-              <a:rPr lang="en-GB" dirty="0"/>
-              <a:t>Here is the distinction I want to make visible: a repaired implementation can pass application tests without becoming an accepted release. PR 18 is closed unmerged: hosted acceptance tests passed, but evidence and repository-controls failed. PR 27 is also closed unmerged. Its local validation passed 500 unit and 10 PostgreSQL acceptance tests, scope/merge passed, but full </a:t>
-            </a:r>
-            <a:r>
-              <a:rPr lang="en-GB" dirty="0" err="1"/>
-              <a:t>validate:all</a:t>
-            </a:r>
-            <a:r>
-              <a:rPr lang="en-GB" dirty="0"/>
-              <a:t> reported 84 </a:t>
-            </a:r>
-            <a:r>
-              <a:rPr lang="en-GB" dirty="0" err="1"/>
-              <a:t>Zizmor</a:t>
-            </a:r>
-            <a:r>
-              <a:rPr lang="en-GB" dirty="0"/>
-              <a:t> findings and hosted evidence/repository-controls failed. Neither closure converted these results into acceptance. I will not merge those facts into one green status.</a:t>
-            </a:r>
-            <a:endParaRPr dirty="0"/>
-          </a:p>
-          <a:p>
-            <a:endParaRPr dirty="0"/>
-          </a:p>
-          <a:p>
-            <a:r>
-              <a:rPr dirty="0"/>
+              <a:t>Here is the distinction I want to make visible: a repair candidate can pass application tests without becoming an accepted release. PR #18 remains open at `2ce3cf8…`, unmerged and unaccepted. Its PostgreSQL acceptance job passed, but human-review, repository-controls, and final trusted acceptance remain blocked; AC15 is unverified. PR #27 is also open, but draft. Its current candidate `bfb2cbf…` passes 528 unit and 10 PostgreSQL acceptance tests locally; full `validate:all` reports 83 Zizmor findings. Hosted run `36705616895` fails repository-controls, human-review, and evidence, and AC9 remains unproven. Neither is accepted; do not merge those facts into one green status.</a:t>
+            </a:r>
+          </a:p>
+          <a:p/>
+          <a:p>
+            <a:r>
               <a:t>DEMO — REPO / VS CODE</a:t>
             </a:r>
           </a:p>
           <a:p>
             <a:r>
-              <a:rPr lang="en-GB" dirty="0"/>
-              <a:t>Show the closed PR 18 and PR 27 pages only as historical examples. Their local tests did not clear the failed hosted evidence and repository-controls gates; PR 27's two read-only CLI canaries proved identity binding only. Keep scanner findings visible: Poutine reports zero findings, while </a:t>
-            </a:r>
-            <a:r>
-              <a:rPr lang="en-GB" dirty="0" err="1"/>
-              <a:t>Zizmor</a:t>
-            </a:r>
-            <a:r>
-              <a:rPr lang="en-GB" dirty="0"/>
-              <a:t> reported 84 on PR 27. The displayed code is the historical missing-artifact check from the audited baseline; it ends after the closing brace, before the report object. Do not present either closure as acceptance.</a:t>
-            </a:r>
-            <a:endParaRPr dirty="0"/>
-          </a:p>
-          <a:p>
-            <a:endParaRPr dirty="0"/>
-          </a:p>
-          <a:p>
-            <a:r>
-              <a:rPr dirty="0"/>
+              <a:t>Show the open PR #18 and draft PR #27 as candidates, not closed historical examples. The two read-only CLI canaries ran at predecessor `bb767fc…` and proved task/contract/plan/base/session/owner identity only. Keep the current scanner result visible: Poutine reported zero findings; Zizmor reports 83 unsuppressed findings. The code on this slide is the historical missing-artifact check from audited baseline `b65c2de…`; it is an exact historical excerpt, not current implementation code. Do not present any PR as acceptance.</a:t>
+            </a:r>
+          </a:p>
+          <a:p/>
+          <a:p>
+            <a:r>
               <a:t>DOCUMENTATION LINKS</a:t>
             </a:r>
           </a:p>
           <a:p>
             <a:r>
-              <a:rPr dirty="0"/>
               <a:t>https://github.com/webmaxru/northstar-orders-api-demo/pull/18</a:t>
             </a:r>
           </a:p>
           <a:p>
             <a:r>
-              <a:rPr dirty="0"/>
               <a:t>https://github.com/webmaxru/northstar-orders-api-demo/pull/27</a:t>
             </a:r>
           </a:p>
           <a:p>
             <a:r>
-              <a:rPr dirty="0"/>
               <a:t>https://github.com/webmaxru/northstar-orders-api-demo/issues/14</a:t>
             </a:r>
           </a:p>
           <a:p>
             <a:r>
-              <a:rPr dirty="0"/>
               <a:t>https://github.com/webmaxru/ai-engineering-system/blob/main/docs/GUIDE-CONFORMANCE.md</a:t>
             </a:r>
           </a:p>
           <a:p>
             <a:r>
-              <a:rPr dirty="0"/>
-              <a:t>https://github.com/webmaxru/northstar-orders-api-demo</a:t>
-            </a:r>
-          </a:p>
-          <a:p>
-            <a:endParaRPr dirty="0"/>
-          </a:p>
-          <a:p>
-            <a:r>
-              <a:rPr dirty="0"/>
+              <a:t>https://github.com/webmaxru/northstar-orders-api-demo/blob/b65c2de5c8224342c72c37eeed7ef9f965ad8a2c/scripts/build-execution-report.mjs</a:t>
+            </a:r>
+          </a:p>
+          <a:p/>
+          <a:p>
+            <a:r>
               <a:t>EVIDENCE BOUNDARY</a:t>
             </a:r>
           </a:p>
           <a:p>
             <a:r>
-              <a:rPr lang="en-GB" dirty="0"/>
-              <a:t>PR 18 was closed unmerged; its head 17e7a5c passed hosted acceptance tests but failed evidence and repository-controls. Closed PR 27 head fc59deef passed 500 unit tests, 10 PostgreSQL acceptance tests, scope and merge checks locally, but its full validation reported 84 </a:t>
-            </a:r>
-            <a:r>
-              <a:rPr lang="en-GB" dirty="0" err="1"/>
-              <a:t>Zizmor</a:t>
-            </a:r>
-            <a:r>
-              <a:rPr lang="en-GB" dirty="0"/>
-              <a:t> findings. Two read-only CLI identity canaries proved only task/contract/plan/base/session/owner binding. No live VS Code or successful cloud run is recorded; PR 29 used the wrong base and produced zero changes. No hosted </a:t>
-            </a:r>
-            <a:r>
-              <a:rPr lang="en-GB" dirty="0" err="1"/>
-              <a:t>ready_for_acceptance</a:t>
-            </a:r>
-            <a:r>
-              <a:rPr lang="en-GB" dirty="0"/>
-              <a:t> is recorded.</a:t>
-            </a:r>
-            <a:endParaRPr dirty="0"/>
+              <a:t>PR #18 is open and unaccepted; its hosted acceptance job passed, while human-review, repository-controls, and final trusted acceptance are incomplete. PR #27 is open/draft at `bfb2cbf…`; local 528-unit/10-acceptance validation passes, full Zizmor reports 83, and hosted run `36705616895` is `review_required` with AC1–AC8/AC10 proven and AC9 unproven. Two CLI canaries at `bb767fc…` proved identity binding only. Cloud PR #30 stopped because `artifacts/task-contract.json` was absent; PR #29 was the separate wrong-base/no-change attempt. No hosted `ready_for_acceptance` is recorded.</a:t>
+            </a:r>
           </a:p>
         </p:txBody>
       </p:sp>
@@ -18336,7 +17778,7 @@
                 <a:ea typeface="Cascadia Mono" pitchFamily="34" charset="-122"/>
                 <a:cs typeface="Cascadia Mono" pitchFamily="34" charset="-120"/>
               </a:rPr>
-              <a:t>DRAFT: BASE ALIGNED; PG 12/12; REVIEW APPROVED; CONTROLS FAIL.</a:t>
+              <a:t>DRAFT: BASE 17E7; PG 12/12; REVIEW PASS; CONTROLS FAIL.</a:t>
             </a:r>
             <a:endParaRPr lang="en-US" sz="1150" dirty="0"/>
           </a:p>
@@ -31784,7 +31226,7 @@
                 <a:ea typeface="Cascadia Mono" pitchFamily="34" charset="-122"/>
                 <a:cs typeface="Cascadia Mono" pitchFamily="34" charset="-120"/>
               </a:rPr>
-              <a:t>CLI ID ONLY; PR 27 CLOSED; CLOUD AC9 UNPROVED.</a:t>
+              <a:t>CLI ID ONLY; PR 27 DRAFT; CLOUD AC9 UNPROVEN.</a:t>
             </a:r>
             <a:endParaRPr lang="en-US" sz="1150" dirty="0"/>
           </a:p>
@@ -48539,7 +47981,7 @@
                 <a:ea typeface="Franklin Gothic Book" pitchFamily="34" charset="-122"/>
                 <a:cs typeface="Franklin Gothic Book" pitchFamily="34" charset="-120"/>
               </a:rPr>
-              <a:t>Historical defect; locally repaired. Hosted acceptance is still separate.</a:t>
+              <a:t>Repair candidates exist; hosted acceptance is still separate.</a:t>
             </a:r>
             <a:endParaRPr lang="en-US" sz="1400" dirty="0"/>
           </a:p>
@@ -48687,7 +48129,7 @@
                 <a:ea typeface="Cascadia Mono" pitchFamily="34" charset="-122"/>
                 <a:cs typeface="Cascadia Mono" pitchFamily="34" charset="-120"/>
               </a:rPr>
-              <a:t>PR 18 head 17e7a5c5 (closed)</a:t>
+              <a:t>PR 18 head 2ce3cf8 (open)</a:t>
             </a:r>
             <a:endParaRPr lang="en-US" sz="1450" dirty="0"/>
           </a:p>
@@ -48720,7 +48162,7 @@
                 <a:ea typeface="Cascadia Mono" pitchFamily="34" charset="-122"/>
                 <a:cs typeface="Cascadia Mono" pitchFamily="34" charset="-120"/>
               </a:rPr>
-              <a:t>PR 27: 500 unit / 10 PostgreSQL PASS</a:t>
+              <a:t>PR 27: 528 unit / 10 PostgreSQL PASS</a:t>
             </a:r>
           </a:p>
           <a:p>
@@ -48736,7 +48178,7 @@
                 <a:ea typeface="Cascadia Mono" pitchFamily="34" charset="-122"/>
                 <a:cs typeface="Cascadia Mono" pitchFamily="34" charset="-120"/>
               </a:rPr>
-              <a:t>Zizmor 84; Poutine 0</a:t>
+              <a:t>Zizmor 83; Poutine 0</a:t>
             </a:r>
           </a:p>
           <a:p>
@@ -48752,7 +48194,7 @@
                 <a:ea typeface="Cascadia Mono" pitchFamily="34" charset="-122"/>
                 <a:cs typeface="Cascadia Mono" pitchFamily="34" charset="-120"/>
               </a:rPr>
-              <a:t>No VS Code; cloud PR 29 wrong-base</a:t>
+              <a:t>No VS Code; cloud AC9 unproven</a:t>
             </a:r>
           </a:p>
         </p:txBody>

</xml_diff>

<commit_message>
docs: refresh presentation evidence and notes
Co-authored-by: Copilot App <223556219+Copilot@users.noreply.github.com>
</commit_message>
<xml_diff>
--- a/From-agents-to-engineering-systems.pptx
+++ b/From-agents-to-engineering-systems.pptx
@@ -2727,7 +2727,7 @@
           </a:p>
           <a:p>
             <a:r>
-              <a:t>Northstar main remains the known-defective baseline `b65c2de…`; the inert framework snapshot tracks validated candidate `bfb2cbf…` but remains `known-defective`, and conformance remains blocked. PR #18 is open at `2ce3cf8…`, unmerged and unaccepted; its local validation passed 489 unit/9 PostgreSQL tests, but hosted human-review, controls, and final trusted acceptance remain unresolved and AC15 is unverified. PR #19 is open/draft at `cf762216`, based on older `17e7a5c…`; its local 470 unit/12 PostgreSQL tests and human-review pass, but Zizmor reports 86 findings and repository-controls fails. PR #27 is open/draft at `bfb2cbf…`; local validation passes 528 unit/10 PostgreSQL tests, while `validate:all` fails on 83 Zizmor findings. Hosted run `36705616895` passes plan, scope, quality, acceptance, CodeQL, dependency, secret, merge, and governance checks, but controls, human-review, and evidence fail; AC9 is unproven. PR #28 remains open/draft and unaccepted. PR #13 and #29 are closed; #29 used `main` and made no source changes. Cloud canary PR #30 stopped because the task-contract artifact was absent; no live VS Code or successful cloud delivery is established.</a:t>
+              <a:t>Northstar main remains the known-defective baseline `b65c2de…`; the inert framework snapshot tracks candidate `bfb2cbf…` but remains `known-defective`, and conformance remains blocked. PR #18 is open at `2ce3cf8…`, unmerged and unaccepted; its local validation passed 489 unit/9 PostgreSQL tests, but hosted human-review, controls, and final trusted acceptance remain unresolved and AC15 is unverified. PR #19 is open/draft at `cf762216`, based on older `17e7a5c…`; its local 470 unit/12 PostgreSQL tests and human-review pass, but Zizmor reports 86 findings and repository-controls fails. PR #27 is open/draft at `a5c64fc…`, based on `2ce3cf8…`; `npm run validate` passes 535 unit and 10 PostgreSQL acceptance tests. Fastify 5.12.5 has zero npm audit vulnerabilities. `npm run validate:all` still fails with 83 Zizmor findings. Hosted run `36873981770` passes plan-contract, plan-approval, scope, quality, acceptance, dependency-review, CodeQL, secret-scan, merge-validation, and governance; it fails repository-controls, human-review (zero approvals on this head), and evidence. `validation-authority` is missing; the report is `review_required`, 9/10 criteria proven, with AC9 unproven. Separate Cloud run `36869969461` used predecessor `b05b481`; its Actions wrapper completed, but artifact-view attempts failed, so no bound Cloud result is established. PR #28 remains open/draft and unaccepted. PR #13 and #29 are closed; #29 used `main` and made no source changes. Earlier Cloud canary PR #30 stopped because the task-contract artifact was absent. No live VS Code or successful Cloud delivery is established.</a:t>
             </a:r>
           </a:p>
         </p:txBody>
@@ -3384,7 +3384,7 @@
           <a:lstStyle/>
           <a:p>
             <a:r>
-              <a:t>TALK TRACK — OPTIONAL, HIDDEN</a:t>
+              <a:t>TALK TRACK — OPTIONAL BACKUP (not hidden; skip in main run)</a:t>
             </a:r>
           </a:p>
           <a:p>
@@ -3397,9 +3397,7 @@
               <a:t>This slide is a backup for questions about context selection. The main story already shows the concrete issue, ADR and scoped rules, which make the same point more directly.</a:t>
             </a:r>
           </a:p>
-          <a:p>
-            <a:endParaRPr/>
-          </a:p>
+          <a:p/>
           <a:p>
             <a:r>
               <a:t>DEMO — REPO / VS CODE</a:t>
@@ -3410,9 +3408,7 @@
               <a:t>If needed, compare the task contract with the service instruction file. Identify one relevant invariant and one unrelated file you intentionally do not load. There is no need for another live agent run.</a:t>
             </a:r>
           </a:p>
-          <a:p>
-            <a:endParaRPr/>
-          </a:p>
+          <a:p/>
           <a:p>
             <a:r>
               <a:t>DOCUMENTATION LINKS</a:t>
@@ -4487,7 +4483,7 @@
           </a:p>
           <a:p>
             <a:r>
-              <a:t>Issue #16 is open. Its implementation PR #27 at `bfb2cbf…` is draft: local validation passes 528 unit/10 PostgreSQL tests, but full validation reports 83 Zizmor findings. Hosted run `36705616895` fails repository-controls, human-review, and evidence; AC9 remains unproven. The local CLI canaries at predecessor `bb767fc…` prove identity binding only. Cloud canary PR #30 stopped because the task-contract artifact was absent. Local results do not imply hosted acceptance.</a:t>
+              <a:t>Issue #16 is open. Its implementation PR #27 is open/draft at `a5c64fc…` on base `2ce3cf8…`: local validation passes 535 unit/10 PostgreSQL tests, Fastify 5.12.5 has zero npm audit vulnerabilities, and full validation still reports 83 Zizmor findings. Hosted run `36873981770` passes plan, scope, quality, acceptance, dependency, CodeQL, secret, merge, and governance checks, but fails repository-controls, human-review, and evidence; `validation-authority` is missing and AC9 remains unproven. The local CLI canaries at predecessor `bb767fc…` prove identity binding only. Separate Cloud run `36869969461` at predecessor `b05b481` completed its Actions wrapper, but artifact-view attempts failed; it does not establish task-bound Cloud evidence. Local results do not imply hosted acceptance.</a:t>
             </a:r>
           </a:p>
           <a:p/>
@@ -4498,7 +4494,7 @@
           </a:p>
           <a:p>
             <a:r>
-              <a:t>Show current PR #19 and PR #27, identify each exact head/base before comparing results, and open the acceptance output and Zizmor report. PR #27 is open/draft, not closed; PR #19 is also draft/unaccepted. Do not suppress findings or present a green subset as overall acceptance.</a:t>
+              <a:t>Show current PR #19 and PR #27, identify each exact head/base before comparing results, and open the acceptance output and Zizmor report. PR #27 is draft, not closed; PR #19 is also draft/unaccepted. There is no current-head approval for PR #27. Do not suppress findings or present a green subset as overall acceptance.</a:t>
             </a:r>
           </a:p>
           <a:p/>
@@ -4895,7 +4891,7 @@
           </a:p>
           <a:p>
             <a:r>
-              <a:t>Issue #16 is open; approved plan PR #26 is open, and implementation PR #27 at `bfb2cbf…` is draft. Cloud canary PR #30 used predecessor base `bb767fc…` but stopped because `artifacts/task-contract.json` was absent. PR #32 attempted Issue #24 on that same Issue #16 base and is not valid Issue #24 evidence. No cloud parallel-isolation result or hosted acceptance is established.</a:t>
+              <a:t>Issue #16 is open; approved plan PR #26 is open, and implementation PR #27 is open/draft at `a5c64fc…` on base `2ce3cf8…`. Its local validation passes 535 unit/10 PostgreSQL tests; Fastify 5.12.5 has zero npm audit vulnerabilities, but full `validate:all` still reports 83 Zizmor findings. Hosted run `36873981770` fails repository-controls, human-review, and evidence; `validation-authority` is missing and AC9 remains unproven. Earlier Cloud canary PR #30 used predecessor base `bb767fc…` but stopped because `artifacts/task-contract.json` was absent. A separate Cloud run `36869969461` at predecessor `b05b481` completed its Actions wrapper, but artifact-view attempts failed; no bound Cloud result is inspectable. PR #32 attempted Issue #24 on that same Issue #16 base and is not valid Issue #24 evidence. No cloud parallel-isolation result or hosted acceptance is established.</a:t>
             </a:r>
           </a:p>
           <a:p/>
@@ -4958,7 +4954,7 @@
           </a:p>
           <a:p>
             <a:r>
-              <a:t>Synthetic concurrency tests and two local CLI identity canaries are not live cloud acceptance. PR #27 AC9 remains unproven; cloud task bootstrap lacked the contract artifact. PR #29 remains a wrong-base/no-change attempt.</a:t>
+              <a:t>Synthetic concurrency tests and two local CLI identity canaries are not live cloud acceptance. PR #27 AC9 remains unproven; Cloud run `36869969461` has no inspectable artifact result. PR #29 remains a wrong-base/no-change attempt.</a:t>
             </a:r>
           </a:p>
         </p:txBody>
@@ -5181,7 +5177,7 @@
           <a:lstStyle/>
           <a:p>
             <a:r>
-              <a:t>TALK TRACK — OPTIONAL, HIDDEN</a:t>
+              <a:t>TALK TRACK — OPTIONAL BACKUP (not hidden; skip in main run)</a:t>
             </a:r>
           </a:p>
           <a:p>
@@ -5194,9 +5190,7 @@
               <a:t>For this session I keep the main story on inspectable changes and their acceptance evidence. If we discuss operational metrics, I would start from the outcome we care about and then ask which signals actually explain it, rather than celebrating the largest activity counter.</a:t>
             </a:r>
           </a:p>
-          <a:p>
-            <a:endParaRPr/>
-          </a:p>
+          <a:p/>
           <a:p>
             <a:r>
               <a:t>DEMO — REPO / VS CODE</a:t>
@@ -5207,9 +5201,7 @@
               <a:t>No scheduled demo. If asked, distinguish application replay/conflict metrics from agent-session activity and from accepted changes. Do not invent productivity numbers.</a:t>
             </a:r>
           </a:p>
-          <a:p>
-            <a:endParaRPr/>
-          </a:p>
+          <a:p/>
           <a:p>
             <a:r>
               <a:t>DOCUMENTATION LINKS</a:t>
@@ -5445,7 +5437,7 @@
           <a:lstStyle/>
           <a:p>
             <a:r>
-              <a:t>TALK TRACK — OPTIONAL, HIDDEN</a:t>
+              <a:t>TALK TRACK — OPTIONAL BACKUP (not hidden; skip in main run)</a:t>
             </a:r>
           </a:p>
           <a:p>
@@ -5573,7 +5565,7 @@
           <a:lstStyle/>
           <a:p>
             <a:r>
-              <a:t>TALK TRACK — OPTIONAL, HIDDEN</a:t>
+              <a:t>TALK TRACK — OPTIONAL BACKUP (not hidden; skip in main run)</a:t>
             </a:r>
           </a:p>
           <a:p>
@@ -5586,9 +5578,7 @@
               <a:t>For the main story, the two risk-based workflows make the point more concretely. They let us discuss which action is authorized now, and what evidence would justify the next action.</a:t>
             </a:r>
           </a:p>
-          <a:p>
-            <a:endParaRPr/>
-          </a:p>
+          <a:p/>
           <a:p>
             <a:r>
               <a:t>DEMO — REPO / VS CODE</a:t>
@@ -5599,9 +5589,7 @@
               <a:t>No additional live run. Use the current plan, permission scope and acceptance checklist if someone asks where to begin adopting the patterns.</a:t>
             </a:r>
           </a:p>
-          <a:p>
-            <a:endParaRPr/>
-          </a:p>
+          <a:p/>
           <a:p>
             <a:r>
               <a:t>DOCUMENTATION LINKS</a:t>
@@ -6261,7 +6249,7 @@
           <a:lstStyle/>
           <a:p>
             <a:r>
-              <a:t>TALK TRACK — OPTIONAL, HIDDEN</a:t>
+              <a:t>TALK TRACK — OPTIONAL BACKUP (not hidden; skip in main run)</a:t>
             </a:r>
           </a:p>
           <a:p>
@@ -6274,9 +6262,7 @@
               <a:t>If we use it in questions, I would connect each capability to a concrete need: model choice, controlled tools, evidence, policy and operational support. I would not imply that a vendor feature list establishes the controls in a particular repository.</a:t>
             </a:r>
           </a:p>
-          <a:p>
-            <a:endParaRPr/>
-          </a:p>
+          <a:p/>
           <a:p>
             <a:r>
               <a:t>DEMO — REPO / VS CODE</a:t>
@@ -6287,9 +6273,7 @@
               <a:t>No scheduled demo. Use only if the audience asks how to evaluate a platform, and distinguish documented product capability from this repository's verified setup.</a:t>
             </a:r>
           </a:p>
-          <a:p>
-            <a:endParaRPr/>
-          </a:p>
+          <a:p/>
           <a:p>
             <a:r>
               <a:t>DOCUMENTATION LINKS</a:t>
@@ -6433,7 +6417,7 @@
           </a:p>
           <a:p>
             <a:r>
-              <a:t>Show open issues #4 and #17 and draft PR #19. Maintenance plans #15/#21/#23/#25/#26 remain open; implementation PRs #18/#27/#28 also remain open, with #27 and #28 draft/unaccepted. Only PR #13 and PR #29 are closed among the prior canaries. PR #19 at `cf762216` passes local PostgreSQL 12/12 and hosted human-review, but full validation has 86 Zizmor findings and repository-controls fails. PR #27 at `bfb2cbf…` passes local 528-unit/10-acceptance validation, but full validation has 83 Zizmor findings; hosted run `36705616895` is `review_required`, with AC9 unproven. PR #28 remains draft and unaccepted. Do not show a green status as acceptance.</a:t>
+              <a:t>Show open issues #4 and #17 and draft PR #19. Maintenance plans #15/#21/#23/#25/#26 remain open; PRs #21 and #23 are stale plan proposals, not accepted implementation. Implementation PRs #18/#27/#28 also remain open, with #27 and #28 draft/unaccepted. Only PR #13 and PR #29 are closed among the prior canaries. PR #19 at `cf762216` passes local PostgreSQL 12/12 and hosted human-review, but full validation has 86 Zizmor findings and repository-controls fails. PR #27 is now at `a5c64fc…` on base `2ce3cf8…`; it passes local 535-unit/10-acceptance validation, Fastify audit is clean, but full validation has 83 Zizmor findings. Hosted run `36873981770` is `review_required` with 9/10 criteria proven; repository-controls, human-review, and evidence fail, `validation-authority` is missing, and AC9 is unproven. PR #28 remains draft and unaccepted. Do not show a green status as acceptance.</a:t>
             </a:r>
           </a:p>
           <a:p/>
@@ -6444,7 +6428,7 @@
           </a:p>
           <a:p>
             <a:r>
-              <a:t>A fresh implementation review is requested on PR #27 head `bfb2cbf…`. Resolve the `repository-controls`, `human-review`, and `evidence` gates; `validation-authority` did not run. The cloud task-resolution canary stopped on absent `artifacts/task-contract.json`, and no successful cloud or VS Code delivery is proved. Do not change repository settings or rulesets without the required authorization.</a:t>
+              <a:t>A fresh independent implementation review is needed on PR #27 head `a5c64fc…`; the current-head human-review check found zero approvals. Resolve repository-controls and evidence through the proposed Issue #22/#24 approval sequence; do not change repository settings or rulesets until that sequence is approved and the required trusted authority is in place. `validation-authority` is missing. Cloud run `36869969461` at predecessor `b05b481` completed its wrapper but artifact-view attempts failed; no task-bound Cloud evidence or AC9 proof exists. The Issue #20 plan refresh produced no plan after a task-authority/skill denial; PR #21/#23 remain stale, so the 83 Zizmor findings are not yet remediated.</a:t>
             </a:r>
           </a:p>
           <a:p/>
@@ -6501,7 +6485,7 @@
           </a:p>
           <a:p>
             <a:r>
-              <a:t>PR #18 remains open and unaccepted; PR #19, #27, and #28 are open drafts. PR #15/#21/#23/#25/#26 are open plans; the required implementation and hosted acceptance steps remain pending. PR #13 and #29 are closed historical attempts, not accepted results. No hosted `ready_for_acceptance`, live VS Code delivery, or successful cloud-agent delivery is recorded.</a:t>
+              <a:t>PR #18 remains open and unaccepted; PRs #19, #27, and #28 are open drafts. PR #15/#21/#23/#25/#26 are open plans; #21 and #23 are stale. Required implementation and hosted acceptance steps remain pending. PR #13 and #29 are closed historical attempts, not accepted results. No hosted `ready_for_acceptance`, live VS Code delivery, or successful task-bound Cloud-agent delivery is recorded.</a:t>
             </a:r>
           </a:p>
         </p:txBody>
@@ -6594,7 +6578,7 @@
           <a:lstStyle/>
           <a:p>
             <a:r>
-              <a:t>TALK TRACK — OPTIONAL, HIDDEN</a:t>
+              <a:t>TALK TRACK — OPTIONAL BACKUP (not hidden; skip in main run)</a:t>
             </a:r>
           </a:p>
           <a:p>
@@ -6607,9 +6591,7 @@
               <a:t>For the main story I prefer the concrete missing-artifact defect. It makes the same point with evidence we can inspect, so this slide is kept as a discussion backup rather than another introduction.</a:t>
             </a:r>
           </a:p>
-          <a:p>
-            <a:endParaRPr/>
-          </a:p>
+          <a:p/>
           <a:p>
             <a:r>
               <a:t>DEMO — REPO / VS CODE</a:t>
@@ -6620,9 +6602,7 @@
               <a:t>No scheduled demo. If asked, return to the negative evidence test rather than inventing a productivity percentage.</a:t>
             </a:r>
           </a:p>
-          <a:p>
-            <a:endParaRPr/>
-          </a:p>
+          <a:p/>
           <a:p>
             <a:r>
               <a:t>DOCUMENTATION LINKS</a:t>
@@ -6947,7 +6927,7 @@
           </a:p>
           <a:p>
             <a:r>
-              <a:t>Here is the distinction I want to make visible: a repair candidate can pass application tests without becoming an accepted release. PR #18 remains open at `2ce3cf8…`, unmerged and unaccepted. Its PostgreSQL acceptance job passed, but human-review, repository-controls, and final trusted acceptance remain blocked; AC15 is unverified. PR #27 is also open, but draft. Its current candidate `bfb2cbf…` passes 528 unit and 10 PostgreSQL acceptance tests locally; full `validate:all` reports 83 Zizmor findings. Hosted run `36705616895` fails repository-controls, human-review, and evidence, and AC9 remains unproven. Neither is accepted; do not merge those facts into one green status.</a:t>
+              <a:t>Here is the distinction I want to make visible: a repair candidate can pass application tests without becoming an accepted release. PR #18 remains open at `2ce3cf8…`, unmerged and unaccepted. Its PostgreSQL acceptance job passed, but human-review, repository-controls, and final trusted acceptance remain blocked; AC15 is unverified. PR #27 is also open/draft, now at `a5c64fc…` on base `2ce3cf8…`. `npm run validate` passes 535 unit and 10 PostgreSQL acceptance tests locally. Fastify 5.12.5 has zero npm audit vulnerabilities; full `npm run validate:all` still reports 83 Zizmor findings. Hosted run `36873981770` passes plan-contract, plan-approval, scope, quality, acceptance, dependency-review, CodeQL, secret-scan, merge-validation, and governance, but fails repository-controls, human-review, and evidence. `validation-authority` is missing, and AC9 remains unproven. Neither PR is accepted; do not merge those facts into one green status.</a:t>
             </a:r>
           </a:p>
           <a:p/>
@@ -6958,7 +6938,7 @@
           </a:p>
           <a:p>
             <a:r>
-              <a:t>Show the open PR #18 and draft PR #27 as candidates, not closed historical examples. The two read-only CLI canaries ran at predecessor `bb767fc…` and proved task/contract/plan/base/session/owner identity only. Keep the current scanner result visible: Poutine reported zero findings; Zizmor reports 83 unsuppressed findings. The code on this slide is the historical missing-artifact check from audited baseline `b65c2de…`; it is an exact historical excerpt, not current implementation code. Do not present any PR as acceptance.</a:t>
+              <a:t>Show the open PR #18 and draft PR #27 as candidates, not closed historical examples. The two read-only CLI canaries ran at predecessor `bb767fc…` and proved task/contract/plan/base/session/owner identity only. Keep the current scanner result visible: Poutine reported zero findings; Zizmor reports 83 unsuppressed findings. Cloud run `36869969461` used predecessor `b05b481`; its wrapper completed, but artifact-view attempts failed, so it is not a task-bound Cloud result. The code on this slide is the historical missing-artifact check from audited baseline `b65c2de…`; it is an exact historical excerpt, not current implementation code. Do not present any PR as acceptance.</a:t>
             </a:r>
           </a:p>
           <a:p/>
@@ -7000,7 +6980,7 @@
           </a:p>
           <a:p>
             <a:r>
-              <a:t>PR #18 is open and unaccepted; its hosted acceptance job passed, while human-review, repository-controls, and final trusted acceptance are incomplete. PR #27 is open/draft at `bfb2cbf…`; local 528-unit/10-acceptance validation passes, full Zizmor reports 83, and hosted run `36705616895` is `review_required` with AC1–AC8/AC10 proven and AC9 unproven. Two CLI canaries at `bb767fc…` proved identity binding only. Cloud PR #30 stopped because `artifacts/task-contract.json` was absent; PR #29 was the separate wrong-base/no-change attempt. No hosted `ready_for_acceptance` is recorded.</a:t>
+              <a:t>PR #18 is open and unaccepted; its hosted acceptance job passed, while human-review, repository-controls, and final trusted acceptance are incomplete. PR #27 is open/draft at `a5c64fc…`; local 535-unit/10-acceptance validation passes, Fastify audit is clean, and full Zizmor reports 83. Hosted run `36873981770` is `review_required` (9/10 criteria proven): repository-controls, human-review, and evidence fail; `validation-authority` is missing and AC9 is unproven. Two CLI canaries at `bb767fc…` proved identity binding only. Cloud run `36869969461` at predecessor `b05b481` has no inspectable artifact result. No hosted `ready_for_acceptance` is recorded.</a:t>
             </a:r>
           </a:p>
         </p:txBody>
@@ -48162,7 +48142,7 @@
                 <a:ea typeface="Cascadia Mono" pitchFamily="34" charset="-122"/>
                 <a:cs typeface="Cascadia Mono" pitchFamily="34" charset="-120"/>
               </a:rPr>
-              <a:t>PR 27: 528 unit / 10 PostgreSQL PASS</a:t>
+              <a:t>PR 27: 535 unit / 10 PostgreSQL PASS</a:t>
             </a:r>
           </a:p>
           <a:p>

</xml_diff>

<commit_message>
docs: refresh cloud canary presentation evidence
Co-authored-by: Copilot App <223556219+Copilot@users.noreply.github.com>
</commit_message>
<xml_diff>
--- a/From-agents-to-engineering-systems.pptx
+++ b/From-agents-to-engineering-systems.pptx
@@ -6417,7 +6417,7 @@
           </a:p>
           <a:p>
             <a:r>
-              <a:t>Show open issues #4 and #17 and draft PR #19. Maintenance plans #15/#21/#23/#25/#26 remain open; PRs #21 and #23 are stale plan proposals, not accepted implementation. Implementation PRs #18/#27/#28 also remain open, with #27 and #28 draft/unaccepted. Only PR #13 and PR #29 are closed among the prior canaries. PR #19 at `cf762216` passes local PostgreSQL 12/12 and hosted human-review, but full validation has 86 Zizmor findings and repository-controls fails. PR #27 is now at `a5c64fc…` on base `2ce3cf8…`; it passes local 535-unit/10-acceptance validation, Fastify audit is clean, but full validation has 83 Zizmor findings. Hosted run `36873981770` is `review_required` with 9/10 criteria proven; repository-controls, human-review, and evidence fail, `validation-authority` is missing, and AC9 is unproven. PR #28 remains draft and unaccepted. Do not show a green status as acceptance.</a:t>
+              <a:t>Show open issues #4 and #17 and draft PR #19. Maintenance plans #15/#21/#23/#25/#26 remain open; PRs #21 and #23 are stale plan proposals, not accepted implementation. Implementation PRs #18/#27/#28 also remain open, with #27 and #28 draft/unaccepted. Only PR #13 and PR #29 are closed among the prior canaries. PR #19 at `cf762216` passes local PostgreSQL 12/12 and hosted human-review, but full validation has 86 Zizmor findings and repository-controls fails. PR #27 is at `a5c64fc…` on base `2ce3cf8…`; it passes local 535-unit/10-acceptance validation and Fastify audit is clean, but full validation has 83 Zizmor findings. Hosted run `36873981770` is `review_required` with 9/10 criteria proven; repository-controls, human-review, and evidence fail, `validation-authority` is missing, and AC9 is unproven. PR #28 is at `35ac911…` and remains draft. A fresh `npm run validate:all` after `npm ci` passed 525 unit tests and PostgreSQL acceptance 9/9, then stopped at npm audit with two high advisories: Fastify `&lt;=5.12.4` and `brace-expansion` `4.0.0–5.0.11`. Issue #24 prohibits manifest changes; no audit fix or acceptance is claimed. Hosted run `36635911460` fails human-review and repository-controls; its evidence check passes. Do not show a green subset as acceptance.</a:t>
             </a:r>
           </a:p>
           <a:p/>
@@ -6428,7 +6428,7 @@
           </a:p>
           <a:p>
             <a:r>
-              <a:t>A fresh independent implementation review is needed on PR #27 head `a5c64fc…`; the current-head human-review check found zero approvals. Resolve repository-controls and evidence through the proposed Issue #22/#24 approval sequence; do not change repository settings or rulesets until that sequence is approved and the required trusted authority is in place. `validation-authority` is missing. Cloud run `36869969461` at predecessor `b05b481` completed its wrapper but artifact-view attempts failed; no task-bound Cloud evidence or AC9 proof exists. The Issue #20 plan refresh produced no plan after a task-authority/skill denial; PR #21/#23 remain stale, so the 83 Zizmor findings are not yet remediated.</a:t>
+              <a:t>A fresh independent implementation review is needed on PR #27 head `a5c64fc…`; current-head human-review found zero approvals. PR #28 also needs review on its current head. Resolve repository-controls and evidence through the proposed Issue #22/#24 approval sequence; do not change repository settings or rulesets until that sequence is approved and trusted authority is in place. `validation-authority` is missing. Cloud run `36869969461` at predecessor `b05b481` completed its wrapper but artifact-view attempts failed. Later bounded canary run `36900971355` logged `npm run contract:fetch -- --issue 16` as successful but did not run the plan gate and published no artifacts. Run `36901509449` attempted only `npm run plan:gate -- --pr 27`; its bash tool call returned `success=false` without a recorded command result or reason, and it published no artifacts. Neither later run proves task/session/owner binding or AC9. The Issue #20 plan refresh produced no plan after the task-authority/skill denial; PR #21/#23 remain stale, so the Zizmor findings are not remediated.</a:t>
             </a:r>
           </a:p>
           <a:p/>
@@ -6485,7 +6485,7 @@
           </a:p>
           <a:p>
             <a:r>
-              <a:t>PR #18 remains open and unaccepted; PRs #19, #27, and #28 are open drafts. PR #15/#21/#23/#25/#26 are open plans; #21 and #23 are stale. Required implementation and hosted acceptance steps remain pending. PR #13 and #29 are closed historical attempts, not accepted results. No hosted `ready_for_acceptance`, live VS Code delivery, or successful task-bound Cloud-agent delivery is recorded.</a:t>
+              <a:t>PR #18 remains open and unaccepted; PRs #19, #27, and #28 are open drafts. PR #15/#21/#23/#25/#26 are open plans; #21 and #23 are stale. Required implementation and hosted acceptance steps remain pending. PR #13 and #29 are closed historical attempts, not accepted results. No hosted `ready_for_acceptance`, live VS Code execution, or successful task-bound Cloud-agent delivery is recorded.</a:t>
             </a:r>
           </a:p>
         </p:txBody>

</xml_diff>

<commit_message>
docs: sync deck with PR 27 hosted evidence
Co-authored-by: Copilot App <223556219+Copilot@users.noreply.github.com>
</commit_message>
<xml_diff>
--- a/From-agents-to-engineering-systems.pptx
+++ b/From-agents-to-engineering-systems.pptx
@@ -6412,23 +6412,35 @@
           <a:p/>
           <a:p>
             <a:r>
-              <a:t>DEMO — REPO / VS CODE</a:t>
-            </a:r>
-          </a:p>
-          <a:p>
-            <a:r>
-              <a:t>Show open issues #4 and #17 and draft PR #19. Maintenance plans #15/#21/#23/#25/#26 remain open; PRs #21 and #23 are stale plan proposals, not accepted implementation. Implementation PRs #18/#27/#28 also remain open, with #27 and #28 draft/unaccepted. Only PR #13 and PR #29 are closed among the prior canaries. PR #19 at `cf762216` passes local PostgreSQL 12/12 and hosted human-review, but full validation has 86 Zizmor findings and repository-controls fails. PR #27 is at `a5c64fc…` on base `2ce3cf8…`; it passes local 535-unit/10-acceptance validation and Fastify audit is clean, but full validation has 83 Zizmor findings. Hosted run `36873981770` is `review_required` with 9/10 criteria proven; repository-controls, human-review, and evidence fail, `validation-authority` is missing, and AC9 is unproven. PR #28 is at `35ac911…` and remains draft. A fresh `npm run validate:all` after `npm ci` passed 525 unit tests and PostgreSQL acceptance 9/9, then stopped at npm audit with two high advisories: Fastify `&lt;=5.12.4` and `brace-expansion` `4.0.0–5.0.11`. Issue #24 prohibits manifest changes; no audit fix or acceptance is claimed. Hosted run `36635911460` fails human-review and repository-controls; its evidence check passes. Do not show a green subset as acceptance.</a:t>
+              <a:t>DEMO - REPO / VS CODE</a:t>
+            </a:r>
+          </a:p>
+          <a:p>
+            <a:r>
+              <a:t>Show open issues #4 and #17 and draft PR #19. Maintenance plans #15, #21, #23, #25, and #26 remain open; plans #21 and #23 are stale. PRs #18, #27, and #28 remain open; #27 and #28 are draft/unaccepted. PR #19 at `cf762216` has local PostgreSQL acceptance 12/12 and hosted human-review, but full validation has 86 Zizmor findings, repository-controls fails, and its base is stale.</a:t>
             </a:r>
           </a:p>
           <a:p/>
           <a:p>
             <a:r>
+              <a:t>PR #27 is now at `92a8af62939847c0ba3120128afbb3129a12cab6` on base `2ce3cf8`. Local validation passes 535 unit tests and 10 PostgreSQL acceptance tests; audit reports zero vulnerabilities. Full `validate:all` reports 83 Zizmor findings. Hosted run `36929325151` passes plan-contract, plan-approval, scope, quality, acceptance, dependency-review, CodeQL, secret-scan, merge-validation, and governance; repository-controls, human-review, and evidence fail. The approvals visible on the PR predate this head, `validation-authority` is absent, and the report is `review_required` with 9/10 criteria proven; AC9 remains unproven.</a:t>
+            </a:r>
+          </a:p>
+          <a:p/>
+          <a:p>
+            <a:r>
+              <a:t>PR #28 remains draft at `35ac911` and needs current-head review; repository-controls fails. A fresh `validate:all` on that candidate previously stopped at npm audit with two high advisories; Issue #24 prohibits manifest changes. Issue #20 plan PR #21 and Issue #22 plan PR #23 remain tied to stale base `17e7a5c`; the Issue #20 refresh must wait for its #22 prerequisite. No settings or rulesets changed.</a:t>
+            </a:r>
+          </a:p>
+          <a:p/>
+          <a:p>
+            <a:r>
               <a:t>NEXT ACTION</a:t>
             </a:r>
           </a:p>
           <a:p>
             <a:r>
-              <a:t>A fresh independent implementation review is needed on PR #27 head `a5c64fc…`; current-head human-review found zero approvals. PR #28 also needs review on its current head. Resolve repository-controls and evidence through the proposed Issue #22/#24 approval sequence; do not change repository settings or rulesets until that sequence is approved and trusted authority is in place. `validation-authority` is missing. Cloud run `36869969461` at predecessor `b05b481` completed its wrapper but artifact-view attempts failed. Later bounded canary run `36900971355` logged `npm run contract:fetch -- --issue 16` as successful but did not run the plan gate and published no artifacts. Run `36901509449` attempted only `npm run plan:gate -- --pr 27`; its bash tool call returned `success=false` without a recorded command result or reason, and it published no artifacts. Neither later run proves task/session/owner binding or AC9. The Issue #20 plan refresh produced no plan after the task-authority/skill denial; PR #21/#23 remain stale, so the Zizmor findings are not remediated.</a:t>
+              <a:t>An independent review of exact PR #27 head `92a8af6` is needed; a reviewer is requested, but existing approvals target older commits. Resolve repository-controls and evidence through the approved Issue #22/#24 sequence; do not change rulesets, permissions, or secrets outside that plan. Do not spend another Cloud retry without a classified failure and remaining repair budget. AC9 is still open. No hosted `ready_for_acceptance` or live VS Code execution exists.</a:t>
             </a:r>
           </a:p>
           <a:p/>
@@ -6485,7 +6497,7 @@
           </a:p>
           <a:p>
             <a:r>
-              <a:t>PR #18 remains open and unaccepted; PRs #19, #27, and #28 are open drafts. PR #15/#21/#23/#25/#26 are open plans; #21 and #23 are stale. Required implementation and hosted acceptance steps remain pending. PR #13 and #29 are closed historical attempts, not accepted results. No hosted `ready_for_acceptance`, live VS Code execution, or successful task-bound Cloud-agent delivery is recorded.</a:t>
+              <a:t>PR #18 remains open and unaccepted. PR #19, #27, and #28 are open drafts. PR #15/#21/#23/#25/#26 are open plan PRs; #21 and #23 are stale. Required implementation and hosted acceptance steps remain pending. PR #13 and #29 are closed historical attempts. No hosted `ready_for_acceptance`, live VS Code execution, or successful task-bound Cloud-agent delivery is recorded.</a:t>
             </a:r>
           </a:p>
         </p:txBody>
@@ -6927,18 +6939,18 @@
           </a:p>
           <a:p>
             <a:r>
-              <a:t>Here is the distinction I want to make visible: a repair candidate can pass application tests without becoming an accepted release. PR #18 remains open at `2ce3cf8…`, unmerged and unaccepted. Its PostgreSQL acceptance job passed, but human-review, repository-controls, and final trusted acceptance remain blocked; AC15 is unverified. PR #27 is also open/draft, now at `a5c64fc…` on base `2ce3cf8…`. `npm run validate` passes 535 unit and 10 PostgreSQL acceptance tests locally. Fastify 5.12.5 has zero npm audit vulnerabilities; full `npm run validate:all` still reports 83 Zizmor findings. Hosted run `36873981770` passes plan-contract, plan-approval, scope, quality, acceptance, dependency-review, CodeQL, secret-scan, merge-validation, and governance, but fails repository-controls, human-review, and evidence. `validation-authority` is missing, and AC9 remains unproven. Neither PR is accepted; do not merge those facts into one green status.</a:t>
+              <a:t>A repair candidate can pass application tests without becoming an accepted release. PR #18 remains open at `2ce3cf8`, unmerged and unaccepted; its PostgreSQL acceptance passed, but human-review, repository-controls, and trusted acceptance remain blocked, and AC15 is unverified. PR #27 is open/draft at `92a8af6` on base `2ce3cf8`. The published Cloud identity fix removes only the Bot-author and `copilot/`-branch-prefix requirements; it still binds the live same-repository PR to Issue #16, approved plan #26, exact base/head, branch, and ancestry. Local validation passes 535 unit tests, 10 PostgreSQL acceptance tests, 79 governance checks, and npm audit; `validate:all` still reports 83 Zizmor findings.</a:t>
             </a:r>
           </a:p>
           <a:p/>
           <a:p>
             <a:r>
-              <a:t>DEMO — REPO / VS CODE</a:t>
-            </a:r>
-          </a:p>
-          <a:p>
-            <a:r>
-              <a:t>Show the open PR #18 and draft PR #27 as candidates, not closed historical examples. The two read-only CLI canaries ran at predecessor `bb767fc…` and proved task/contract/plan/base/session/owner identity only. Keep the current scanner result visible: Poutine reported zero findings; Zizmor reports 83 unsuppressed findings. Cloud run `36869969461` used predecessor `b05b481`; its wrapper completed, but artifact-view attempts failed, so it is not a task-bound Cloud result. The code on this slide is the historical missing-artifact check from audited baseline `b65c2de…`; it is an exact historical excerpt, not current implementation code. Do not present any PR as acceptance.</a:t>
+              <a:t>DEMO - REPO / VS CODE</a:t>
+            </a:r>
+          </a:p>
+          <a:p>
+            <a:r>
+              <a:t>Show PR #18 and draft PR #27 as candidates, not accepted releases. The two read-only CLI canaries at predecessor `bb767fc` prove task/contract/plan/base/session/owner identity only. Hosted run `36929325151` at `92a8af6` passes plan-contract, plan-approval, scope, quality, acceptance, dependency-review, CodeQL, secret-scan, merge-validation, and governance; it fails repository-controls, human-review, and evidence. The visible approvals target older commits, `validation-authority` is absent, and AC9 remains unproven. The Copilot Cloud runs `36900971355` and `36901509449` were earlier bounded canaries at `a5c64fc`; neither produced task-bound Cloud evidence. The code shown is the historical missing-artifact check from audited baseline `b65c2de`, not the current implementation.</a:t>
             </a:r>
           </a:p>
           <a:p/>
@@ -6980,7 +6992,7 @@
           </a:p>
           <a:p>
             <a:r>
-              <a:t>PR #18 is open and unaccepted; its hosted acceptance job passed, while human-review, repository-controls, and final trusted acceptance are incomplete. PR #27 is open/draft at `a5c64fc…`; local 535-unit/10-acceptance validation passes, Fastify audit is clean, and full Zizmor reports 83. Hosted run `36873981770` is `review_required` (9/10 criteria proven): repository-controls, human-review, and evidence fail; `validation-authority` is missing and AC9 is unproven. Two CLI canaries at `bb767fc…` proved identity binding only. Cloud run `36869969461` at predecessor `b05b481` has no inspectable artifact result. No hosted `ready_for_acceptance` is recorded.</a:t>
+              <a:t>PR #18 is open and unaccepted. PR #27 is published at `92a8af6`, but remains draft and unaccepted. Its hosted report is `review_required` with 9/10 criteria proven; repository-controls, human-review, and evidence fail; AC9 remains unproven. No hosted `ready_for_acceptance`, live VS Code run, or successful task-bound Cloud-agent delivery is recorded.</a:t>
             </a:r>
           </a:p>
         </p:txBody>

</xml_diff>

<commit_message>
docs: sync evidence with PR 27 session identity fix
Co-authored-by: Copilot App <223556219+Copilot@users.noreply.github.com>
</commit_message>
<xml_diff>
--- a/From-agents-to-engineering-systems.pptx
+++ b/From-agents-to-engineering-systems.pptx
@@ -6423,24 +6423,30 @@
           <a:p/>
           <a:p>
             <a:r>
-              <a:t>PR #27 is now at `92a8af62939847c0ba3120128afbb3129a12cab6` on base `2ce3cf8`. Local validation passes 535 unit tests and 10 PostgreSQL acceptance tests; audit reports zero vulnerabilities. Full `validate:all` reports 83 Zizmor findings. Hosted run `36929325151` passes plan-contract, plan-approval, scope, quality, acceptance, dependency-review, CodeQL, secret-scan, merge-validation, and governance; repository-controls, human-review, and evidence fail. The approvals visible on the PR predate this head, `validation-authority` is absent, and the report is `review_required` with 9/10 criteria proven; AC9 remains unproven.</a:t>
+              <a:t>PR #27 is now at `f1c40a961451d29fed04ac37ad01eb63ddec076d` on base `2ce3cf8`. Local validation passes 541 unit and 10 PostgreSQL acceptance tests; audit reports zero vulnerabilities. Full `validate:all` reports 83 Zizmor findings. Hosted run `36934750341` passes plan-contract, plan-approval, scope, quality, acceptance, dependency review, CodeQL, secret scan, merge-validation, and governance; repository-controls, human-review, and evidence fail. Existing approvals predate this head, `validation-authority` is absent, and the report is `review_required` with 9/10 criteria proven; AC9 is unproven.</a:t>
             </a:r>
           </a:p>
           <a:p/>
           <a:p>
             <a:r>
-              <a:t>PR #28 remains draft at `35ac911` and needs current-head review; repository-controls fails. A fresh `validate:all` on that candidate previously stopped at npm audit with two high advisories; Issue #24 prohibits manifest changes. Issue #20 plan PR #21 and Issue #22 plan PR #23 remain tied to stale base `17e7a5c`; the Issue #20 refresh must wait for its #22 prerequisite. No settings or rulesets changed.</a:t>
+              <a:t>The implementation now resolves session IDs consistently across task hooks and CLI entry points. A local Cloud-shaped simulation with a missing event payload ID and a host-environment ID passes SessionStart, PreToolUse, and `plan:gate`; this is not Cloud host evidence. The latest actual Cloud run `36930550238` on predecessor `92a8af6` still returned `success=false` for plan-gate without details or artifacts, before the session-identity fallback was published. No further Cloud retry was made because the failure remains opaque and the bounded retry policy applies.</a:t>
             </a:r>
           </a:p>
           <a:p/>
           <a:p>
             <a:r>
+              <a:t>PR #28 remains draft at `35ac911`; its current-head review and repository-controls are still outstanding. PR #21 and #23 remain stale plan proposals. No rules, permissions, secrets, or protected environments changed.</a:t>
+            </a:r>
+          </a:p>
+          <a:p/>
+          <a:p>
+            <a:r>
               <a:t>NEXT ACTION</a:t>
             </a:r>
           </a:p>
           <a:p>
             <a:r>
-              <a:t>An independent review of exact PR #27 head `92a8af6` is needed; a reviewer is requested, but existing approvals target older commits. Resolve repository-controls and evidence through the approved Issue #22/#24 sequence; do not change rulesets, permissions, or secrets outside that plan. Do not spend another Cloud retry without a classified failure and remaining repair budget. AC9 is still open. No hosted `ready_for_acceptance` or live VS Code execution exists.</a:t>
+              <a:t>An independent review of exact PR #27 head `f1c40a9` is needed; the reviewer request exists, but visible approvals target older commits. Resolve repository-controls and evidence through the approved Issue #22/#24 sequence; do not change settings outside that plan. Zizmor remediation remains blocked until Issue #20's plan is refreshed on the authorized base and independently approved. No hosted `ready_for_acceptance` or live VS Code execution exists.</a:t>
             </a:r>
           </a:p>
           <a:p/>
@@ -6497,7 +6503,7 @@
           </a:p>
           <a:p>
             <a:r>
-              <a:t>PR #18 remains open and unaccepted. PR #19, #27, and #28 are open drafts. PR #15/#21/#23/#25/#26 are open plan PRs; #21 and #23 are stale. Required implementation and hosted acceptance steps remain pending. PR #13 and #29 are closed historical attempts. No hosted `ready_for_acceptance`, live VS Code execution, or successful task-bound Cloud-agent delivery is recorded.</a:t>
+              <a:t>PR #18 remains open and unaccepted. PR #19, #27, and #28 are open drafts. PR #15/#21/#23/#25/#26 are open plan PRs; #21 and #23 are stale. PR #27 has local unit/acceptance evidence, but hosted controls/review/evidence still block acceptance. PR #13 and #29 are closed historical attempts. No hosted `ready_for_acceptance`, live VS Code execution, or successful task-bound Cloud-agent delivery is recorded.</a:t>
             </a:r>
           </a:p>
         </p:txBody>
@@ -6939,18 +6945,24 @@
           </a:p>
           <a:p>
             <a:r>
-              <a:t>A repair candidate can pass application tests without becoming an accepted release. PR #18 remains open at `2ce3cf8`, unmerged and unaccepted; its PostgreSQL acceptance passed, but human-review, repository-controls, and trusted acceptance remain blocked, and AC15 is unverified. PR #27 is open/draft at `92a8af6` on base `2ce3cf8`. The published Cloud identity fix removes only the Bot-author and `copilot/`-branch-prefix requirements; it still binds the live same-repository PR to Issue #16, approved plan #26, exact base/head, branch, and ancestry. Local validation passes 535 unit tests, 10 PostgreSQL acceptance tests, 79 governance checks, and npm audit; `validate:all` still reports 83 Zizmor findings.</a:t>
+              <a:t>A repair candidate can pass application tests without becoming an accepted release. PR #18 remains open at `2ce3cf8`, unmerged and unaccepted; its PostgreSQL acceptance passed, but human-review, repository-controls, and trusted acceptance remain blocked, and AC15 is unverified. PR #27 is now open/draft at `f1c40a9` on base `2ce3cf8`. Local validation passes 541 unit tests, 10 PostgreSQL acceptance tests, and 79 governance checks; npm audit reports zero vulnerabilities. Full `npm run validate:all` still fails on 83 Zizmor findings.</a:t>
             </a:r>
           </a:p>
           <a:p/>
           <a:p>
             <a:r>
+              <a:t>The Cloud resolver no longer requires a Bot author or a `copilot/` branch prefix. SessionStart, UserPromptSubmit, PreToolUse, audit/Stop hooks, and CLI entry points now resolve session identity consistently from the event payload, Copilot host environment, or a GitHub Actions repository/run/attempt identity. A local Cloud-shaped simulation with no session ID in the event payload resolved the task, plan, PR, base/head, and owner; PreToolUse allowed the approved plan gate. This is local hook-path evidence, not a successful Cloud session.</a:t>
+            </a:r>
+          </a:p>
+          <a:p/>
+          <a:p>
+            <a:r>
               <a:t>DEMO - REPO / VS CODE</a:t>
             </a:r>
           </a:p>
           <a:p>
             <a:r>
-              <a:t>Show PR #18 and draft PR #27 as candidates, not accepted releases. The two read-only CLI canaries at predecessor `bb767fc` prove task/contract/plan/base/session/owner identity only. Hosted run `36929325151` at `92a8af6` passes plan-contract, plan-approval, scope, quality, acceptance, dependency-review, CodeQL, secret-scan, merge-validation, and governance; it fails repository-controls, human-review, and evidence. The visible approvals target older commits, `validation-authority` is absent, and AC9 remains unproven. The Copilot Cloud runs `36900971355` and `36901509449` were earlier bounded canaries at `a5c64fc`; neither produced task-bound Cloud evidence. The code shown is the historical missing-artifact check from audited baseline `b65c2de`, not the current implementation.</a:t>
+              <a:t>Show PR #18 and draft PR #27 as candidates, not accepted releases. Hosted run `36934750341` on `f1c40a9` passes plan-contract, plan-approval, scope, quality, acceptance, dependency review, CodeQL, secret scan, merge-validation, and governance. It fails repository-controls, human-review, and evidence; visible approvals target older commits, `validation-authority` is absent, and the report is `review_required` with 9/10 criteria proven. AC9 remains unproven. Cloud run `36930550238` on predecessor `92a8af6` attempted the plan gate but its bash tool returned `success=false` without command output or artifacts. No Cloud session has tested the session-identity fallback. The code shown is the historical missing-artifact check from baseline `b65c2de`, not current implementation code.</a:t>
             </a:r>
           </a:p>
           <a:p/>
@@ -6992,7 +7004,7 @@
           </a:p>
           <a:p>
             <a:r>
-              <a:t>PR #18 is open and unaccepted. PR #27 is published at `92a8af6`, but remains draft and unaccepted. Its hosted report is `review_required` with 9/10 criteria proven; repository-controls, human-review, and evidence fail; AC9 remains unproven. No hosted `ready_for_acceptance`, live VS Code run, or successful task-bound Cloud-agent delivery is recorded.</a:t>
+              <a:t>PR #18 remains open and unaccepted. PR #27 is published at `f1c40a9`, but remains draft and unaccepted. Hosted run `36934750341` is `review_required` with 9/10 criteria proven; repository-controls, human-review, and evidence fail; AC9 remains unproven. No hosted `ready_for_acceptance`, live VS Code run, or successful task-bound Cloud-agent delivery is recorded.</a:t>
             </a:r>
           </a:p>
         </p:txBody>

</xml_diff>

<commit_message>
docs: refresh Northstar conformance and deck evidence
Co-authored-by: Copilot App <223556219+Copilot@users.noreply.github.com>
</commit_message>
<xml_diff>
--- a/From-agents-to-engineering-systems.pptx
+++ b/From-agents-to-engineering-systems.pptx
@@ -2669,18 +2669,18 @@
           </a:p>
           <a:p>
             <a:r>
-              <a:t>We will compare plan-first idempotency with a plan + execution endpoint. Same plan → act → evaluate system, different timing of human validation. I will keep application behavior, local tests, hosted policy, and live agent evidence distinct.</a:t>
+              <a:t>We will compare plan-first idempotency with a plan + execution endpoint. It is the same plan, act, evaluate system with different timing of human validation. Keep application behavior, local tests, hosted policy, and live agent evidence distinct.</a:t>
             </a:r>
           </a:p>
           <a:p/>
           <a:p>
             <a:r>
-              <a:t>DEMO — REPO / VS CODE</a:t>
-            </a:r>
-          </a:p>
-          <a:p>
-            <a:r>
-              <a:t>Open the WI-1843 task worktree at PR #19 head `cf762216` and verify `docs/demos/README.md` there. Show the WI-1842 and WI-1843 runbooks and open issues #4 and #17. PR #13 and PR #29 are closed historical attempts; PRs #15, #18, #21, #23, #25, #26, #27, and #28 are open maintenance items. PR #27 and #28 are draft implementations; none is accepted. Do not present an open PR or approved plan as implementation acceptance.</a:t>
+              <a:t>DEMO - REPO / VS CODE</a:t>
+            </a:r>
+          </a:p>
+          <a:p>
+            <a:r>
+              <a:t>Open the WI-1843 task worktree at PR #19 head `cf762216` and verify `docs/demos/README.md` there. Show the WI-1842 and WI-1843 runbooks and open issues #4 and #17. PR #13 and PR #29 are closed historical attempts; PRs #15, #18, #21, #23, #25, #26, #27, and #28 are open maintenance items. PR #27 and #28 are draft implementations; neither is accepted. PR #27 is at `f1c40a9` and has current-head approval. PR #28 is at `cb507e2` and needs a fresh current-head review. Do not present an open PR or approved plan as implementation acceptance.</a:t>
             </a:r>
           </a:p>
           <a:p/>
@@ -2716,6 +2716,11 @@
           </a:p>
           <a:p>
             <a:r>
+              <a:t>https://github.com/webmaxru/northstar-orders-api-demo/pull/28</a:t>
+            </a:r>
+          </a:p>
+          <a:p>
+            <a:r>
               <a:t>https://learn.microsoft.com/en-us/training/modules/design-agent-architecture-integration/4-plan-reason-execution</a:t>
             </a:r>
           </a:p>
@@ -2727,7 +2732,7 @@
           </a:p>
           <a:p>
             <a:r>
-              <a:t>Northstar main remains the known-defective baseline `b65c2de…`; the inert framework snapshot tracks candidate `bfb2cbf…` but remains `known-defective`, and conformance remains blocked. PR #18 is open at `2ce3cf8…`, unmerged and unaccepted; its local validation passed 489 unit/9 PostgreSQL tests, but hosted human-review, controls, and final trusted acceptance remain unresolved and AC15 is unverified. PR #19 is open/draft at `cf762216`, based on older `17e7a5c…`; its local 470 unit/12 PostgreSQL tests and human-review pass, but Zizmor reports 86 findings and repository-controls fails. PR #27 is open/draft at `a5c64fc…`, based on `2ce3cf8…`; `npm run validate` passes 535 unit and 10 PostgreSQL acceptance tests. Fastify 5.12.5 has zero npm audit vulnerabilities. `npm run validate:all` still fails with 83 Zizmor findings. Hosted run `36873981770` passes plan-contract, plan-approval, scope, quality, acceptance, dependency-review, CodeQL, secret-scan, merge-validation, and governance; it fails repository-controls, human-review (zero approvals on this head), and evidence. `validation-authority` is missing; the report is `review_required`, 9/10 criteria proven, with AC9 unproven. Separate Cloud run `36869969461` used predecessor `b05b481`; its Actions wrapper completed, but artifact-view attempts failed, so no bound Cloud result is established. PR #28 remains open/draft and unaccepted. PR #13 and #29 are closed; #29 used `main` and made no source changes. Earlier Cloud canary PR #30 stopped because the task-contract artifact was absent. No live VS Code or successful Cloud delivery is established.</a:t>
+              <a:t>Northstar main remains the known-defective baseline `b65c2de5c8224342c72c37eeed7ef9f965ad8a2c`; the inert framework snapshot tracks candidate `bfb2cbf1d0f488ced1595f100c14ed8e312bb1f7` but remains `known-defective`, and conformance remains blocked. PR #18 is open at `2ce3cf8`, unmerged and unaccepted; its local validation passed 489 unit/9 PostgreSQL tests, but hosted human-review, controls, and trusted acceptance remain unresolved and AC15 is unverified. PR #19 is open/draft at `cf762216`, based on older `17e7a5c`; its local 470 unit/12 PostgreSQL tests pass, but repository-controls fails and no hosted delivery is accepted. PR #27 is open/draft at `f1c40a9`, based on `2ce3cf8`; local validation passes 541 unit and 10 PostgreSQL acceptance tests, and npm audit reports zero vulnerabilities. Full `validate:all` still fails with 83 Zizmor findings. Hosted run `36984950941` passes current-head human-review and core checks but fails repository-controls/evidence; `validation-authority` is missing, AC9 is unproven, and the report is `review_required` with 9/10 criteria proven. PR #28 is open/draft at `cb507e2`; local `validate` passes 527 unit and 9 PostgreSQL acceptance tests, but full `validate:all` stops on two high dependency advisories inherited from its base. Hosted run `36990391843` fails dependency-review, repository-controls, current-head human-review, and evidence. No accepted Cloud or VS Code delivery is established. PR #13 and #29 are closed; #29 used `main` and made no source changes. No rules, permissions, secrets, or protected environments changed.</a:t>
             </a:r>
           </a:p>
         </p:txBody>
@@ -4478,23 +4483,23 @@
           </a:p>
           <a:p>
             <a:r>
-              <a:t>The endpoint candidate PR #19 at `cf762216` is locally proven by 470 unit tests, 12 PostgreSQL acceptance tests, scope, and merge checks. Full `validate:all` fails on 86 Zizmor findings; Poutine reports zero findings. Hosted human-review passes, but repository-controls fails. Its issue/plan/base `17e7a5c…` is older than current PR #18 head `2ce3cf8…`, so no hosted acceptance is claimed.</a:t>
-            </a:r>
-          </a:p>
-          <a:p>
-            <a:r>
-              <a:t>Issue #16 is open. Its implementation PR #27 is open/draft at `a5c64fc…` on base `2ce3cf8…`: local validation passes 535 unit/10 PostgreSQL tests, Fastify 5.12.5 has zero npm audit vulnerabilities, and full validation still reports 83 Zizmor findings. Hosted run `36873981770` passes plan, scope, quality, acceptance, dependency, CodeQL, secret, merge, and governance checks, but fails repository-controls, human-review, and evidence; `validation-authority` is missing and AC9 remains unproven. The local CLI canaries at predecessor `bb767fc…` prove identity binding only. Separate Cloud run `36869969461` at predecessor `b05b481` completed its Actions wrapper, but artifact-view attempts failed; it does not establish task-bound Cloud evidence. Local results do not imply hosted acceptance.</a:t>
+              <a:t>The endpoint candidate PR #19 at `cf762216` is locally validated by 470 unit tests, 12 PostgreSQL acceptance tests, scope, and merge checks. Full `validate:all` fails on 86 Zizmor findings; Poutine reports zero findings. Hosted human-review passes, but repository-controls fails. Its issue/plan/base `17e7a5c` is older than current PR #18 head `2ce3cf8`, so no hosted acceptance is claimed.</a:t>
+            </a:r>
+          </a:p>
+          <a:p>
+            <a:r>
+              <a:t>Issue #16 is open. Its implementation PR #27 is open/draft at `f1c40a9` on base `2ce3cf8`: local validation passes 541 unit/10 PostgreSQL tests, Fastify 5.12.5 has zero npm audit vulnerabilities, and full `validate:all` still reports 83 Zizmor findings. `vibeprogrammer` approved this exact head. Hosted run `36984950941` passes current-head human-review and core checks, but fails repository-controls and evidence; `validation-authority` is missing and AC9 remains unproven. The local CLI canaries at predecessor `bb767fc` prove identity binding only. Cloud run `36930550238` on predecessor `92a8af6` returned `success=false` without inspectable output; no actual Cloud run tested the fallback. Local results do not imply hosted acceptance.</a:t>
             </a:r>
           </a:p>
           <a:p/>
           <a:p>
             <a:r>
-              <a:t>DEMO — REPO / VS CODE</a:t>
-            </a:r>
-          </a:p>
-          <a:p>
-            <a:r>
-              <a:t>Show current PR #19 and PR #27, identify each exact head/base before comparing results, and open the acceptance output and Zizmor report. PR #27 is draft, not closed; PR #19 is also draft/unaccepted. There is no current-head approval for PR #27. Do not suppress findings or present a green subset as overall acceptance.</a:t>
+              <a:t>DEMO - REPO / VS CODE</a:t>
+            </a:r>
+          </a:p>
+          <a:p>
+            <a:r>
+              <a:t>Show current PR #19 and PR #27, identify each exact head/base before comparing results, and open the acceptance output and Zizmor report. PR #27 is draft and has current-head approval, not acceptance; PR #19 is also draft/unaccepted. Do not suppress findings or present a green subset as overall acceptance.</a:t>
             </a:r>
           </a:p>
           <a:p/>
@@ -4886,23 +4891,28 @@
           </a:p>
           <a:p>
             <a:r>
-              <a:t>A plan on a separate worktree can be useful, but a green local identity result is not cloud acceptance. Two read-only Copilot CLI canaries at predecessor `bb767fc…` resolved issue #16, its contract, approved plan, base, session, and distinct workspace-owner identities. They made no source changes and did not prove write authorization, Stop behavior, recovery, VS Code behavior, or cloud isolation.</a:t>
-            </a:r>
-          </a:p>
-          <a:p>
-            <a:r>
-              <a:t>Issue #16 is open; approved plan PR #26 is open, and implementation PR #27 is open/draft at `a5c64fc…` on base `2ce3cf8…`. Its local validation passes 535 unit/10 PostgreSQL tests; Fastify 5.12.5 has zero npm audit vulnerabilities, but full `validate:all` still reports 83 Zizmor findings. Hosted run `36873981770` fails repository-controls, human-review, and evidence; `validation-authority` is missing and AC9 remains unproven. Earlier Cloud canary PR #30 used predecessor base `bb767fc…` but stopped because `artifacts/task-contract.json` was absent. A separate Cloud run `36869969461` at predecessor `b05b481` completed its Actions wrapper, but artifact-view attempts failed; no bound Cloud result is inspectable. PR #32 attempted Issue #24 on that same Issue #16 base and is not valid Issue #24 evidence. No cloud parallel-isolation result or hosted acceptance is established.</a:t>
+              <a:t>A plan on a separate worktree can be useful, but a green local identity result is not cloud acceptance. Two read-only Copilot CLI canaries at predecessor `bb767fc` resolved issue #16, its contract, approved plan, base, session, and distinct workspace-owner identities. They made no source changes and did not prove write authorization, Stop behavior, recovery, VS Code behavior, or cloud isolation.</a:t>
+            </a:r>
+          </a:p>
+          <a:p>
+            <a:r>
+              <a:t>Issue #16 is open; approved plan PR #26 is open, and implementation PR #27 is open/draft at `f1c40a9` on base `2ce3cf8`. Its local validation passes 541 unit/10 PostgreSQL tests; Fastify 5.12.5 has zero npm audit vulnerabilities, but full `validate:all` still reports 83 Zizmor findings. `vibeprogrammer` approved this exact head. Hosted run `36984950941` passes current-head human-review and core checks but fails repository-controls/evidence; `validation-authority` is missing, the report is `review_required`, and AC9 remains unproven. Earlier Cloud canary PR #30 used predecessor base `bb767fc` but stopped because `artifacts/task-contract.json` was absent. Cloud run `36930550238` on predecessor `92a8af6` returned `success=false` without an inspectable result; no bound Cloud result is established for `f1c40a9`.</a:t>
+            </a:r>
+          </a:p>
+          <a:p>
+            <a:r>
+              <a:t>Issue #24 PR #28 is at `cb507e2` on base `2ce3cf8`; its refreshed plan PR #25 is approved. Local validation passes 527 unit/9 PostgreSQL tests, but the hosted run `36990391843` fails dependency-review, repository-controls, current-head human-review, and evidence. The inherited dependencies cannot be changed under the approved Issue #24 scope. PR #32 attempted Issue #24 on an older Issue #16 base and is not valid Issue #24 evidence. No cloud parallel-isolation result or hosted acceptance is established.</a:t>
             </a:r>
           </a:p>
           <a:p/>
           <a:p>
             <a:r>
-              <a:t>DEMO — REPO / VS CODE</a:t>
-            </a:r>
-          </a:p>
-          <a:p>
-            <a:r>
-              <a:t>Show separate CLI worktree paths and the current open PR #27. Explain that the canaries prove only local read-only identity binding. Do not run destructive shared-checkout tests. VS Code Local-mode behavior is unverified; any future cloud task must bind its own live contract and approved base.</a:t>
+              <a:t>DEMO - REPO / VS CODE</a:t>
+            </a:r>
+          </a:p>
+          <a:p>
+            <a:r>
+              <a:t>Show separate CLI worktree paths and current open PRs #27 and #28. Explain that the canaries prove only local read-only identity binding. Do not run destructive shared-checkout tests. VS Code Local-mode behavior is unverified; any future cloud task must bind its own live contract and approved base.</a:t>
             </a:r>
           </a:p>
           <a:p/>
@@ -4918,11 +4928,21 @@
           </a:p>
           <a:p>
             <a:r>
+              <a:t>https://github.com/webmaxru/northstar-orders-api-demo/issues/24</a:t>
+            </a:r>
+          </a:p>
+          <a:p>
+            <a:r>
               <a:t>https://github.com/webmaxru/northstar-orders-api-demo/pull/27</a:t>
             </a:r>
           </a:p>
           <a:p>
             <a:r>
+              <a:t>https://github.com/webmaxru/northstar-orders-api-demo/pull/28</a:t>
+            </a:r>
+          </a:p>
+          <a:p>
+            <a:r>
               <a:t>https://github.com/webmaxru/northstar-orders-api-demo/pull/30</a:t>
             </a:r>
           </a:p>
@@ -4954,7 +4974,7 @@
           </a:p>
           <a:p>
             <a:r>
-              <a:t>Synthetic concurrency tests and two local CLI identity canaries are not live cloud acceptance. PR #27 AC9 remains unproven; Cloud run `36869969461` has no inspectable artifact result. PR #29 remains a wrong-base/no-change attempt.</a:t>
+              <a:t>Synthetic concurrency tests and two local CLI identity canaries are not live cloud acceptance. PR #27 AC9 remains unproven; Cloud run `36930550238` has no inspectable result for the predecessor head, and no real run has tested the `f1c40a9` fallback. PR #28 also remains a draft with failed hosted gates. No hosted `ready_for_acceptance` is established.</a:t>
             </a:r>
           </a:p>
         </p:txBody>
@@ -6406,7 +6426,7 @@
           </a:p>
           <a:p>
             <a:r>
-              <a:t>Thank you. The useful takeaway is that agentic development can be made inspectable: name the task, see the boundaries, challenge the plan or code at the right time, and check what the evidence actually proves. The database acceptance results are real; a completed governed-agent delivery is not established.</a:t>
+              <a:t>The engineering-system model makes work inspectable; it does not turn passing tests or a reviewer click into acceptance. Only current task-bound evidence plus the required hosted controls and independent human acceptance can do that.</a:t>
             </a:r>
           </a:p>
           <a:p/>
@@ -6417,93 +6437,87 @@
           </a:p>
           <a:p>
             <a:r>
-              <a:t>Show open issues #4 and #17 and draft PR #19. Maintenance plans #15, #21, #23, #25, and #26 remain open; plans #21 and #23 are stale. PRs #18, #27, and #28 remain open; #27 and #28 are draft/unaccepted. PR #19 at `cf762216` has local PostgreSQL acceptance 12/12 and hosted human-review, but full validation has 86 Zizmor findings, repository-controls fails, and its base is stale.</a:t>
+              <a:t>PR #27 is a draft on base `2ce3cf8` at `f1c40a9` and now has a current-head approval. Hosted run `36984950941` passes human-review, but repository-controls and evidence still fail; the report is `review_required`, `validation-authority` is absent, and AC9 remains unproven. VS Code workspace trust was not granted, and no successful Cloud task-bound run tested this candidate.</a:t>
             </a:r>
           </a:p>
           <a:p/>
           <a:p>
             <a:r>
-              <a:t>PR #27 is now at `f1c40a961451d29fed04ac37ad01eb63ddec076d` on base `2ce3cf8`. Local validation passes 541 unit and 10 PostgreSQL acceptance tests; audit reports zero vulnerabilities. Full `validate:all` reports 83 Zizmor findings. Hosted run `36934750341` passes plan-contract, plan-approval, scope, quality, acceptance, dependency review, CodeQL, secret scan, merge-validation, and governance; repository-controls, human-review, and evidence fail. Existing approvals predate this head, `validation-authority` is absent, and the report is `review_required` with 9/10 criteria proven; AC9 is unproven.</a:t>
+              <a:t>Issue #24 PR #28 is a draft at `cb507e2` on the same parent base. Its current plan PR #25 is approved on the exact plan head. The implementation fixes bootstrap-mode wiring and retrieves omitted run attempts from GitHub for the existing browser-plan-canary maintenance route. Local validation is green through 527 unit tests, 9 PostgreSQL acceptance tests, lint, typecheck, build, 79 governance checks, secret scan, and workflow compilation. Full `validate:all` stops on two high dependency advisories from the old parent base; the task plan prohibits manifest changes. Hosted run `36990391843` passes core code and acceptance checks but fails dependency-review, repository-controls, current-head human-review, and evidence. Zizmor reports 79 findings; no suppressions were added.</a:t>
             </a:r>
           </a:p>
           <a:p/>
           <a:p>
             <a:r>
-              <a:t>The implementation now resolves session IDs consistently across task hooks and CLI entry points. A local Cloud-shaped simulation with a missing event payload ID and a host-environment ID passes SessionStart, PreToolUse, and `plan:gate`; this is not Cloud host evidence. The latest actual Cloud run `36930550238` on predecessor `92a8af6` still returned `success=false` for plan-gate without details or artifacts, before the session-identity fallback was published. No further Cloud retry was made because the failure remains opaque and the bounded retry policy applies.</a:t>
+              <a:t>The repository-controls 403 is caused by the read-only pull-request `github.token` lacking access to ruleset/App/secret metadata; it does not show those settings are disabled. Separate API reads verified active branch rules, no bypass actors, and secret scanning/push protection, but do not make the PR check pass. No GitHub settings or secrets were changed.</a:t>
             </a:r>
           </a:p>
           <a:p/>
           <a:p>
             <a:r>
-              <a:t>PR #28 remains draft at `35ac911`; its current-head review and repository-controls are still outstanding. PR #21 and #23 remain stale plan proposals. No rules, permissions, secrets, or protected environments changed.</a:t>
+              <a:t>NEXT ACTION</a:t>
+            </a:r>
+          </a:p>
+          <a:p>
+            <a:r>
+              <a:t>Keep both PRs draft. PR #28 needs a fresh independent current-head review and an accepted dependency/base sequence; Issue #22/#20 plans must be rebound after the parent advances. Resolve trusted control-plane evidence only through their approved plans and preflight. Do not merge or claim acceptance. WI-1842 and endpoint demos still have no successful hosted plan → act → evaluate sequence.</a:t>
             </a:r>
           </a:p>
           <a:p/>
           <a:p>
             <a:r>
-              <a:t>NEXT ACTION</a:t>
-            </a:r>
-          </a:p>
-          <a:p>
-            <a:r>
-              <a:t>An independent review of exact PR #27 head `f1c40a9` is needed; the reviewer request exists, but visible approvals target older commits. Resolve repository-controls and evidence through the approved Issue #22/#24 sequence; do not change settings outside that plan. Zizmor remediation remains blocked until Issue #20's plan is refreshed on the authorized base and independently approved. No hosted `ready_for_acceptance` or live VS Code execution exists.</a:t>
+              <a:t>DOCUMENTATION LINKS</a:t>
+            </a:r>
+          </a:p>
+          <a:p>
+            <a:r>
+              <a:t>https://github.com/webmaxru/ai-engineering-system/blob/main/docs/GUIDE-CONFORMANCE.md</a:t>
+            </a:r>
+          </a:p>
+          <a:p>
+            <a:r>
+              <a:t>https://github.com/webmaxru/northstar-orders-api-demo/pull/18</a:t>
+            </a:r>
+          </a:p>
+          <a:p>
+            <a:r>
+              <a:t>https://github.com/webmaxru/northstar-orders-api-demo/pull/27</a:t>
+            </a:r>
+          </a:p>
+          <a:p>
+            <a:r>
+              <a:t>https://github.com/webmaxru/northstar-orders-api-demo/pull/28</a:t>
+            </a:r>
+          </a:p>
+          <a:p>
+            <a:r>
+              <a:t>https://github.com/webmaxru/northstar-orders-api-demo/pull/25</a:t>
+            </a:r>
+          </a:p>
+          <a:p>
+            <a:r>
+              <a:t>https://github.com/webmaxru/northstar-orders-api-demo/issues/20</a:t>
+            </a:r>
+          </a:p>
+          <a:p>
+            <a:r>
+              <a:t>https://github.com/webmaxru/northstar-orders-api-demo/issues/22</a:t>
+            </a:r>
+          </a:p>
+          <a:p>
+            <a:r>
+              <a:t>https://github.com/webmaxru/northstar-orders-api-demo/issues/24</a:t>
             </a:r>
           </a:p>
           <a:p/>
           <a:p>
             <a:r>
-              <a:t>DOCUMENTATION LINKS</a:t>
-            </a:r>
-          </a:p>
-          <a:p>
-            <a:r>
-              <a:t>https://github.com/webmaxru/ai-engineering-system</a:t>
-            </a:r>
-          </a:p>
-          <a:p>
-            <a:r>
-              <a:t>https://github.com/webmaxru/northstar-orders-api-demo/pull/18</a:t>
-            </a:r>
-          </a:p>
-          <a:p>
-            <a:r>
-              <a:t>https://github.com/webmaxru/northstar-orders-api-demo/pull/19</a:t>
-            </a:r>
-          </a:p>
-          <a:p>
-            <a:r>
-              <a:t>https://github.com/webmaxru/northstar-orders-api-demo/pull/27</a:t>
-            </a:r>
-          </a:p>
-          <a:p>
-            <a:r>
-              <a:t>https://github.com/webmaxru/northstar-orders-api-demo/pull/28</a:t>
-            </a:r>
-          </a:p>
-          <a:p>
-            <a:r>
-              <a:t>https://github.com/webmaxru/northstar-orders-api-demo/issues/16</a:t>
-            </a:r>
-          </a:p>
-          <a:p>
-            <a:r>
-              <a:t>https://github.com/webmaxru/ai-engineering-system/blob/main/docs/GUIDE-CONFORMANCE.md</a:t>
-            </a:r>
-          </a:p>
-          <a:p>
-            <a:r>
-              <a:t>https://learn.microsoft.com/en-us/training/modules/design-agent-architecture-integration/4-plan-reason-execution</a:t>
-            </a:r>
-          </a:p>
-          <a:p/>
-          <a:p>
-            <a:r>
               <a:t>EVIDENCE BOUNDARY</a:t>
             </a:r>
           </a:p>
           <a:p>
             <a:r>
-              <a:t>PR #18 remains open and unaccepted. PR #19, #27, and #28 are open drafts. PR #15/#21/#23/#25/#26 are open plan PRs; #21 and #23 are stale. PR #27 has local unit/acceptance evidence, but hosted controls/review/evidence still block acceptance. PR #13 and #29 are closed historical attempts. No hosted `ready_for_acceptance`, live VS Code execution, or successful task-bound Cloud-agent delivery is recorded.</a:t>
+              <a:t>Neither implementation PR is accepted. No hosted `ready_for_acceptance`, successful task-bound Cloud session, or VS Code runtime evidence exists. The architecture lock remains blocked; no integration, settings mutation, secret change, or merge is claimed.</a:t>
             </a:r>
           </a:p>
         </p:txBody>
@@ -6945,29 +6959,47 @@
           </a:p>
           <a:p>
             <a:r>
-              <a:t>A repair candidate can pass application tests without becoming an accepted release. PR #18 remains open at `2ce3cf8`, unmerged and unaccepted; its PostgreSQL acceptance passed, but human-review, repository-controls, and trusted acceptance remain blocked, and AC15 is unverified. PR #27 is now open/draft at `f1c40a9` on base `2ce3cf8`. Local validation passes 541 unit tests, 10 PostgreSQL acceptance tests, and 79 governance checks; npm audit reports zero vulnerabilities. Full `npm run validate:all` still fails on 83 Zizmor findings.</a:t>
+              <a:t>A passing local suite is necessary, not acceptance. Keep the plan → act → evaluate evidence bound to the exact task, plan, source head, checks, and human decision.</a:t>
             </a:r>
           </a:p>
           <a:p/>
           <a:p>
             <a:r>
-              <a:t>The Cloud resolver no longer requires a Bot author or a `copilot/` branch prefix. SessionStart, UserPromptSubmit, PreToolUse, audit/Stop hooks, and CLI entry points now resolve session identity consistently from the event payload, Copilot host environment, or a GitHub Actions repository/run/attempt identity. A local Cloud-shaped simulation with no session ID in the event payload resolved the task, plan, PR, base/head, and owner; PreToolUse allowed the approved plan gate. This is local hook-path evidence, not a successful Cloud session.</a:t>
+              <a:t>DEMO - REPO / VS CODE</a:t>
+            </a:r>
+          </a:p>
+          <a:p>
+            <a:r>
+              <a:t>Show PR #18, draft PR #27, and draft PR #28 as candidates, not accepted releases. PR #18 remains open and unaccepted; its hosted acceptance and trusted status remain blocked.</a:t>
             </a:r>
           </a:p>
           <a:p/>
           <a:p>
             <a:r>
-              <a:t>DEMO - REPO / VS CODE</a:t>
-            </a:r>
-          </a:p>
-          <a:p>
-            <a:r>
-              <a:t>Show PR #18 and draft PR #27 as candidates, not accepted releases. Hosted run `36934750341` on `f1c40a9` passes plan-contract, plan-approval, scope, quality, acceptance, dependency review, CodeQL, secret scan, merge-validation, and governance. It fails repository-controls, human-review, and evidence; visible approvals target older commits, `validation-authority` is absent, and the report is `review_required` with 9/10 criteria proven. AC9 remains unproven. Cloud run `36930550238` on predecessor `92a8af6` attempted the plan gate but its bash tool returned `success=false` without command output or artifacts. No Cloud session has tested the session-identity fallback. The code shown is the historical missing-artifact check from baseline `b65c2de`, not current implementation code.</a:t>
+              <a:t>PR #27 is at `f1c40a961451d29fed04ac37ad01eb63ddec076d` on base `2ce3cf8`. `vibeprogrammer` approved this exact head on 2026-10-02. Local validation passes 541 unit tests, 10 PostgreSQL acceptance tests, 79 governance checks, scope, lint, typecheck, build, audit, and secret scan; full `validate:all` fails on 83 Zizmor findings. Hosted run `36984950941` passes current-head human-review and core checks, but repository-controls and evidence fail. The report remains `review_required` with 9/10 criteria proven: `validation-authority` is missing and AC9 is unproven. No actual Cloud run tested the session-identity fallback.</a:t>
             </a:r>
           </a:p>
           <a:p/>
           <a:p>
             <a:r>
+              <a:t>PR #28 is at `cb507e20cd0cb8fdeabfedaece67510a651757b0` on the same parent base. Its approved Issue #24 plan is PR #25 at `7d0a78d8…`. The new code binds the protected bootstrap dispatch mode and resolves omitted System Maintenance run attempts from GitHub while rejecting stale supplied attempts. Local focused tests pass 62/62; full local `validate` passes 527 unit tests and 79 governance checks, PostgreSQL acceptance passes 9/9, secret scan and workflow compilation pass. `validate:all` stops at two high dependency advisories inherited from the base; Issue #24 forbids manifest edits. Hosted run `36990391843` also fails repository-controls, current-head review, and evidence; PR #28 remains draft.</a:t>
+            </a:r>
+          </a:p>
+          <a:p/>
+          <a:p>
+            <a:r>
+              <a:t>The repository-controls failure is not proof the rules are disabled. The pull-request workflow's `github.token` has only `contents: read` and receives HTTP 403 for admin/App/secret metadata. Separate read-only API checks verified an active strict main ruleset with no bypass actors, required PR/CODEOWNERS review, the configured status identities, and enabled secret scanning/push protection. No settings or permissions changed.</a:t>
+            </a:r>
+          </a:p>
+          <a:p/>
+          <a:p>
+            <a:r>
+              <a:t>VS Code remains unverified because workspace trust was not granted. Cloud run `36930550238` was on predecessor `92a8af6`, returned `success=false` without output or artifacts, and did not test the later identity fallback. There is no accepted Cloud plan → act → evaluate run.</a:t>
+            </a:r>
+          </a:p>
+          <a:p/>
+          <a:p>
+            <a:r>
               <a:t>DOCUMENTATION LINKS</a:t>
             </a:r>
           </a:p>
@@ -6983,7 +7015,17 @@
           </a:p>
           <a:p>
             <a:r>
-              <a:t>https://github.com/webmaxru/northstar-orders-api-demo/issues/14</a:t>
+              <a:t>https://github.com/webmaxru/northstar-orders-api-demo/pull/28</a:t>
+            </a:r>
+          </a:p>
+          <a:p>
+            <a:r>
+              <a:t>https://github.com/webmaxru/northstar-orders-api-demo/issues/16</a:t>
+            </a:r>
+          </a:p>
+          <a:p>
+            <a:r>
+              <a:t>https://github.com/webmaxru/northstar-orders-api-demo/issues/24</a:t>
             </a:r>
           </a:p>
           <a:p>
@@ -6991,11 +7033,6 @@
               <a:t>https://github.com/webmaxru/ai-engineering-system/blob/main/docs/GUIDE-CONFORMANCE.md</a:t>
             </a:r>
           </a:p>
-          <a:p>
-            <a:r>
-              <a:t>https://github.com/webmaxru/northstar-orders-api-demo/blob/b65c2de5c8224342c72c37eeed7ef9f965ad8a2c/scripts/build-execution-report.mjs</a:t>
-            </a:r>
-          </a:p>
           <a:p/>
           <a:p>
             <a:r>
@@ -7004,7 +7041,7 @@
           </a:p>
           <a:p>
             <a:r>
-              <a:t>PR #18 remains open and unaccepted. PR #27 is published at `f1c40a9`, but remains draft and unaccepted. Hosted run `36934750341` is `review_required` with 9/10 criteria proven; repository-controls, human-review, and evidence fail; AC9 remains unproven. No hosted `ready_for_acceptance`, live VS Code run, or successful task-bound Cloud-agent delivery is recorded.</a:t>
+              <a:t>Neither implementation PR is accepted. No hosted `ready_for_acceptance`, successful Cloud host canary, or VS Code runtime proof exists. `architecture-lock.json` remains blocked; no ruleset, secret, permission, or protected-environment changes were made.</a:t>
             </a:r>
           </a:p>
         </p:txBody>
@@ -48166,7 +48203,7 @@
                 <a:ea typeface="Cascadia Mono" pitchFamily="34" charset="-122"/>
                 <a:cs typeface="Cascadia Mono" pitchFamily="34" charset="-120"/>
               </a:rPr>
-              <a:t>PR 27: 535 unit / 10 PostgreSQL PASS</a:t>
+              <a:t>PR 27: 541 unit / 10 PostgreSQL PASS</a:t>
             </a:r>
           </a:p>
           <a:p>

</xml_diff>

<commit_message>
docs: record trusted publisher stacked-base blocker
Co-authored-by: Copilot App <223556219+Copilot@users.noreply.github.com>
</commit_message>
<xml_diff>
--- a/From-agents-to-engineering-systems.pptx
+++ b/From-agents-to-engineering-systems.pptx
@@ -2680,7 +2680,7 @@
           </a:p>
           <a:p>
             <a:r>
-              <a:t>Open the WI-1843 task worktree at PR #19 head `cf762216` and verify `docs/demos/README.md` there. Show the WI-1842 and WI-1843 runbooks and open issues #4 and #17. PR #13 and PR #29 are closed historical attempts; PRs #15, #18, #21, #23, #25, #26, #27, and #28 are open maintenance items. PR #27 and #28 are draft implementations; neither is accepted. PR #27 is at `f1c40a9` and has current-head approval. PR #28 is at `cb507e2` and needs a fresh current-head review. Do not present an open PR or approved plan as implementation acceptance.</a:t>
+              <a:t>Show issues #4 and #17, PR #18, and drafts #19, #27, and #28. PR #27 is at `f1c40a9` and has exact-head approval. PR #28 is at `cb507e2`, was approved on that exact head by `vibeprogrammer` (review `5391273930`), and remains draft because hosted dependency-review, repository-controls, and evidence still fail. Do not present review approval as acceptance.</a:t>
             </a:r>
           </a:p>
           <a:p/>
@@ -2696,11 +2696,6 @@
           </a:p>
           <a:p>
             <a:r>
-              <a:t>https://github.com/webmaxru/northstar-orders-api-demo</a:t>
-            </a:r>
-          </a:p>
-          <a:p>
-            <a:r>
               <a:t>https://github.com/webmaxru/northstar-orders-api-demo/pull/18</a:t>
             </a:r>
           </a:p>
@@ -2721,7 +2716,7 @@
           </a:p>
           <a:p>
             <a:r>
-              <a:t>https://learn.microsoft.com/en-us/training/modules/design-agent-architecture-integration/4-plan-reason-execution</a:t>
+              <a:t>https://github.com/webmaxru/northstar-orders-api-demo/issues/24</a:t>
             </a:r>
           </a:p>
           <a:p/>
@@ -2732,7 +2727,7 @@
           </a:p>
           <a:p>
             <a:r>
-              <a:t>Northstar main remains the known-defective baseline `b65c2de5c8224342c72c37eeed7ef9f965ad8a2c`; the inert framework snapshot tracks candidate `bfb2cbf1d0f488ced1595f100c14ed8e312bb1f7` but remains `known-defective`, and conformance remains blocked. PR #18 is open at `2ce3cf8`, unmerged and unaccepted; its local validation passed 489 unit/9 PostgreSQL tests, but hosted human-review, controls, and trusted acceptance remain unresolved and AC15 is unverified. PR #19 is open/draft at `cf762216`, based on older `17e7a5c`; its local 470 unit/12 PostgreSQL tests pass, but repository-controls fails and no hosted delivery is accepted. PR #27 is open/draft at `f1c40a9`, based on `2ce3cf8`; local validation passes 541 unit and 10 PostgreSQL acceptance tests, and npm audit reports zero vulnerabilities. Full `validate:all` still fails with 83 Zizmor findings. Hosted run `36984950941` passes current-head human-review and core checks but fails repository-controls/evidence; `validation-authority` is missing, AC9 is unproven, and the report is `review_required` with 9/10 criteria proven. PR #28 is open/draft at `cb507e2`; local `validate` passes 527 unit and 9 PostgreSQL acceptance tests, but full `validate:all` stops on two high dependency advisories inherited from its base. Hosted run `36990391843` fails dependency-review, repository-controls, current-head human-review, and evidence. No accepted Cloud or VS Code delivery is established. PR #13 and #29 are closed; #29 used `main` and made no source changes. No rules, permissions, secrets, or protected environments changed.</a:t>
+              <a:t>Northstar main remains the known-defective baseline `b65c2de`; the framework snapshot remains `known-defective` and conformance is blocked. PR #27 run `36984950941` passes current-head human-review but fails repository-controls/evidence; AC9 is unproven. PR #28 run `37001565136` passes current-head human-review but fails dependency-review, repository-controls, and evidence. Trusted Publish Evidence run `37001721147` executed protected main at `b65c2de` and failed because the deployed resolver only recognizes PRs targeting `main`; PR #28 is stacked on the parent branch. The candidate's resolver fix is not yet active on protected main. No accepted Cloud or VS Code delivery exists; no settings, permissions, or secrets changed.</a:t>
             </a:r>
           </a:p>
         </p:txBody>
@@ -4896,12 +4891,12 @@
           </a:p>
           <a:p>
             <a:r>
-              <a:t>Issue #16 is open; approved plan PR #26 is open, and implementation PR #27 is open/draft at `f1c40a9` on base `2ce3cf8`. Its local validation passes 541 unit/10 PostgreSQL tests; Fastify 5.12.5 has zero npm audit vulnerabilities, but full `validate:all` still reports 83 Zizmor findings. `vibeprogrammer` approved this exact head. Hosted run `36984950941` passes current-head human-review and core checks but fails repository-controls/evidence; `validation-authority` is missing, the report is `review_required`, and AC9 remains unproven. Earlier Cloud canary PR #30 used predecessor base `bb767fc` but stopped because `artifacts/task-contract.json` was absent. Cloud run `36930550238` on predecessor `92a8af6` returned `success=false` without an inspectable result; no bound Cloud result is established for `f1c40a9`.</a:t>
-            </a:r>
-          </a:p>
-          <a:p>
-            <a:r>
-              <a:t>Issue #24 PR #28 is at `cb507e2` on base `2ce3cf8`; its refreshed plan PR #25 is approved. Local validation passes 527 unit/9 PostgreSQL tests, but the hosted run `36990391843` fails dependency-review, repository-controls, current-head human-review, and evidence. The inherited dependencies cannot be changed under the approved Issue #24 scope. PR #32 attempted Issue #24 on an older Issue #16 base and is not valid Issue #24 evidence. No cloud parallel-isolation result or hosted acceptance is established.</a:t>
+              <a:t>Issue #16 PR #27 is open/draft at `f1c40a9` on base `2ce3cf8`; it has exact-head approval and local validation (541 unit/10 PostgreSQL tests), but hosted run `36984950941` still fails repository-controls/evidence and AC9 is unproven. Cloud run `36930550238` on predecessor `92a8af6` returned `success=false` without an inspectable result; no actual Cloud run tested the identity fallback.</a:t>
+            </a:r>
+          </a:p>
+          <a:p>
+            <a:r>
+              <a:t>Issue #24 PR #28 is open/draft at `cb507e2` on base `2ce3cf8` and exact-head approved (review `5391273930`). Local validation passes 527 unit/9 PostgreSQL tests and the 62 focused resolver tests. Hosted run `37001565136` passes current-head human-review but fails dependency-review, repository-controls, and evidence. Trusted Publish Evidence run `37001721147` uses old protected-main code at `b65c2de` and cannot resolve the stacked PR because it targets the parent branch; the approved candidate resolver fix is not yet integrated on main.</a:t>
             </a:r>
           </a:p>
           <a:p/>
@@ -4912,7 +4907,7 @@
           </a:p>
           <a:p>
             <a:r>
-              <a:t>Show separate CLI worktree paths and current open PRs #27 and #28. Explain that the canaries prove only local read-only identity binding. Do not run destructive shared-checkout tests. VS Code Local-mode behavior is unverified; any future cloud task must bind its own live contract and approved base.</a:t>
+              <a:t>Show separate CLI worktree paths and current open PRs #27/#28. Explain that local canaries prove only read-only identity binding. Issue #22 and #20 plan work remains behind Issue #24 acceptance; after integration, refresh those plans against the exact resulting parent. VS Code Local-mode behavior remains unverified.</a:t>
             </a:r>
           </a:p>
           <a:p/>
@@ -4953,11 +4948,6 @@
           </a:p>
           <a:p>
             <a:r>
-              <a:t>https://github.com/webmaxru/northstar-orders-api-demo/pull/29</a:t>
-            </a:r>
-          </a:p>
-          <a:p>
-            <a:r>
               <a:t>https://learn.microsoft.com/en-us/training/modules/multi-agent-systems-orchestration/4-execution-isolation-permissions-concurrency</a:t>
             </a:r>
           </a:p>
@@ -4974,7 +4964,7 @@
           </a:p>
           <a:p>
             <a:r>
-              <a:t>Synthetic concurrency tests and two local CLI identity canaries are not live cloud acceptance. PR #27 AC9 remains unproven; Cloud run `36930550238` has no inspectable result for the predecessor head, and no real run has tested the `f1c40a9` fallback. PR #28 also remains a draft with failed hosted gates. No hosted `ready_for_acceptance` is established.</a:t>
+              <a:t>Synthetic tests and read-only local CLI canaries are not live cloud acceptance. PR #27 AC9 remains unproven; PR #28 has an exact-head review but required hosted gates fail. No hosted `ready_for_acceptance` or settings mutation is established.</a:t>
             </a:r>
           </a:p>
         </p:txBody>
@@ -6426,7 +6416,7 @@
           </a:p>
           <a:p>
             <a:r>
-              <a:t>The engineering-system model makes work inspectable; it does not turn passing tests or a reviewer click into acceptance. Only current task-bound evidence plus the required hosted controls and independent human acceptance can do that.</a:t>
+              <a:t>The engineering-system model makes work inspectable; it does not turn passing tests or a reviewer click into acceptance. Only current task-bound evidence plus required hosted controls and independent human acceptance can do that.</a:t>
             </a:r>
           </a:p>
           <a:p/>
@@ -6437,19 +6427,19 @@
           </a:p>
           <a:p>
             <a:r>
-              <a:t>PR #27 is a draft on base `2ce3cf8` at `f1c40a9` and now has a current-head approval. Hosted run `36984950941` passes human-review, but repository-controls and evidence still fail; the report is `review_required`, `validation-authority` is absent, and AC9 remains unproven. VS Code workspace trust was not granted, and no successful Cloud task-bound run tested this candidate.</a:t>
+              <a:t>PR #27 is a draft on base `2ce3cf8` at `f1c40a9` and has exact-head approval. Hosted run `36984950941` passes human-review, but repository-controls and evidence fail; validation-authority is absent, AC9 is unproven, and the report is `review_required`. VS Code workspace trust was not granted, and no successful Cloud task-bound run tested this candidate.</a:t>
             </a:r>
           </a:p>
           <a:p/>
           <a:p>
             <a:r>
-              <a:t>Issue #24 PR #28 is a draft at `cb507e2` on the same parent base. Its current plan PR #25 is approved on the exact plan head. The implementation fixes bootstrap-mode wiring and retrieves omitted run attempts from GitHub for the existing browser-plan-canary maintenance route. Local validation is green through 527 unit tests, 9 PostgreSQL acceptance tests, lint, typecheck, build, 79 governance checks, secret scan, and workflow compilation. Full `validate:all` stops on two high dependency advisories from the old parent base; the task plan prohibits manifest changes. Hosted run `36990391843` passes core code and acceptance checks but fails dependency-review, repository-controls, current-head human-review, and evidence. Zizmor reports 79 findings; no suppressions were added.</a:t>
+              <a:t>Issue #24 PR #28 is a draft at `cb507e2` on the same parent base and was approved at the exact head (review `5391273930`). The implementation fixes bootstrap-mode wiring, derives omitted maintenance run attempts from GitHub, and adds exact stacked-base PR resolution. Local validation passes 527 unit/9 PostgreSQL tests, the 62 focused resolver tests, 79 governance checks, secret scan and workflow compilation. Hosted run `37001565136` passes current-head human-review but fails dependency-review, repository-controls, and evidence. The trusted Publish Evidence follow-up `37001721147` runs protected main at `b65c2de` and fails to resolve the stacked PR because that deployed resolver still requires a main base. The candidate fix is not active on protected main yet. Zizmor reports 79 findings; no suppressions were added.</a:t>
             </a:r>
           </a:p>
           <a:p/>
           <a:p>
             <a:r>
-              <a:t>The repository-controls 403 is caused by the read-only pull-request `github.token` lacking access to ruleset/App/secret metadata; it does not show those settings are disabled. Separate API reads verified active branch rules, no bypass actors, and secret scanning/push protection, but do not make the PR check pass. No GitHub settings or secrets were changed.</a:t>
+              <a:t>The repository-controls 403 is caused by the read-only pull-request token lacking access to administrator/App/secret metadata; separate API reads verified the active ruleset and enabled scanning, but do not make the hosted check pass. No GitHub settings or secrets changed.</a:t>
             </a:r>
           </a:p>
           <a:p/>
@@ -6460,7 +6450,7 @@
           </a:p>
           <a:p>
             <a:r>
-              <a:t>Keep both PRs draft. PR #28 needs a fresh independent current-head review and an accepted dependency/base sequence; Issue #22/#20 plans must be rebound after the parent advances. Resolve trusted control-plane evidence only through their approved plans and preflight. Do not merge or claim acceptance. WI-1842 and endpoint demos still have no successful hosted plan → act → evaluate sequence.</a:t>
+              <a:t>Keep PR #28 draft while the required dependency, trusted-control and evidence gates remain unresolved. Do not start the Issue #22 settings migration: its own contract requires accepted Issue #24 and fresh trusted-acceptance on the exact parent. After #24 is integrated by a human and the parent advances, refresh the #22/#20 plans on the exact new base. Do not merge or claim acceptance. WI-1842 and endpoint demos still lack successful hosted plan → act → evaluate flows.</a:t>
             </a:r>
           </a:p>
           <a:p/>
@@ -6959,7 +6949,7 @@
           </a:p>
           <a:p>
             <a:r>
-              <a:t>A passing local suite is necessary, not acceptance. Keep the plan → act → evaluate evidence bound to the exact task, plan, source head, checks, and human decision.</a:t>
+              <a:t>A passing local suite is necessary, not acceptance. Keep plan → act → evaluate evidence bound to the exact task, plan, source head, checks, and human decision.</a:t>
             </a:r>
           </a:p>
           <a:p/>
@@ -6970,42 +6960,37 @@
           </a:p>
           <a:p>
             <a:r>
-              <a:t>Show PR #18, draft PR #27, and draft PR #28 as candidates, not accepted releases. PR #18 remains open and unaccepted; its hosted acceptance and trusted status remain blocked.</a:t>
+              <a:t>Show PR #18 and drafts #27/#28 as candidates, not accepted releases. PR #18 remains unaccepted; its hosted trusted acceptance is blocked.</a:t>
             </a:r>
           </a:p>
           <a:p/>
           <a:p>
             <a:r>
-              <a:t>PR #27 is at `f1c40a961451d29fed04ac37ad01eb63ddec076d` on base `2ce3cf8`. `vibeprogrammer` approved this exact head on 2026-10-02. Local validation passes 541 unit tests, 10 PostgreSQL acceptance tests, 79 governance checks, scope, lint, typecheck, build, audit, and secret scan; full `validate:all` fails on 83 Zizmor findings. Hosted run `36984950941` passes current-head human-review and core checks, but repository-controls and evidence fail. The report remains `review_required` with 9/10 criteria proven: `validation-authority` is missing and AC9 is unproven. No actual Cloud run tested the session-identity fallback.</a:t>
+              <a:t>PR #27 is at `f1c40a961451d29fed04ac37ad01eb63ddec076d` on base `2ce3cf8`. `vibeprogrammer` approved this exact head. Local validation passes 541 unit tests, 10 PostgreSQL acceptance tests, 79 governance checks, scope, lint, typecheck, build, audit, and secret scan; `validate:all` fails on 83 Zizmor findings. Hosted run `36984950941` passes current-head human-review and core checks, but repository-controls/evidence fail. The report is `review_required`; validation-authority is missing and AC9 is unproven.</a:t>
             </a:r>
           </a:p>
           <a:p/>
           <a:p>
             <a:r>
-              <a:t>PR #28 is at `cb507e20cd0cb8fdeabfedaece67510a651757b0` on the same parent base. Its approved Issue #24 plan is PR #25 at `7d0a78d8…`. The new code binds the protected bootstrap dispatch mode and resolves omitted System Maintenance run attempts from GitHub while rejecting stale supplied attempts. Local focused tests pass 62/62; full local `validate` passes 527 unit tests and 79 governance checks, PostgreSQL acceptance passes 9/9, secret scan and workflow compilation pass. `validate:all` stops at two high dependency advisories inherited from the base; Issue #24 forbids manifest edits. Hosted run `36990391843` also fails repository-controls, current-head review, and evidence; PR #28 remains draft.</a:t>
+              <a:t>PR #28 is at `cb507e20cd0cb8fdeabfedaece67510a651757b0` on the same parent base and has exact-head review approval `5391273930`. Its local focused tests pass 62/62; full `validate` passes 527 unit tests and 79 governance checks, PostgreSQL acceptance passes 9/9, and secret scan/workflow compile pass. Hosted run `37001565136` passes current-head review but fails dependency-review, repository-controls, and evidence. `npm audit` reports two high advisories inherited from the base; Issue #24 prohibits manifest edits. Trusted Publish Evidence run `37001721147` ran old default-branch code at `b65c2de` and failed to resolve the stacked PR. The resolver fix is in PR #28, not yet integrated into trusted main.</a:t>
             </a:r>
           </a:p>
           <a:p/>
           <a:p>
             <a:r>
-              <a:t>The repository-controls failure is not proof the rules are disabled. The pull-request workflow's `github.token` has only `contents: read` and receives HTTP 403 for admin/App/secret metadata. Separate read-only API checks verified an active strict main ruleset with no bypass actors, required PR/CODEOWNERS review, the configured status identities, and enabled secret scanning/push protection. No settings or permissions changed.</a:t>
+              <a:t>The repository-controls 403 is not proof controls are disabled. The PR workflow token is read-only and cannot inspect administrator/App/secret metadata. Separate API checks verified the active ruleset/status identities and enabled secret scanning/push protection. No settings or permissions changed.</a:t>
             </a:r>
           </a:p>
           <a:p/>
           <a:p>
             <a:r>
-              <a:t>VS Code remains unverified because workspace trust was not granted. Cloud run `36930550238` was on predecessor `92a8af6`, returned `success=false` without output or artifacts, and did not test the later identity fallback. There is no accepted Cloud plan → act → evaluate run.</a:t>
+              <a:t>VS Code remains unverified; no successful task-bound Cloud delivery exists. Issue #22/#20 work must wait for Issue #24 acceptance and the resulting exact parent base.</a:t>
             </a:r>
           </a:p>
           <a:p/>
           <a:p>
             <a:r>
               <a:t>DOCUMENTATION LINKS</a:t>
-            </a:r>
-          </a:p>
-          <a:p>
-            <a:r>
-              <a:t>https://github.com/webmaxru/northstar-orders-api-demo/pull/18</a:t>
             </a:r>
           </a:p>
           <a:p>

</xml_diff>